<commit_message>
Separate data entry from accuracy accountability; add source-to-sink trace
Each stage now names who creates or enters the data and who is accountable
for its accuracy, with roles awaiting client confirmation left Open. Adds a
hop-by-hop trace of request details and of a coordinator update through to
the product, measurement and business sinks, plus element-level lineage.
Deck slide 6 becomes the trace; the pipeline image shows the split owners.

Co-Authored-By: Claude Opus 5.5 <noreply@anthropic.com>
Claude-Session: https://claude.ai/code/session_01XD5hCTym2561nrmEJXnbUU
</commit_message>
<xml_diff>
--- a/MDPM 830/Data Pipeline/TeamDART_MDPM830_Data_Pipeline.pptx
+++ b/MDPM 830/Data Pipeline/TeamDART_MDPM830_Data_Pipeline.pptx
@@ -116,44 +116,44 @@
   <p:extLst>
     <p:ext uri="{521415D9-36F7-43E2-AB2F-B90AF26B5E84}">
       <p14:sectionLst xmlns:p14="http://schemas.microsoft.com/office/powerpoint/2010/main">
-        <p14:section name="Opening" id="{86e9cc30-03f2-1040-686c-cac80c94e8aa}">
+        <p14:section name="Opening" id="{700e8be8-ed57-f627-ce3d-cfd5da568e43}">
           <p14:sldIdLst>
             <p14:sldId id="256"/>
           </p14:sldIdLst>
         </p14:section>
-        <p14:section name="Product and data" id="{cd8d91f9-e8e4-304c-235c-7071a0da1f4a}">
+        <p14:section name="Product and data" id="{639d0519-cc3d-7020-390c-dde37f96f640}">
           <p14:sldIdLst>
             <p14:sldId id="257"/>
           </p14:sldIdLst>
         </p14:section>
-        <p14:section name="Step One: Sources and scope" id="{33587874-298e-f819-e435-0f15315525ef}">
+        <p14:section name="Step One: Sources and scope" id="{0be59457-288e-c96a-dbc2-46dad222a9c0}">
           <p14:sldIdLst>
             <p14:sldId id="258"/>
             <p14:sldId id="259"/>
           </p14:sldIdLst>
         </p14:section>
-        <p14:section name="Step Two: The pipeline" id="{16be08b2-e190-5d28-2492-a907a6649447}">
+        <p14:section name="Step Two: The pipeline" id="{05c87d1b-200b-abf2-eb98-b4d050be2115}">
           <p14:sldIdLst>
             <p14:sldId id="260"/>
             <p14:sldId id="261"/>
           </p14:sldIdLst>
         </p14:section>
-        <p14:section name="Step Three: Sinks" id="{8e4d0003-8416-e909-30e7-356f9ad987d9}">
+        <p14:section name="Step Three: Sinks" id="{7670ffbb-0ab0-cc51-4fe4-9b2e62a73825}">
           <p14:sldIdLst>
             <p14:sldId id="262"/>
           </p14:sldIdLst>
         </p14:section>
-        <p14:section name="Step Four: Generated data" id="{702887bb-b94b-7c10-1181-be7ce9e3638b}">
+        <p14:section name="Step Four: Generated data" id="{ed42749f-572c-162a-9330-427fc2183ca6}">
           <p14:sldIdLst>
             <p14:sldId id="263"/>
           </p14:sldIdLst>
         </p14:section>
-        <p14:section name="Step Five: Gaps and leaks" id="{8dc7f738-11ac-b4da-8fce-30b0b78ed7c5}">
+        <p14:section name="Step Five: Gaps and leaks" id="{57e5dbb2-2855-a36d-2a0c-fa4c125c1b57}">
           <p14:sldIdLst>
             <p14:sldId id="264"/>
           </p14:sldIdLst>
         </p14:section>
-        <p14:section name="Implications" id="{c4b413a4-bb13-eef2-0ac0-16c4b48c8b12}">
+        <p14:section name="Implications" id="{ea75c458-93f8-8852-5d29-e5908c9e0cb1}">
           <p14:sldIdLst>
             <p14:sldId id="265"/>
           </p14:sldIdLst>
@@ -1028,7 +1028,7 @@
           <a:p>
             <a:r>
               <a:rPr lang="en-US" dirty="0"/>
-              <a:t>This image is the pipeline model built in Miro with the Session Four conceptual template: the scope boundary on top, the five stages (Generate, Collect, Keep and Shape, Store, Use) each with an owner, three kinds of sink on the right, and the loop underneath. The board link is on this slide and opens with view access.
+              <a:t>This image is the pipeline model built in Miro with the Session Four conceptual template: the scope boundary on top, the five stages (Generate, Collect, Keep and Shape, Store, Use), each showing who enters the data and who is accountable for its accuracy, three kinds of sink on the right, and the loop underneath. The board link is on this slide and opens with view access.
 On the board, read these frames together: "Working 2: Pipeline Stages and Data Ownership" (this picture plus the full stage table), "Data Pipeline: Sinks, Generated Data, Gaps and Leaks" (Steps Three to Five), and "Scope, Data Sources and Origin" (Step One).
 Nodes do the work and connectors carry the controls (Session Four, adapted from Raj et al. 2020, Fig. 6):
 A Authenticate, into Collect: only an authorized requester may submit for their ministry (FR-25, Roles and Authorization Rules).
@@ -1125,17 +1125,20 @@
           <a:p>
             <a:r>
               <a:rPr lang="en-US" dirty="0"/>
-              <a:t>Step Two asks who or what is responsible at each stage, what the preparation step must achieve, and the constraints: quality, frequency, format, ownership and access.
-Owners:
-Generate: each creator owns what they enter: the original requester (need), the CMAC (request), the Furniture Request Coordinator (review), the Furniture Coordinator (assignment and proposal), the vendor or mover (delivery), and the client (decision).
-Collect: the CMAC at submission; coordinators for updates.
-Keep and Shape: OPEN. Our proposal is the Furniture Request Coordinator, because they decide whether a request is complete enough to act on (task model 4.3). To confirm.
-Store: OPEN. The data owner for the request record is to be confirmed with the client.
-Use: CMACs, Furniture Coordinators and Infrastructure management are the consumers; the owner of the reports is to be confirmed.
-Frequency and format: human-generated and intermittent, one request at a time, event-driven on each submission or update. Prototype file limits are 10MB for attachments and 5MB for message replies.
-Quality evidence for the cleaning rules: the prototype shows one request labelled both Awaiting initial review and Reviewing, and activity events dated before submission. These are exactly the problems the six rules prevent.
-Keep the original (Raj et al., Session Three principle one): the request as submitted is kept as bronze, so a later question can go back to it. FR-22 also requires the history of a merged duplicate to be preserved.
-Access: role-based on every view (FR-25, NFR-14 to NFR-16). A CMAC sees only their own requests. No historical migration; no direct SnapTracker or OneGX/SAP link assumed.</a:t>
+              <a:t>This slide traces the data itself, not just the stages. It follows one request's details from the person who needs the furniture to the three kinds of sink, and names two different roles at every hop: who enters the data, and who is accountable for its accuracy. Creating or entering data is not the same as being accountable for it. Creators answer for what they state, the stage owner answers for the rules that make the data trustworthy, and the data owner answers for the record end to end. Roles marked Open need the client's confirmation.
+Trace 1, request details:
+1. The need is born with the original requester: item, quantity, location, reason. It reaches the CMAC by email, Teams or phone. The requester answers for what they state.
+Control A, authenticate: only an authorized requester may submit for their ministry (FR-25).
+2. The CMAC enters it in the guided form, adds type, required date and attachments, and PRISM Core pre-fills requester and building data (NFR-09). We propose the CMAC is accountable for the details they submit. The owner of PRISM Core reference data is Open.
+Control V, validate: required fields and the attachments the request type needs are checked (FR-03, FR-07). If they fail, the request goes back to the CMAC in the request thread and is checked again (Scenario 7).
+3. The coordinator reviews it. The request as submitted is kept (bronze). One consistent version is built (silver) using six rules: one Work Order ID with every update linked; one status from a standard list; a named, valid owner at every stage; required fields complete before review; dates in one format and true order; duplicates checked on an agreed match key. Who owns these rules is Open; we propose the Furniture Request Coordinator.
+Control F, monitor: every stage change carries a time.
+4. The record is stored once and read by everyone. Its data owner is Open, to confirm with the client.
+Control M, mitigate: a failed update or upload is retried and the user is told.
+5. The product reads it, and control S, alarm, notifies the requester when Action Required is unanswered.
+Sinks reached: the product sink (CMAC view, coordinator queue); the measurement sink (submission time, returns for information and stage times give right first time and time in stage); the business-value sinks (aggregates by location, status and period for Infrastructure reports; recycled preference for the recycle program; item, location and fulfilment date for asset and warranty history).
+Trace 2 is on the Miro board: a coordinator update must be entered on the request, not only sent by email or Teams, or it never reaches the record (gap G1). The board also has an element-by-element lineage table: born, entered by, accountable for accuracy, path, and sinks reached.
+Constraints: human-generated and intermittent; event-driven; files 10MB, replies 5MB; role-based access; retention per the Government of Alberta records schedule, to confirm; no historical migration; no direct SnapTracker or OneGX/SAP link assumed.</a:t>
             </a:r>
             <a:endParaRPr lang="en-US" dirty="0"/>
           </a:p>
@@ -6531,7 +6534,7 @@
         <p:spPr>
           <a:xfrm>
             <a:off x="548640" y="1143000"/>
-            <a:ext cx="11064240" cy="4243461"/>
+            <a:ext cx="11064240" cy="4360612"/>
           </a:xfrm>
           <a:prstGeom prst="rect">
             <a:avLst/>
@@ -6546,7 +6549,7 @@
         </p:nvSpPr>
         <p:spPr>
           <a:xfrm>
-            <a:off x="548640" y="5523621"/>
+            <a:off x="548640" y="5640772"/>
             <a:ext cx="11064240" cy="502920"/>
           </a:xfrm>
           <a:prstGeom prst="roundRect">
@@ -6568,7 +6571,7 @@
         </p:nvSpPr>
         <p:spPr>
           <a:xfrm>
-            <a:off x="685800" y="5523621"/>
+            <a:off x="685800" y="5640772"/>
             <a:ext cx="10789920" cy="502920"/>
           </a:xfrm>
           <a:prstGeom prst="rect">
@@ -6716,7 +6719,7 @@
                   <a:schemeClr val="accent1"/>
                 </a:solidFill>
               </a:rPr>
-              <a:t>STEP TWO  |  OWNERS, PREPARATION, CONSTRAINTS</a:t>
+              <a:t>STEP TWO  |  SOURCE TO SINK, AND WHO ANSWERS FOR IT</a:t>
             </a:r>
             <a:endParaRPr lang="en-US" sz="1200" dirty="0"/>
           </a:p>
@@ -6757,1702 +6760,1986 @@
                 <a:ea typeface="Cambria" pitchFamily="34" charset="-122"/>
                 <a:cs typeface="Cambria" pitchFamily="34" charset="-120"/>
               </a:rPr>
-              <a:t>Every stage has an owner; two still need confirming</a:t>
+              <a:t>Request data from source to sink, with an owner at every hop</a:t>
             </a:r>
             <a:endParaRPr lang="en-US" sz="3000" dirty="0"/>
           </a:p>
         </p:txBody>
       </p:sp>
-      <p:graphicFrame>
-        <p:nvGraphicFramePr>
-          <p:cNvPr id="7" name="Table 0"/>
-          <p:cNvGraphicFramePr>
-            <a:graphicFrameLocks noGrp="1"/>
-          </p:cNvGraphicFramePr>
-          <p:nvPr>
-            <p:extLst>
-              <p:ext uri="{D42A27DB-BD31-4B8C-83A1-F6EECF244321}">
-                <p14:modId xmlns:p14="http://schemas.microsoft.com/office/powerpoint/2010/main" val="1579011935"/>
-              </p:ext>
-            </p:extLst>
-          </p:nvPr>
-        </p:nvGraphicFramePr>
-        <p:xfrm>
-          <a:off x="548640" y="1188720"/>
-          <a:ext cx="7955280" cy="914400"/>
-        </p:xfrm>
-        <a:graphic>
-          <a:graphicData uri="http://schemas.openxmlformats.org/drawingml/2006/table">
-            <a:tbl>
-              <a:tblPr/>
-              <a:tblGrid>
-                <a:gridCol w="1325880"/>
-                <a:gridCol w="2011680"/>
-                <a:gridCol w="2606040"/>
-                <a:gridCol w="2011680"/>
-              </a:tblGrid>
-              <a:tr h="274320">
-                <a:tc>
-                  <a:txBody>
-                    <a:bodyPr/>
-                    <a:lstStyle/>
-                    <a:p>
-                      <a:pPr indent="0" marL="0">
-                        <a:buNone/>
-                      </a:pPr>
-                      <a:r>
-                        <a:rPr lang="en-US" sz="1200" b="1" dirty="0">
-                          <a:solidFill>
-                            <a:srgbClr val="FFFFFF"/>
-                          </a:solidFill>
-                          <a:latin typeface="Calibri" pitchFamily="34" charset="0"/>
-                          <a:ea typeface="Calibri" pitchFamily="34" charset="-122"/>
-                          <a:cs typeface="Calibri" pitchFamily="34" charset="-120"/>
-                        </a:rPr>
-                        <a:t>Stage</a:t>
-                      </a:r>
-                      <a:endParaRPr lang="en-US" sz="1200" dirty="0">
-                        <a:latin typeface="Calibri" charset="0"/>
-                        <a:ea typeface="Calibri" charset="0"/>
-                        <a:cs typeface="Calibri" charset="0"/>
-                      </a:endParaRPr>
-                    </a:p>
-                  </a:txBody>
-                  <a:tcPr marL="54864" marR="54864" marT="54864" marB="54864" anchor="t">
-                    <a:lnL w="12700" cap="flat" cmpd="sng" algn="ctr">
-                      <a:solidFill>
-                        <a:srgbClr val="FFFFFF"/>
-                      </a:solidFill>
-                      <a:prstDash val="solid"/>
-                      <a:round/>
-                      <a:headEnd type="none" w="med" len="med"/>
-                      <a:tailEnd type="none" w="med" len="med"/>
-                    </a:lnL>
-                    <a:lnR w="12700" cap="flat" cmpd="sng" algn="ctr">
-                      <a:solidFill>
-                        <a:srgbClr val="FFFFFF"/>
-                      </a:solidFill>
-                      <a:prstDash val="solid"/>
-                      <a:round/>
-                      <a:headEnd type="none" w="med" len="med"/>
-                      <a:tailEnd type="none" w="med" len="med"/>
-                    </a:lnR>
-                    <a:lnT w="12700" cap="flat" cmpd="sng" algn="ctr">
-                      <a:solidFill>
-                        <a:srgbClr val="FFFFFF"/>
-                      </a:solidFill>
-                      <a:prstDash val="solid"/>
-                      <a:round/>
-                      <a:headEnd type="none" w="med" len="med"/>
-                      <a:tailEnd type="none" w="med" len="med"/>
-                    </a:lnT>
-                    <a:lnB w="12700" cap="flat" cmpd="sng" algn="ctr">
-                      <a:solidFill>
-                        <a:srgbClr val="FFFFFF"/>
-                      </a:solidFill>
-                      <a:prstDash val="solid"/>
-                      <a:round/>
-                      <a:headEnd type="none" w="med" len="med"/>
-                      <a:tailEnd type="none" w="med" len="med"/>
-                    </a:lnB>
-                    <a:solidFill>
-                      <a:srgbClr val="0F3D3E"/>
-                    </a:solidFill>
-                  </a:tcPr>
-                </a:tc>
-                <a:tc>
-                  <a:txBody>
-                    <a:bodyPr/>
-                    <a:lstStyle/>
-                    <a:p>
-                      <a:pPr indent="0" marL="0">
-                        <a:buNone/>
-                      </a:pPr>
-                      <a:r>
-                        <a:rPr lang="en-US" sz="1200" b="1" dirty="0">
-                          <a:solidFill>
-                            <a:srgbClr val="FFFFFF"/>
-                          </a:solidFill>
-                          <a:latin typeface="Calibri" pitchFamily="34" charset="0"/>
-                          <a:ea typeface="Calibri" pitchFamily="34" charset="-122"/>
-                          <a:cs typeface="Calibri" pitchFamily="34" charset="-120"/>
-                        </a:rPr>
-                        <a:t>Owner</a:t>
-                      </a:r>
-                      <a:endParaRPr lang="en-US" sz="1200" dirty="0">
-                        <a:latin typeface="Calibri" charset="0"/>
-                        <a:ea typeface="Calibri" charset="0"/>
-                        <a:cs typeface="Calibri" charset="0"/>
-                      </a:endParaRPr>
-                    </a:p>
-                  </a:txBody>
-                  <a:tcPr marL="54864" marR="54864" marT="54864" marB="54864" anchor="t">
-                    <a:lnL w="12700" cap="flat" cmpd="sng" algn="ctr">
-                      <a:solidFill>
-                        <a:srgbClr val="FFFFFF"/>
-                      </a:solidFill>
-                      <a:prstDash val="solid"/>
-                      <a:round/>
-                      <a:headEnd type="none" w="med" len="med"/>
-                      <a:tailEnd type="none" w="med" len="med"/>
-                    </a:lnL>
-                    <a:lnR w="12700" cap="flat" cmpd="sng" algn="ctr">
-                      <a:solidFill>
-                        <a:srgbClr val="FFFFFF"/>
-                      </a:solidFill>
-                      <a:prstDash val="solid"/>
-                      <a:round/>
-                      <a:headEnd type="none" w="med" len="med"/>
-                      <a:tailEnd type="none" w="med" len="med"/>
-                    </a:lnR>
-                    <a:lnT w="12700" cap="flat" cmpd="sng" algn="ctr">
-                      <a:solidFill>
-                        <a:srgbClr val="FFFFFF"/>
-                      </a:solidFill>
-                      <a:prstDash val="solid"/>
-                      <a:round/>
-                      <a:headEnd type="none" w="med" len="med"/>
-                      <a:tailEnd type="none" w="med" len="med"/>
-                    </a:lnT>
-                    <a:lnB w="12700" cap="flat" cmpd="sng" algn="ctr">
-                      <a:solidFill>
-                        <a:srgbClr val="FFFFFF"/>
-                      </a:solidFill>
-                      <a:prstDash val="solid"/>
-                      <a:round/>
-                      <a:headEnd type="none" w="med" len="med"/>
-                      <a:tailEnd type="none" w="med" len="med"/>
-                    </a:lnB>
-                    <a:solidFill>
-                      <a:srgbClr val="0F3D3E"/>
-                    </a:solidFill>
-                  </a:tcPr>
-                </a:tc>
-                <a:tc>
-                  <a:txBody>
-                    <a:bodyPr/>
-                    <a:lstStyle/>
-                    <a:p>
-                      <a:pPr indent="0" marL="0">
-                        <a:buNone/>
-                      </a:pPr>
-                      <a:r>
-                        <a:rPr lang="en-US" sz="1200" b="1" dirty="0">
-                          <a:solidFill>
-                            <a:srgbClr val="FFFFFF"/>
-                          </a:solidFill>
-                          <a:latin typeface="Calibri" pitchFamily="34" charset="0"/>
-                          <a:ea typeface="Calibri" pitchFamily="34" charset="-122"/>
-                          <a:cs typeface="Calibri" pitchFamily="34" charset="-120"/>
-                        </a:rPr>
-                        <a:t>Preparation and control</a:t>
-                      </a:r>
-                      <a:endParaRPr lang="en-US" sz="1200" dirty="0">
-                        <a:latin typeface="Calibri" charset="0"/>
-                        <a:ea typeface="Calibri" charset="0"/>
-                        <a:cs typeface="Calibri" charset="0"/>
-                      </a:endParaRPr>
-                    </a:p>
-                  </a:txBody>
-                  <a:tcPr marL="54864" marR="54864" marT="54864" marB="54864" anchor="t">
-                    <a:lnL w="12700" cap="flat" cmpd="sng" algn="ctr">
-                      <a:solidFill>
-                        <a:srgbClr val="FFFFFF"/>
-                      </a:solidFill>
-                      <a:prstDash val="solid"/>
-                      <a:round/>
-                      <a:headEnd type="none" w="med" len="med"/>
-                      <a:tailEnd type="none" w="med" len="med"/>
-                    </a:lnL>
-                    <a:lnR w="12700" cap="flat" cmpd="sng" algn="ctr">
-                      <a:solidFill>
-                        <a:srgbClr val="FFFFFF"/>
-                      </a:solidFill>
-                      <a:prstDash val="solid"/>
-                      <a:round/>
-                      <a:headEnd type="none" w="med" len="med"/>
-                      <a:tailEnd type="none" w="med" len="med"/>
-                    </a:lnR>
-                    <a:lnT w="12700" cap="flat" cmpd="sng" algn="ctr">
-                      <a:solidFill>
-                        <a:srgbClr val="FFFFFF"/>
-                      </a:solidFill>
-                      <a:prstDash val="solid"/>
-                      <a:round/>
-                      <a:headEnd type="none" w="med" len="med"/>
-                      <a:tailEnd type="none" w="med" len="med"/>
-                    </a:lnT>
-                    <a:lnB w="12700" cap="flat" cmpd="sng" algn="ctr">
-                      <a:solidFill>
-                        <a:srgbClr val="FFFFFF"/>
-                      </a:solidFill>
-                      <a:prstDash val="solid"/>
-                      <a:round/>
-                      <a:headEnd type="none" w="med" len="med"/>
-                      <a:tailEnd type="none" w="med" len="med"/>
-                    </a:lnB>
-                    <a:solidFill>
-                      <a:srgbClr val="0F3D3E"/>
-                    </a:solidFill>
-                  </a:tcPr>
-                </a:tc>
-                <a:tc>
-                  <a:txBody>
-                    <a:bodyPr/>
-                    <a:lstStyle/>
-                    <a:p>
-                      <a:pPr indent="0" marL="0">
-                        <a:buNone/>
-                      </a:pPr>
-                      <a:r>
-                        <a:rPr lang="en-US" sz="1200" b="1" dirty="0">
-                          <a:solidFill>
-                            <a:srgbClr val="FFFFFF"/>
-                          </a:solidFill>
-                          <a:latin typeface="Calibri" pitchFamily="34" charset="0"/>
-                          <a:ea typeface="Calibri" pitchFamily="34" charset="-122"/>
-                          <a:cs typeface="Calibri" pitchFamily="34" charset="-120"/>
-                        </a:rPr>
-                        <a:t>Constraints</a:t>
-                      </a:r>
-                      <a:endParaRPr lang="en-US" sz="1200" dirty="0">
-                        <a:latin typeface="Calibri" charset="0"/>
-                        <a:ea typeface="Calibri" charset="0"/>
-                        <a:cs typeface="Calibri" charset="0"/>
-                      </a:endParaRPr>
-                    </a:p>
-                  </a:txBody>
-                  <a:tcPr marL="54864" marR="54864" marT="54864" marB="54864" anchor="t">
-                    <a:lnL w="12700" cap="flat" cmpd="sng" algn="ctr">
-                      <a:solidFill>
-                        <a:srgbClr val="FFFFFF"/>
-                      </a:solidFill>
-                      <a:prstDash val="solid"/>
-                      <a:round/>
-                      <a:headEnd type="none" w="med" len="med"/>
-                      <a:tailEnd type="none" w="med" len="med"/>
-                    </a:lnL>
-                    <a:lnR w="12700" cap="flat" cmpd="sng" algn="ctr">
-                      <a:solidFill>
-                        <a:srgbClr val="FFFFFF"/>
-                      </a:solidFill>
-                      <a:prstDash val="solid"/>
-                      <a:round/>
-                      <a:headEnd type="none" w="med" len="med"/>
-                      <a:tailEnd type="none" w="med" len="med"/>
-                    </a:lnR>
-                    <a:lnT w="12700" cap="flat" cmpd="sng" algn="ctr">
-                      <a:solidFill>
-                        <a:srgbClr val="FFFFFF"/>
-                      </a:solidFill>
-                      <a:prstDash val="solid"/>
-                      <a:round/>
-                      <a:headEnd type="none" w="med" len="med"/>
-                      <a:tailEnd type="none" w="med" len="med"/>
-                    </a:lnT>
-                    <a:lnB w="12700" cap="flat" cmpd="sng" algn="ctr">
-                      <a:solidFill>
-                        <a:srgbClr val="FFFFFF"/>
-                      </a:solidFill>
-                      <a:prstDash val="solid"/>
-                      <a:round/>
-                      <a:headEnd type="none" w="med" len="med"/>
-                      <a:tailEnd type="none" w="med" len="med"/>
-                    </a:lnB>
-                    <a:solidFill>
-                      <a:srgbClr val="0F3D3E"/>
-                    </a:solidFill>
-                  </a:tcPr>
-                </a:tc>
-              </a:tr>
-              <a:tr h="274320">
-                <a:tc>
-                  <a:txBody>
-                    <a:bodyPr/>
-                    <a:lstStyle/>
-                    <a:p>
-                      <a:pPr indent="0" marL="0">
-                        <a:buNone/>
-                      </a:pPr>
-                      <a:r>
-                        <a:rPr lang="en-US" sz="1200" b="1" dirty="0">
-                          <a:solidFill>
-                            <a:srgbClr val="1A1A1A"/>
-                          </a:solidFill>
-                          <a:latin typeface="Calibri" pitchFamily="34" charset="0"/>
-                          <a:ea typeface="Calibri" pitchFamily="34" charset="-122"/>
-                          <a:cs typeface="Calibri" pitchFamily="34" charset="-120"/>
-                        </a:rPr>
-                        <a:t>1 Generate</a:t>
-                      </a:r>
-                      <a:endParaRPr lang="en-US" sz="1200" dirty="0">
-                        <a:latin typeface="Calibri" charset="0"/>
-                        <a:ea typeface="Calibri" charset="0"/>
-                        <a:cs typeface="Calibri" charset="0"/>
-                      </a:endParaRPr>
-                    </a:p>
-                  </a:txBody>
-                  <a:tcPr marL="54864" marR="54864" marT="54864" marB="54864" anchor="t">
-                    <a:lnL w="12700" cap="flat" cmpd="sng" algn="ctr">
-                      <a:solidFill>
-                        <a:srgbClr val="FFFFFF"/>
-                      </a:solidFill>
-                      <a:prstDash val="solid"/>
-                      <a:round/>
-                      <a:headEnd type="none" w="med" len="med"/>
-                      <a:tailEnd type="none" w="med" len="med"/>
-                    </a:lnL>
-                    <a:lnR w="12700" cap="flat" cmpd="sng" algn="ctr">
-                      <a:solidFill>
-                        <a:srgbClr val="FFFFFF"/>
-                      </a:solidFill>
-                      <a:prstDash val="solid"/>
-                      <a:round/>
-                      <a:headEnd type="none" w="med" len="med"/>
-                      <a:tailEnd type="none" w="med" len="med"/>
-                    </a:lnR>
-                    <a:lnT w="12700" cap="flat" cmpd="sng" algn="ctr">
-                      <a:solidFill>
-                        <a:srgbClr val="FFFFFF"/>
-                      </a:solidFill>
-                      <a:prstDash val="solid"/>
-                      <a:round/>
-                      <a:headEnd type="none" w="med" len="med"/>
-                      <a:tailEnd type="none" w="med" len="med"/>
-                    </a:lnT>
-                    <a:lnB w="12700" cap="flat" cmpd="sng" algn="ctr">
-                      <a:solidFill>
-                        <a:srgbClr val="FFFFFF"/>
-                      </a:solidFill>
-                      <a:prstDash val="solid"/>
-                      <a:round/>
-                      <a:headEnd type="none" w="med" len="med"/>
-                      <a:tailEnd type="none" w="med" len="med"/>
-                    </a:lnB>
-                    <a:solidFill>
-                      <a:srgbClr val="C6DCFF"/>
-                    </a:solidFill>
-                  </a:tcPr>
-                </a:tc>
-                <a:tc>
-                  <a:txBody>
-                    <a:bodyPr/>
-                    <a:lstStyle/>
-                    <a:p>
-                      <a:pPr indent="0" marL="0">
-                        <a:buNone/>
-                      </a:pPr>
-                      <a:r>
-                        <a:rPr lang="en-US" sz="1200" dirty="0">
-                          <a:solidFill>
-                            <a:srgbClr val="1A1A1A"/>
-                          </a:solidFill>
-                          <a:latin typeface="Calibri" pitchFamily="34" charset="0"/>
-                          <a:ea typeface="Calibri" pitchFamily="34" charset="-122"/>
-                          <a:cs typeface="Calibri" pitchFamily="34" charset="-120"/>
-                        </a:rPr>
-                        <a:t>Each creator owns what they enter</a:t>
-                      </a:r>
-                      <a:endParaRPr lang="en-US" sz="1200" dirty="0">
-                        <a:latin typeface="Calibri" charset="0"/>
-                        <a:ea typeface="Calibri" charset="0"/>
-                        <a:cs typeface="Calibri" charset="0"/>
-                      </a:endParaRPr>
-                    </a:p>
-                  </a:txBody>
-                  <a:tcPr marL="54864" marR="54864" marT="54864" marB="54864" anchor="t">
-                    <a:lnL w="12700" cap="flat" cmpd="sng" algn="ctr">
-                      <a:solidFill>
-                        <a:srgbClr val="FFFFFF"/>
-                      </a:solidFill>
-                      <a:prstDash val="solid"/>
-                      <a:round/>
-                      <a:headEnd type="none" w="med" len="med"/>
-                      <a:tailEnd type="none" w="med" len="med"/>
-                    </a:lnL>
-                    <a:lnR w="12700" cap="flat" cmpd="sng" algn="ctr">
-                      <a:solidFill>
-                        <a:srgbClr val="FFFFFF"/>
-                      </a:solidFill>
-                      <a:prstDash val="solid"/>
-                      <a:round/>
-                      <a:headEnd type="none" w="med" len="med"/>
-                      <a:tailEnd type="none" w="med" len="med"/>
-                    </a:lnR>
-                    <a:lnT w="12700" cap="flat" cmpd="sng" algn="ctr">
-                      <a:solidFill>
-                        <a:srgbClr val="FFFFFF"/>
-                      </a:solidFill>
-                      <a:prstDash val="solid"/>
-                      <a:round/>
-                      <a:headEnd type="none" w="med" len="med"/>
-                      <a:tailEnd type="none" w="med" len="med"/>
-                    </a:lnT>
-                    <a:lnB w="12700" cap="flat" cmpd="sng" algn="ctr">
-                      <a:solidFill>
-                        <a:srgbClr val="FFFFFF"/>
-                      </a:solidFill>
-                      <a:prstDash val="solid"/>
-                      <a:round/>
-                      <a:headEnd type="none" w="med" len="med"/>
-                      <a:tailEnd type="none" w="med" len="med"/>
-                    </a:lnB>
-                    <a:solidFill>
-                      <a:srgbClr val="F4F7F7"/>
-                    </a:solidFill>
-                  </a:tcPr>
-                </a:tc>
-                <a:tc>
-                  <a:txBody>
-                    <a:bodyPr/>
-                    <a:lstStyle/>
-                    <a:p>
-                      <a:pPr indent="0" marL="0">
-                        <a:buNone/>
-                      </a:pPr>
-                      <a:r>
-                        <a:rPr lang="en-US" sz="1200" dirty="0">
-                          <a:solidFill>
-                            <a:srgbClr val="1A1A1A"/>
-                          </a:solidFill>
-                          <a:latin typeface="Calibri" pitchFamily="34" charset="0"/>
-                          <a:ea typeface="Calibri" pitchFamily="34" charset="-122"/>
-                          <a:cs typeface="Calibri" pitchFamily="34" charset="-120"/>
-                        </a:rPr>
-                        <a:t>None; data is created here</a:t>
-                      </a:r>
-                      <a:endParaRPr lang="en-US" sz="1200" dirty="0">
-                        <a:latin typeface="Calibri" charset="0"/>
-                        <a:ea typeface="Calibri" charset="0"/>
-                        <a:cs typeface="Calibri" charset="0"/>
-                      </a:endParaRPr>
-                    </a:p>
-                  </a:txBody>
-                  <a:tcPr marL="54864" marR="54864" marT="54864" marB="54864" anchor="t">
-                    <a:lnL w="12700" cap="flat" cmpd="sng" algn="ctr">
-                      <a:solidFill>
-                        <a:srgbClr val="FFFFFF"/>
-                      </a:solidFill>
-                      <a:prstDash val="solid"/>
-                      <a:round/>
-                      <a:headEnd type="none" w="med" len="med"/>
-                      <a:tailEnd type="none" w="med" len="med"/>
-                    </a:lnL>
-                    <a:lnR w="12700" cap="flat" cmpd="sng" algn="ctr">
-                      <a:solidFill>
-                        <a:srgbClr val="FFFFFF"/>
-                      </a:solidFill>
-                      <a:prstDash val="solid"/>
-                      <a:round/>
-                      <a:headEnd type="none" w="med" len="med"/>
-                      <a:tailEnd type="none" w="med" len="med"/>
-                    </a:lnR>
-                    <a:lnT w="12700" cap="flat" cmpd="sng" algn="ctr">
-                      <a:solidFill>
-                        <a:srgbClr val="FFFFFF"/>
-                      </a:solidFill>
-                      <a:prstDash val="solid"/>
-                      <a:round/>
-                      <a:headEnd type="none" w="med" len="med"/>
-                      <a:tailEnd type="none" w="med" len="med"/>
-                    </a:lnT>
-                    <a:lnB w="12700" cap="flat" cmpd="sng" algn="ctr">
-                      <a:solidFill>
-                        <a:srgbClr val="FFFFFF"/>
-                      </a:solidFill>
-                      <a:prstDash val="solid"/>
-                      <a:round/>
-                      <a:headEnd type="none" w="med" len="med"/>
-                      <a:tailEnd type="none" w="med" len="med"/>
-                    </a:lnB>
-                    <a:solidFill>
-                      <a:srgbClr val="F4F7F7"/>
-                    </a:solidFill>
-                  </a:tcPr>
-                </a:tc>
-                <a:tc>
-                  <a:txBody>
-                    <a:bodyPr/>
-                    <a:lstStyle/>
-                    <a:p>
-                      <a:pPr indent="0" marL="0">
-                        <a:buNone/>
-                      </a:pPr>
-                      <a:r>
-                        <a:rPr lang="en-US" sz="1200" dirty="0">
-                          <a:solidFill>
-                            <a:srgbClr val="1A1A1A"/>
-                          </a:solidFill>
-                          <a:latin typeface="Calibri" pitchFamily="34" charset="0"/>
-                          <a:ea typeface="Calibri" pitchFamily="34" charset="-122"/>
-                          <a:cs typeface="Calibri" pitchFamily="34" charset="-120"/>
-                        </a:rPr>
-                        <a:t>Much is born in email, Teams, phone and hand-drawn floor plans</a:t>
-                      </a:r>
-                      <a:endParaRPr lang="en-US" sz="1200" dirty="0">
-                        <a:latin typeface="Calibri" charset="0"/>
-                        <a:ea typeface="Calibri" charset="0"/>
-                        <a:cs typeface="Calibri" charset="0"/>
-                      </a:endParaRPr>
-                    </a:p>
-                  </a:txBody>
-                  <a:tcPr marL="54864" marR="54864" marT="54864" marB="54864" anchor="t">
-                    <a:lnL w="12700" cap="flat" cmpd="sng" algn="ctr">
-                      <a:solidFill>
-                        <a:srgbClr val="FFFFFF"/>
-                      </a:solidFill>
-                      <a:prstDash val="solid"/>
-                      <a:round/>
-                      <a:headEnd type="none" w="med" len="med"/>
-                      <a:tailEnd type="none" w="med" len="med"/>
-                    </a:lnL>
-                    <a:lnR w="12700" cap="flat" cmpd="sng" algn="ctr">
-                      <a:solidFill>
-                        <a:srgbClr val="FFFFFF"/>
-                      </a:solidFill>
-                      <a:prstDash val="solid"/>
-                      <a:round/>
-                      <a:headEnd type="none" w="med" len="med"/>
-                      <a:tailEnd type="none" w="med" len="med"/>
-                    </a:lnR>
-                    <a:lnT w="12700" cap="flat" cmpd="sng" algn="ctr">
-                      <a:solidFill>
-                        <a:srgbClr val="FFFFFF"/>
-                      </a:solidFill>
-                      <a:prstDash val="solid"/>
-                      <a:round/>
-                      <a:headEnd type="none" w="med" len="med"/>
-                      <a:tailEnd type="none" w="med" len="med"/>
-                    </a:lnT>
-                    <a:lnB w="12700" cap="flat" cmpd="sng" algn="ctr">
-                      <a:solidFill>
-                        <a:srgbClr val="FFFFFF"/>
-                      </a:solidFill>
-                      <a:prstDash val="solid"/>
-                      <a:round/>
-                      <a:headEnd type="none" w="med" len="med"/>
-                      <a:tailEnd type="none" w="med" len="med"/>
-                    </a:lnB>
-                    <a:solidFill>
-                      <a:srgbClr val="F4F7F7"/>
-                    </a:solidFill>
-                  </a:tcPr>
-                </a:tc>
-              </a:tr>
-              <a:tr h="274320">
-                <a:tc>
-                  <a:txBody>
-                    <a:bodyPr/>
-                    <a:lstStyle/>
-                    <a:p>
-                      <a:pPr indent="0" marL="0">
-                        <a:buNone/>
-                      </a:pPr>
-                      <a:r>
-                        <a:rPr lang="en-US" sz="1200" b="1" dirty="0">
-                          <a:solidFill>
-                            <a:srgbClr val="1A1A1A"/>
-                          </a:solidFill>
-                          <a:latin typeface="Calibri" pitchFamily="34" charset="0"/>
-                          <a:ea typeface="Calibri" pitchFamily="34" charset="-122"/>
-                          <a:cs typeface="Calibri" pitchFamily="34" charset="-120"/>
-                        </a:rPr>
-                        <a:t>2 Collect</a:t>
-                      </a:r>
-                      <a:endParaRPr lang="en-US" sz="1200" dirty="0">
-                        <a:latin typeface="Calibri" charset="0"/>
-                        <a:ea typeface="Calibri" charset="0"/>
-                        <a:cs typeface="Calibri" charset="0"/>
-                      </a:endParaRPr>
-                    </a:p>
-                  </a:txBody>
-                  <a:tcPr marL="54864" marR="54864" marT="54864" marB="54864" anchor="t">
-                    <a:lnL w="12700" cap="flat" cmpd="sng" algn="ctr">
-                      <a:solidFill>
-                        <a:srgbClr val="FFFFFF"/>
-                      </a:solidFill>
-                      <a:prstDash val="solid"/>
-                      <a:round/>
-                      <a:headEnd type="none" w="med" len="med"/>
-                      <a:tailEnd type="none" w="med" len="med"/>
-                    </a:lnL>
-                    <a:lnR w="12700" cap="flat" cmpd="sng" algn="ctr">
-                      <a:solidFill>
-                        <a:srgbClr val="FFFFFF"/>
-                      </a:solidFill>
-                      <a:prstDash val="solid"/>
-                      <a:round/>
-                      <a:headEnd type="none" w="med" len="med"/>
-                      <a:tailEnd type="none" w="med" len="med"/>
-                    </a:lnR>
-                    <a:lnT w="12700" cap="flat" cmpd="sng" algn="ctr">
-                      <a:solidFill>
-                        <a:srgbClr val="FFFFFF"/>
-                      </a:solidFill>
-                      <a:prstDash val="solid"/>
-                      <a:round/>
-                      <a:headEnd type="none" w="med" len="med"/>
-                      <a:tailEnd type="none" w="med" len="med"/>
-                    </a:lnT>
-                    <a:lnB w="12700" cap="flat" cmpd="sng" algn="ctr">
-                      <a:solidFill>
-                        <a:srgbClr val="FFFFFF"/>
-                      </a:solidFill>
-                      <a:prstDash val="solid"/>
-                      <a:round/>
-                      <a:headEnd type="none" w="med" len="med"/>
-                      <a:tailEnd type="none" w="med" len="med"/>
-                    </a:lnB>
-                    <a:solidFill>
-                      <a:srgbClr val="C6DCFF"/>
-                    </a:solidFill>
-                  </a:tcPr>
-                </a:tc>
-                <a:tc>
-                  <a:txBody>
-                    <a:bodyPr/>
-                    <a:lstStyle/>
-                    <a:p>
-                      <a:pPr indent="0" marL="0">
-                        <a:buNone/>
-                      </a:pPr>
-                      <a:r>
-                        <a:rPr lang="en-US" sz="1200" dirty="0">
-                          <a:solidFill>
-                            <a:srgbClr val="1A1A1A"/>
-                          </a:solidFill>
-                          <a:latin typeface="Calibri" pitchFamily="34" charset="0"/>
-                          <a:ea typeface="Calibri" pitchFamily="34" charset="-122"/>
-                          <a:cs typeface="Calibri" pitchFamily="34" charset="-120"/>
-                        </a:rPr>
-                        <a:t>CMAC at submission; coordinators for updates</a:t>
-                      </a:r>
-                      <a:endParaRPr lang="en-US" sz="1200" dirty="0">
-                        <a:latin typeface="Calibri" charset="0"/>
-                        <a:ea typeface="Calibri" charset="0"/>
-                        <a:cs typeface="Calibri" charset="0"/>
-                      </a:endParaRPr>
-                    </a:p>
-                  </a:txBody>
-                  <a:tcPr marL="54864" marR="54864" marT="54864" marB="54864" anchor="t">
-                    <a:lnL w="12700" cap="flat" cmpd="sng" algn="ctr">
-                      <a:solidFill>
-                        <a:srgbClr val="FFFFFF"/>
-                      </a:solidFill>
-                      <a:prstDash val="solid"/>
-                      <a:round/>
-                      <a:headEnd type="none" w="med" len="med"/>
-                      <a:tailEnd type="none" w="med" len="med"/>
-                    </a:lnL>
-                    <a:lnR w="12700" cap="flat" cmpd="sng" algn="ctr">
-                      <a:solidFill>
-                        <a:srgbClr val="FFFFFF"/>
-                      </a:solidFill>
-                      <a:prstDash val="solid"/>
-                      <a:round/>
-                      <a:headEnd type="none" w="med" len="med"/>
-                      <a:tailEnd type="none" w="med" len="med"/>
-                    </a:lnR>
-                    <a:lnT w="12700" cap="flat" cmpd="sng" algn="ctr">
-                      <a:solidFill>
-                        <a:srgbClr val="FFFFFF"/>
-                      </a:solidFill>
-                      <a:prstDash val="solid"/>
-                      <a:round/>
-                      <a:headEnd type="none" w="med" len="med"/>
-                      <a:tailEnd type="none" w="med" len="med"/>
-                    </a:lnT>
-                    <a:lnB w="12700" cap="flat" cmpd="sng" algn="ctr">
-                      <a:solidFill>
-                        <a:srgbClr val="FFFFFF"/>
-                      </a:solidFill>
-                      <a:prstDash val="solid"/>
-                      <a:round/>
-                      <a:headEnd type="none" w="med" len="med"/>
-                      <a:tailEnd type="none" w="med" len="med"/>
-                    </a:lnB>
-                    <a:solidFill>
-                      <a:srgbClr val="F4F7F7"/>
-                    </a:solidFill>
-                  </a:tcPr>
-                </a:tc>
-                <a:tc>
-                  <a:txBody>
-                    <a:bodyPr/>
-                    <a:lstStyle/>
-                    <a:p>
-                      <a:pPr indent="0" marL="0">
-                        <a:buNone/>
-                      </a:pPr>
-                      <a:r>
-                        <a:rPr lang="en-US" sz="1200" dirty="0">
-                          <a:solidFill>
-                            <a:srgbClr val="1A1A1A"/>
-                          </a:solidFill>
-                          <a:latin typeface="Calibri" pitchFamily="34" charset="0"/>
-                          <a:ea typeface="Calibri" pitchFamily="34" charset="-122"/>
-                          <a:cs typeface="Calibri" pitchFamily="34" charset="-120"/>
-                        </a:rPr>
-                        <a:t>Guided form; pre-filled requester and facility data. A: authorized requesters only</a:t>
-                      </a:r>
-                      <a:endParaRPr lang="en-US" sz="1200" dirty="0">
-                        <a:latin typeface="Calibri" charset="0"/>
-                        <a:ea typeface="Calibri" charset="0"/>
-                        <a:cs typeface="Calibri" charset="0"/>
-                      </a:endParaRPr>
-                    </a:p>
-                  </a:txBody>
-                  <a:tcPr marL="54864" marR="54864" marT="54864" marB="54864" anchor="t">
-                    <a:lnL w="12700" cap="flat" cmpd="sng" algn="ctr">
-                      <a:solidFill>
-                        <a:srgbClr val="FFFFFF"/>
-                      </a:solidFill>
-                      <a:prstDash val="solid"/>
-                      <a:round/>
-                      <a:headEnd type="none" w="med" len="med"/>
-                      <a:tailEnd type="none" w="med" len="med"/>
-                    </a:lnL>
-                    <a:lnR w="12700" cap="flat" cmpd="sng" algn="ctr">
-                      <a:solidFill>
-                        <a:srgbClr val="FFFFFF"/>
-                      </a:solidFill>
-                      <a:prstDash val="solid"/>
-                      <a:round/>
-                      <a:headEnd type="none" w="med" len="med"/>
-                      <a:tailEnd type="none" w="med" len="med"/>
-                    </a:lnR>
-                    <a:lnT w="12700" cap="flat" cmpd="sng" algn="ctr">
-                      <a:solidFill>
-                        <a:srgbClr val="FFFFFF"/>
-                      </a:solidFill>
-                      <a:prstDash val="solid"/>
-                      <a:round/>
-                      <a:headEnd type="none" w="med" len="med"/>
-                      <a:tailEnd type="none" w="med" len="med"/>
-                    </a:lnT>
-                    <a:lnB w="12700" cap="flat" cmpd="sng" algn="ctr">
-                      <a:solidFill>
-                        <a:srgbClr val="FFFFFF"/>
-                      </a:solidFill>
-                      <a:prstDash val="solid"/>
-                      <a:round/>
-                      <a:headEnd type="none" w="med" len="med"/>
-                      <a:tailEnd type="none" w="med" len="med"/>
-                    </a:lnB>
-                    <a:solidFill>
-                      <a:srgbClr val="F4F7F7"/>
-                    </a:solidFill>
-                  </a:tcPr>
-                </a:tc>
-                <a:tc>
-                  <a:txBody>
-                    <a:bodyPr/>
-                    <a:lstStyle/>
-                    <a:p>
-                      <a:pPr indent="0" marL="0">
-                        <a:buNone/>
-                      </a:pPr>
-                      <a:r>
-                        <a:rPr lang="en-US" sz="1200" dirty="0">
-                          <a:solidFill>
-                            <a:srgbClr val="1A1A1A"/>
-                          </a:solidFill>
-                          <a:latin typeface="Calibri" pitchFamily="34" charset="0"/>
-                          <a:ea typeface="Calibri" pitchFamily="34" charset="-122"/>
-                          <a:cs typeface="Calibri" pitchFamily="34" charset="-120"/>
-                        </a:rPr>
-                        <a:t>Off-system updates lost; 10MB attachments, 5MB replies</a:t>
-                      </a:r>
-                      <a:endParaRPr lang="en-US" sz="1200" dirty="0">
-                        <a:latin typeface="Calibri" charset="0"/>
-                        <a:ea typeface="Calibri" charset="0"/>
-                        <a:cs typeface="Calibri" charset="0"/>
-                      </a:endParaRPr>
-                    </a:p>
-                  </a:txBody>
-                  <a:tcPr marL="54864" marR="54864" marT="54864" marB="54864" anchor="t">
-                    <a:lnL w="12700" cap="flat" cmpd="sng" algn="ctr">
-                      <a:solidFill>
-                        <a:srgbClr val="FFFFFF"/>
-                      </a:solidFill>
-                      <a:prstDash val="solid"/>
-                      <a:round/>
-                      <a:headEnd type="none" w="med" len="med"/>
-                      <a:tailEnd type="none" w="med" len="med"/>
-                    </a:lnL>
-                    <a:lnR w="12700" cap="flat" cmpd="sng" algn="ctr">
-                      <a:solidFill>
-                        <a:srgbClr val="FFFFFF"/>
-                      </a:solidFill>
-                      <a:prstDash val="solid"/>
-                      <a:round/>
-                      <a:headEnd type="none" w="med" len="med"/>
-                      <a:tailEnd type="none" w="med" len="med"/>
-                    </a:lnR>
-                    <a:lnT w="12700" cap="flat" cmpd="sng" algn="ctr">
-                      <a:solidFill>
-                        <a:srgbClr val="FFFFFF"/>
-                      </a:solidFill>
-                      <a:prstDash val="solid"/>
-                      <a:round/>
-                      <a:headEnd type="none" w="med" len="med"/>
-                      <a:tailEnd type="none" w="med" len="med"/>
-                    </a:lnT>
-                    <a:lnB w="12700" cap="flat" cmpd="sng" algn="ctr">
-                      <a:solidFill>
-                        <a:srgbClr val="FFFFFF"/>
-                      </a:solidFill>
-                      <a:prstDash val="solid"/>
-                      <a:round/>
-                      <a:headEnd type="none" w="med" len="med"/>
-                      <a:tailEnd type="none" w="med" len="med"/>
-                    </a:lnB>
-                    <a:solidFill>
-                      <a:srgbClr val="F4F7F7"/>
-                    </a:solidFill>
-                  </a:tcPr>
-                </a:tc>
-              </a:tr>
-              <a:tr h="274320">
-                <a:tc>
-                  <a:txBody>
-                    <a:bodyPr/>
-                    <a:lstStyle/>
-                    <a:p>
-                      <a:pPr indent="0" marL="0">
-                        <a:buNone/>
-                      </a:pPr>
-                      <a:r>
-                        <a:rPr lang="en-US" sz="1200" b="1" dirty="0">
-                          <a:solidFill>
-                            <a:srgbClr val="1A1A1A"/>
-                          </a:solidFill>
-                          <a:latin typeface="Calibri" pitchFamily="34" charset="0"/>
-                          <a:ea typeface="Calibri" pitchFamily="34" charset="-122"/>
-                          <a:cs typeface="Calibri" pitchFamily="34" charset="-120"/>
-                        </a:rPr>
-                        <a:t>3 Keep and Shape</a:t>
-                      </a:r>
-                      <a:endParaRPr lang="en-US" sz="1200" dirty="0">
-                        <a:latin typeface="Calibri" charset="0"/>
-                        <a:ea typeface="Calibri" charset="0"/>
-                        <a:cs typeface="Calibri" charset="0"/>
-                      </a:endParaRPr>
-                    </a:p>
-                  </a:txBody>
-                  <a:tcPr marL="54864" marR="54864" marT="54864" marB="54864" anchor="t">
-                    <a:lnL w="12700" cap="flat" cmpd="sng" algn="ctr">
-                      <a:solidFill>
-                        <a:srgbClr val="FFFFFF"/>
-                      </a:solidFill>
-                      <a:prstDash val="solid"/>
-                      <a:round/>
-                      <a:headEnd type="none" w="med" len="med"/>
-                      <a:tailEnd type="none" w="med" len="med"/>
-                    </a:lnL>
-                    <a:lnR w="12700" cap="flat" cmpd="sng" algn="ctr">
-                      <a:solidFill>
-                        <a:srgbClr val="FFFFFF"/>
-                      </a:solidFill>
-                      <a:prstDash val="solid"/>
-                      <a:round/>
-                      <a:headEnd type="none" w="med" len="med"/>
-                      <a:tailEnd type="none" w="med" len="med"/>
-                    </a:lnR>
-                    <a:lnT w="12700" cap="flat" cmpd="sng" algn="ctr">
-                      <a:solidFill>
-                        <a:srgbClr val="FFFFFF"/>
-                      </a:solidFill>
-                      <a:prstDash val="solid"/>
-                      <a:round/>
-                      <a:headEnd type="none" w="med" len="med"/>
-                      <a:tailEnd type="none" w="med" len="med"/>
-                    </a:lnT>
-                    <a:lnB w="12700" cap="flat" cmpd="sng" algn="ctr">
-                      <a:solidFill>
-                        <a:srgbClr val="FFFFFF"/>
-                      </a:solidFill>
-                      <a:prstDash val="solid"/>
-                      <a:round/>
-                      <a:headEnd type="none" w="med" len="med"/>
-                      <a:tailEnd type="none" w="med" len="med"/>
-                    </a:lnB>
-                    <a:solidFill>
-                      <a:srgbClr val="C6DCFF"/>
-                    </a:solidFill>
-                  </a:tcPr>
-                </a:tc>
-                <a:tc>
-                  <a:txBody>
-                    <a:bodyPr/>
-                    <a:lstStyle/>
-                    <a:p>
-                      <a:pPr indent="0" marL="0">
-                        <a:buNone/>
-                      </a:pPr>
-                      <a:r>
-                        <a:rPr lang="en-US" sz="1200" dirty="0">
-                          <a:solidFill>
-                            <a:srgbClr val="1A1A1A"/>
-                          </a:solidFill>
-                          <a:latin typeface="Calibri" pitchFamily="34" charset="0"/>
-                          <a:ea typeface="Calibri" pitchFamily="34" charset="-122"/>
-                          <a:cs typeface="Calibri" pitchFamily="34" charset="-120"/>
-                        </a:rPr>
-                        <a:t>Open. Proposed: Furniture Request Coordinator</a:t>
-                      </a:r>
-                      <a:endParaRPr lang="en-US" sz="1200" dirty="0">
-                        <a:latin typeface="Calibri" charset="0"/>
-                        <a:ea typeface="Calibri" charset="0"/>
-                        <a:cs typeface="Calibri" charset="0"/>
-                      </a:endParaRPr>
-                    </a:p>
-                  </a:txBody>
-                  <a:tcPr marL="54864" marR="54864" marT="54864" marB="54864" anchor="t">
-                    <a:lnL w="12700" cap="flat" cmpd="sng" algn="ctr">
-                      <a:solidFill>
-                        <a:srgbClr val="FFFFFF"/>
-                      </a:solidFill>
-                      <a:prstDash val="solid"/>
-                      <a:round/>
-                      <a:headEnd type="none" w="med" len="med"/>
-                      <a:tailEnd type="none" w="med" len="med"/>
-                    </a:lnL>
-                    <a:lnR w="12700" cap="flat" cmpd="sng" algn="ctr">
-                      <a:solidFill>
-                        <a:srgbClr val="FFFFFF"/>
-                      </a:solidFill>
-                      <a:prstDash val="solid"/>
-                      <a:round/>
-                      <a:headEnd type="none" w="med" len="med"/>
-                      <a:tailEnd type="none" w="med" len="med"/>
-                    </a:lnR>
-                    <a:lnT w="12700" cap="flat" cmpd="sng" algn="ctr">
-                      <a:solidFill>
-                        <a:srgbClr val="FFFFFF"/>
-                      </a:solidFill>
-                      <a:prstDash val="solid"/>
-                      <a:round/>
-                      <a:headEnd type="none" w="med" len="med"/>
-                      <a:tailEnd type="none" w="med" len="med"/>
-                    </a:lnT>
-                    <a:lnB w="12700" cap="flat" cmpd="sng" algn="ctr">
-                      <a:solidFill>
-                        <a:srgbClr val="FFFFFF"/>
-                      </a:solidFill>
-                      <a:prstDash val="solid"/>
-                      <a:round/>
-                      <a:headEnd type="none" w="med" len="med"/>
-                      <a:tailEnd type="none" w="med" len="med"/>
-                    </a:lnB>
-                    <a:solidFill>
-                      <a:srgbClr val="FFC6C6"/>
-                    </a:solidFill>
-                  </a:tcPr>
-                </a:tc>
-                <a:tc>
-                  <a:txBody>
-                    <a:bodyPr/>
-                    <a:lstStyle/>
-                    <a:p>
-                      <a:pPr indent="0" marL="0">
-                        <a:buNone/>
-                      </a:pPr>
-                      <a:r>
-                        <a:rPr lang="en-US" sz="1200" dirty="0">
-                          <a:solidFill>
-                            <a:srgbClr val="1A1A1A"/>
-                          </a:solidFill>
-                          <a:latin typeface="Calibri" pitchFamily="34" charset="0"/>
-                          <a:ea typeface="Calibri" pitchFamily="34" charset="-122"/>
-                          <a:cs typeface="Calibri" pitchFamily="34" charset="-120"/>
-                        </a:rPr>
-                        <a:t>Keep the original (bronze); link updates, standard status, check duplicates (silver). V: required fields</a:t>
-                      </a:r>
-                      <a:endParaRPr lang="en-US" sz="1200" dirty="0">
-                        <a:latin typeface="Calibri" charset="0"/>
-                        <a:ea typeface="Calibri" charset="0"/>
-                        <a:cs typeface="Calibri" charset="0"/>
-                      </a:endParaRPr>
-                    </a:p>
-                  </a:txBody>
-                  <a:tcPr marL="54864" marR="54864" marT="54864" marB="54864" anchor="t">
-                    <a:lnL w="12700" cap="flat" cmpd="sng" algn="ctr">
-                      <a:solidFill>
-                        <a:srgbClr val="FFFFFF"/>
-                      </a:solidFill>
-                      <a:prstDash val="solid"/>
-                      <a:round/>
-                      <a:headEnd type="none" w="med" len="med"/>
-                      <a:tailEnd type="none" w="med" len="med"/>
-                    </a:lnL>
-                    <a:lnR w="12700" cap="flat" cmpd="sng" algn="ctr">
-                      <a:solidFill>
-                        <a:srgbClr val="FFFFFF"/>
-                      </a:solidFill>
-                      <a:prstDash val="solid"/>
-                      <a:round/>
-                      <a:headEnd type="none" w="med" len="med"/>
-                      <a:tailEnd type="none" w="med" len="med"/>
-                    </a:lnR>
-                    <a:lnT w="12700" cap="flat" cmpd="sng" algn="ctr">
-                      <a:solidFill>
-                        <a:srgbClr val="FFFFFF"/>
-                      </a:solidFill>
-                      <a:prstDash val="solid"/>
-                      <a:round/>
-                      <a:headEnd type="none" w="med" len="med"/>
-                      <a:tailEnd type="none" w="med" len="med"/>
-                    </a:lnT>
-                    <a:lnB w="12700" cap="flat" cmpd="sng" algn="ctr">
-                      <a:solidFill>
-                        <a:srgbClr val="FFFFFF"/>
-                      </a:solidFill>
-                      <a:prstDash val="solid"/>
-                      <a:round/>
-                      <a:headEnd type="none" w="med" len="med"/>
-                      <a:tailEnd type="none" w="med" len="med"/>
-                    </a:lnB>
-                    <a:solidFill>
-                      <a:srgbClr val="F4F7F7"/>
-                    </a:solidFill>
-                  </a:tcPr>
-                </a:tc>
-                <a:tc>
-                  <a:txBody>
-                    <a:bodyPr/>
-                    <a:lstStyle/>
-                    <a:p>
-                      <a:pPr indent="0" marL="0">
-                        <a:buNone/>
-                      </a:pPr>
-                      <a:r>
-                        <a:rPr lang="en-US" sz="1200" dirty="0">
-                          <a:solidFill>
-                            <a:srgbClr val="1A1A1A"/>
-                          </a:solidFill>
-                          <a:latin typeface="Calibri" pitchFamily="34" charset="0"/>
-                          <a:ea typeface="Calibri" pitchFamily="34" charset="-122"/>
-                          <a:cs typeface="Calibri" pitchFamily="34" charset="-120"/>
-                        </a:rPr>
-                        <a:t>No match key for duplicates; conflicting status labels</a:t>
-                      </a:r>
-                      <a:endParaRPr lang="en-US" sz="1200" dirty="0">
-                        <a:latin typeface="Calibri" charset="0"/>
-                        <a:ea typeface="Calibri" charset="0"/>
-                        <a:cs typeface="Calibri" charset="0"/>
-                      </a:endParaRPr>
-                    </a:p>
-                  </a:txBody>
-                  <a:tcPr marL="54864" marR="54864" marT="54864" marB="54864" anchor="t">
-                    <a:lnL w="12700" cap="flat" cmpd="sng" algn="ctr">
-                      <a:solidFill>
-                        <a:srgbClr val="FFFFFF"/>
-                      </a:solidFill>
-                      <a:prstDash val="solid"/>
-                      <a:round/>
-                      <a:headEnd type="none" w="med" len="med"/>
-                      <a:tailEnd type="none" w="med" len="med"/>
-                    </a:lnL>
-                    <a:lnR w="12700" cap="flat" cmpd="sng" algn="ctr">
-                      <a:solidFill>
-                        <a:srgbClr val="FFFFFF"/>
-                      </a:solidFill>
-                      <a:prstDash val="solid"/>
-                      <a:round/>
-                      <a:headEnd type="none" w="med" len="med"/>
-                      <a:tailEnd type="none" w="med" len="med"/>
-                    </a:lnR>
-                    <a:lnT w="12700" cap="flat" cmpd="sng" algn="ctr">
-                      <a:solidFill>
-                        <a:srgbClr val="FFFFFF"/>
-                      </a:solidFill>
-                      <a:prstDash val="solid"/>
-                      <a:round/>
-                      <a:headEnd type="none" w="med" len="med"/>
-                      <a:tailEnd type="none" w="med" len="med"/>
-                    </a:lnT>
-                    <a:lnB w="12700" cap="flat" cmpd="sng" algn="ctr">
-                      <a:solidFill>
-                        <a:srgbClr val="FFFFFF"/>
-                      </a:solidFill>
-                      <a:prstDash val="solid"/>
-                      <a:round/>
-                      <a:headEnd type="none" w="med" len="med"/>
-                      <a:tailEnd type="none" w="med" len="med"/>
-                    </a:lnB>
-                    <a:solidFill>
-                      <a:srgbClr val="F4F7F7"/>
-                    </a:solidFill>
-                  </a:tcPr>
-                </a:tc>
-              </a:tr>
-              <a:tr h="274320">
-                <a:tc>
-                  <a:txBody>
-                    <a:bodyPr/>
-                    <a:lstStyle/>
-                    <a:p>
-                      <a:pPr indent="0" marL="0">
-                        <a:buNone/>
-                      </a:pPr>
-                      <a:r>
-                        <a:rPr lang="en-US" sz="1200" b="1" dirty="0">
-                          <a:solidFill>
-                            <a:srgbClr val="1A1A1A"/>
-                          </a:solidFill>
-                          <a:latin typeface="Calibri" pitchFamily="34" charset="0"/>
-                          <a:ea typeface="Calibri" pitchFamily="34" charset="-122"/>
-                          <a:cs typeface="Calibri" pitchFamily="34" charset="-120"/>
-                        </a:rPr>
-                        <a:t>4 Store</a:t>
-                      </a:r>
-                      <a:endParaRPr lang="en-US" sz="1200" dirty="0">
-                        <a:latin typeface="Calibri" charset="0"/>
-                        <a:ea typeface="Calibri" charset="0"/>
-                        <a:cs typeface="Calibri" charset="0"/>
-                      </a:endParaRPr>
-                    </a:p>
-                  </a:txBody>
-                  <a:tcPr marL="54864" marR="54864" marT="54864" marB="54864" anchor="t">
-                    <a:lnL w="12700" cap="flat" cmpd="sng" algn="ctr">
-                      <a:solidFill>
-                        <a:srgbClr val="FFFFFF"/>
-                      </a:solidFill>
-                      <a:prstDash val="solid"/>
-                      <a:round/>
-                      <a:headEnd type="none" w="med" len="med"/>
-                      <a:tailEnd type="none" w="med" len="med"/>
-                    </a:lnL>
-                    <a:lnR w="12700" cap="flat" cmpd="sng" algn="ctr">
-                      <a:solidFill>
-                        <a:srgbClr val="FFFFFF"/>
-                      </a:solidFill>
-                      <a:prstDash val="solid"/>
-                      <a:round/>
-                      <a:headEnd type="none" w="med" len="med"/>
-                      <a:tailEnd type="none" w="med" len="med"/>
-                    </a:lnR>
-                    <a:lnT w="12700" cap="flat" cmpd="sng" algn="ctr">
-                      <a:solidFill>
-                        <a:srgbClr val="FFFFFF"/>
-                      </a:solidFill>
-                      <a:prstDash val="solid"/>
-                      <a:round/>
-                      <a:headEnd type="none" w="med" len="med"/>
-                      <a:tailEnd type="none" w="med" len="med"/>
-                    </a:lnT>
-                    <a:lnB w="12700" cap="flat" cmpd="sng" algn="ctr">
-                      <a:solidFill>
-                        <a:srgbClr val="FFFFFF"/>
-                      </a:solidFill>
-                      <a:prstDash val="solid"/>
-                      <a:round/>
-                      <a:headEnd type="none" w="med" len="med"/>
-                      <a:tailEnd type="none" w="med" len="med"/>
-                    </a:lnB>
-                    <a:solidFill>
-                      <a:srgbClr val="C6DCFF"/>
-                    </a:solidFill>
-                  </a:tcPr>
-                </a:tc>
-                <a:tc>
-                  <a:txBody>
-                    <a:bodyPr/>
-                    <a:lstStyle/>
-                    <a:p>
-                      <a:pPr indent="0" marL="0">
-                        <a:buNone/>
-                      </a:pPr>
-                      <a:r>
-                        <a:rPr lang="en-US" sz="1200" dirty="0">
-                          <a:solidFill>
-                            <a:srgbClr val="1A1A1A"/>
-                          </a:solidFill>
-                          <a:latin typeface="Calibri" pitchFamily="34" charset="0"/>
-                          <a:ea typeface="Calibri" pitchFamily="34" charset="-122"/>
-                          <a:cs typeface="Calibri" pitchFamily="34" charset="-120"/>
-                        </a:rPr>
-                        <a:t>Open: data owner, confirm with the client</a:t>
-                      </a:r>
-                      <a:endParaRPr lang="en-US" sz="1200" dirty="0">
-                        <a:latin typeface="Calibri" charset="0"/>
-                        <a:ea typeface="Calibri" charset="0"/>
-                        <a:cs typeface="Calibri" charset="0"/>
-                      </a:endParaRPr>
-                    </a:p>
-                  </a:txBody>
-                  <a:tcPr marL="54864" marR="54864" marT="54864" marB="54864" anchor="t">
-                    <a:lnL w="12700" cap="flat" cmpd="sng" algn="ctr">
-                      <a:solidFill>
-                        <a:srgbClr val="FFFFFF"/>
-                      </a:solidFill>
-                      <a:prstDash val="solid"/>
-                      <a:round/>
-                      <a:headEnd type="none" w="med" len="med"/>
-                      <a:tailEnd type="none" w="med" len="med"/>
-                    </a:lnL>
-                    <a:lnR w="12700" cap="flat" cmpd="sng" algn="ctr">
-                      <a:solidFill>
-                        <a:srgbClr val="FFFFFF"/>
-                      </a:solidFill>
-                      <a:prstDash val="solid"/>
-                      <a:round/>
-                      <a:headEnd type="none" w="med" len="med"/>
-                      <a:tailEnd type="none" w="med" len="med"/>
-                    </a:lnR>
-                    <a:lnT w="12700" cap="flat" cmpd="sng" algn="ctr">
-                      <a:solidFill>
-                        <a:srgbClr val="FFFFFF"/>
-                      </a:solidFill>
-                      <a:prstDash val="solid"/>
-                      <a:round/>
-                      <a:headEnd type="none" w="med" len="med"/>
-                      <a:tailEnd type="none" w="med" len="med"/>
-                    </a:lnT>
-                    <a:lnB w="12700" cap="flat" cmpd="sng" algn="ctr">
-                      <a:solidFill>
-                        <a:srgbClr val="FFFFFF"/>
-                      </a:solidFill>
-                      <a:prstDash val="solid"/>
-                      <a:round/>
-                      <a:headEnd type="none" w="med" len="med"/>
-                      <a:tailEnd type="none" w="med" len="med"/>
-                    </a:lnB>
-                    <a:solidFill>
-                      <a:srgbClr val="FFC6C6"/>
-                    </a:solidFill>
-                  </a:tcPr>
-                </a:tc>
-                <a:tc>
-                  <a:txBody>
-                    <a:bodyPr/>
-                    <a:lstStyle/>
-                    <a:p>
-                      <a:pPr indent="0" marL="0">
-                        <a:buNone/>
-                      </a:pPr>
-                      <a:r>
-                        <a:rPr lang="en-US" sz="1200" dirty="0">
-                          <a:solidFill>
-                            <a:srgbClr val="1A1A1A"/>
-                          </a:solidFill>
-                          <a:latin typeface="Calibri" pitchFamily="34" charset="0"/>
-                          <a:ea typeface="Calibri" pitchFamily="34" charset="-122"/>
-                          <a:cs typeface="Calibri" pitchFamily="34" charset="-120"/>
-                        </a:rPr>
-                        <a:t>One auditable request record. F: every stage change carries a time</a:t>
-                      </a:r>
-                      <a:endParaRPr lang="en-US" sz="1200" dirty="0">
-                        <a:latin typeface="Calibri" charset="0"/>
-                        <a:ea typeface="Calibri" charset="0"/>
-                        <a:cs typeface="Calibri" charset="0"/>
-                      </a:endParaRPr>
-                    </a:p>
-                  </a:txBody>
-                  <a:tcPr marL="54864" marR="54864" marT="54864" marB="54864" anchor="t">
-                    <a:lnL w="12700" cap="flat" cmpd="sng" algn="ctr">
-                      <a:solidFill>
-                        <a:srgbClr val="FFFFFF"/>
-                      </a:solidFill>
-                      <a:prstDash val="solid"/>
-                      <a:round/>
-                      <a:headEnd type="none" w="med" len="med"/>
-                      <a:tailEnd type="none" w="med" len="med"/>
-                    </a:lnL>
-                    <a:lnR w="12700" cap="flat" cmpd="sng" algn="ctr">
-                      <a:solidFill>
-                        <a:srgbClr val="FFFFFF"/>
-                      </a:solidFill>
-                      <a:prstDash val="solid"/>
-                      <a:round/>
-                      <a:headEnd type="none" w="med" len="med"/>
-                      <a:tailEnd type="none" w="med" len="med"/>
-                    </a:lnR>
-                    <a:lnT w="12700" cap="flat" cmpd="sng" algn="ctr">
-                      <a:solidFill>
-                        <a:srgbClr val="FFFFFF"/>
-                      </a:solidFill>
-                      <a:prstDash val="solid"/>
-                      <a:round/>
-                      <a:headEnd type="none" w="med" len="med"/>
-                      <a:tailEnd type="none" w="med" len="med"/>
-                    </a:lnT>
-                    <a:lnB w="12700" cap="flat" cmpd="sng" algn="ctr">
-                      <a:solidFill>
-                        <a:srgbClr val="FFFFFF"/>
-                      </a:solidFill>
-                      <a:prstDash val="solid"/>
-                      <a:round/>
-                      <a:headEnd type="none" w="med" len="med"/>
-                      <a:tailEnd type="none" w="med" len="med"/>
-                    </a:lnB>
-                    <a:solidFill>
-                      <a:srgbClr val="F4F7F7"/>
-                    </a:solidFill>
-                  </a:tcPr>
-                </a:tc>
-                <a:tc>
-                  <a:txBody>
-                    <a:bodyPr/>
-                    <a:lstStyle/>
-                    <a:p>
-                      <a:pPr indent="0" marL="0">
-                        <a:buNone/>
-                      </a:pPr>
-                      <a:r>
-                        <a:rPr lang="en-US" sz="1200" dirty="0">
-                          <a:solidFill>
-                            <a:srgbClr val="1A1A1A"/>
-                          </a:solidFill>
-                          <a:latin typeface="Calibri" pitchFamily="34" charset="0"/>
-                          <a:ea typeface="Calibri" pitchFamily="34" charset="-122"/>
-                          <a:cs typeface="Calibri" pitchFamily="34" charset="-120"/>
-                        </a:rPr>
-                        <a:t>Role-based access; retention to confirm; no migration</a:t>
-                      </a:r>
-                      <a:endParaRPr lang="en-US" sz="1200" dirty="0">
-                        <a:latin typeface="Calibri" charset="0"/>
-                        <a:ea typeface="Calibri" charset="0"/>
-                        <a:cs typeface="Calibri" charset="0"/>
-                      </a:endParaRPr>
-                    </a:p>
-                  </a:txBody>
-                  <a:tcPr marL="54864" marR="54864" marT="54864" marB="54864" anchor="t">
-                    <a:lnL w="12700" cap="flat" cmpd="sng" algn="ctr">
-                      <a:solidFill>
-                        <a:srgbClr val="FFFFFF"/>
-                      </a:solidFill>
-                      <a:prstDash val="solid"/>
-                      <a:round/>
-                      <a:headEnd type="none" w="med" len="med"/>
-                      <a:tailEnd type="none" w="med" len="med"/>
-                    </a:lnL>
-                    <a:lnR w="12700" cap="flat" cmpd="sng" algn="ctr">
-                      <a:solidFill>
-                        <a:srgbClr val="FFFFFF"/>
-                      </a:solidFill>
-                      <a:prstDash val="solid"/>
-                      <a:round/>
-                      <a:headEnd type="none" w="med" len="med"/>
-                      <a:tailEnd type="none" w="med" len="med"/>
-                    </a:lnR>
-                    <a:lnT w="12700" cap="flat" cmpd="sng" algn="ctr">
-                      <a:solidFill>
-                        <a:srgbClr val="FFFFFF"/>
-                      </a:solidFill>
-                      <a:prstDash val="solid"/>
-                      <a:round/>
-                      <a:headEnd type="none" w="med" len="med"/>
-                      <a:tailEnd type="none" w="med" len="med"/>
-                    </a:lnT>
-                    <a:lnB w="12700" cap="flat" cmpd="sng" algn="ctr">
-                      <a:solidFill>
-                        <a:srgbClr val="FFFFFF"/>
-                      </a:solidFill>
-                      <a:prstDash val="solid"/>
-                      <a:round/>
-                      <a:headEnd type="none" w="med" len="med"/>
-                      <a:tailEnd type="none" w="med" len="med"/>
-                    </a:lnB>
-                    <a:solidFill>
-                      <a:srgbClr val="F4F7F7"/>
-                    </a:solidFill>
-                  </a:tcPr>
-                </a:tc>
-              </a:tr>
-              <a:tr h="274320">
-                <a:tc>
-                  <a:txBody>
-                    <a:bodyPr/>
-                    <a:lstStyle/>
-                    <a:p>
-                      <a:pPr indent="0" marL="0">
-                        <a:buNone/>
-                      </a:pPr>
-                      <a:r>
-                        <a:rPr lang="en-US" sz="1200" b="1" dirty="0">
-                          <a:solidFill>
-                            <a:srgbClr val="1A1A1A"/>
-                          </a:solidFill>
-                          <a:latin typeface="Calibri" pitchFamily="34" charset="0"/>
-                          <a:ea typeface="Calibri" pitchFamily="34" charset="-122"/>
-                          <a:cs typeface="Calibri" pitchFamily="34" charset="-120"/>
-                        </a:rPr>
-                        <a:t>5 Use</a:t>
-                      </a:r>
-                      <a:endParaRPr lang="en-US" sz="1200" dirty="0">
-                        <a:latin typeface="Calibri" charset="0"/>
-                        <a:ea typeface="Calibri" charset="0"/>
-                        <a:cs typeface="Calibri" charset="0"/>
-                      </a:endParaRPr>
-                    </a:p>
-                  </a:txBody>
-                  <a:tcPr marL="54864" marR="54864" marT="54864" marB="54864" anchor="t">
-                    <a:lnL w="12700" cap="flat" cmpd="sng" algn="ctr">
-                      <a:solidFill>
-                        <a:srgbClr val="FFFFFF"/>
-                      </a:solidFill>
-                      <a:prstDash val="solid"/>
-                      <a:round/>
-                      <a:headEnd type="none" w="med" len="med"/>
-                      <a:tailEnd type="none" w="med" len="med"/>
-                    </a:lnL>
-                    <a:lnR w="12700" cap="flat" cmpd="sng" algn="ctr">
-                      <a:solidFill>
-                        <a:srgbClr val="FFFFFF"/>
-                      </a:solidFill>
-                      <a:prstDash val="solid"/>
-                      <a:round/>
-                      <a:headEnd type="none" w="med" len="med"/>
-                      <a:tailEnd type="none" w="med" len="med"/>
-                    </a:lnR>
-                    <a:lnT w="12700" cap="flat" cmpd="sng" algn="ctr">
-                      <a:solidFill>
-                        <a:srgbClr val="FFFFFF"/>
-                      </a:solidFill>
-                      <a:prstDash val="solid"/>
-                      <a:round/>
-                      <a:headEnd type="none" w="med" len="med"/>
-                      <a:tailEnd type="none" w="med" len="med"/>
-                    </a:lnT>
-                    <a:lnB w="12700" cap="flat" cmpd="sng" algn="ctr">
-                      <a:solidFill>
-                        <a:srgbClr val="FFFFFF"/>
-                      </a:solidFill>
-                      <a:prstDash val="solid"/>
-                      <a:round/>
-                      <a:headEnd type="none" w="med" len="med"/>
-                      <a:tailEnd type="none" w="med" len="med"/>
-                    </a:lnB>
-                    <a:solidFill>
-                      <a:srgbClr val="C6DCFF"/>
-                    </a:solidFill>
-                  </a:tcPr>
-                </a:tc>
-                <a:tc>
-                  <a:txBody>
-                    <a:bodyPr/>
-                    <a:lstStyle/>
-                    <a:p>
-                      <a:pPr indent="0" marL="0">
-                        <a:buNone/>
-                      </a:pPr>
-                      <a:r>
-                        <a:rPr lang="en-US" sz="1200" dirty="0">
-                          <a:solidFill>
-                            <a:srgbClr val="1A1A1A"/>
-                          </a:solidFill>
-                          <a:latin typeface="Calibri" pitchFamily="34" charset="0"/>
-                          <a:ea typeface="Calibri" pitchFamily="34" charset="-122"/>
-                          <a:cs typeface="Calibri" pitchFamily="34" charset="-120"/>
-                        </a:rPr>
-                        <a:t>CMACs, coordinators, Infrastructure management</a:t>
-                      </a:r>
-                      <a:endParaRPr lang="en-US" sz="1200" dirty="0">
-                        <a:latin typeface="Calibri" charset="0"/>
-                        <a:ea typeface="Calibri" charset="0"/>
-                        <a:cs typeface="Calibri" charset="0"/>
-                      </a:endParaRPr>
-                    </a:p>
-                  </a:txBody>
-                  <a:tcPr marL="54864" marR="54864" marT="54864" marB="54864" anchor="t">
-                    <a:lnL w="12700" cap="flat" cmpd="sng" algn="ctr">
-                      <a:solidFill>
-                        <a:srgbClr val="FFFFFF"/>
-                      </a:solidFill>
-                      <a:prstDash val="solid"/>
-                      <a:round/>
-                      <a:headEnd type="none" w="med" len="med"/>
-                      <a:tailEnd type="none" w="med" len="med"/>
-                    </a:lnL>
-                    <a:lnR w="12700" cap="flat" cmpd="sng" algn="ctr">
-                      <a:solidFill>
-                        <a:srgbClr val="FFFFFF"/>
-                      </a:solidFill>
-                      <a:prstDash val="solid"/>
-                      <a:round/>
-                      <a:headEnd type="none" w="med" len="med"/>
-                      <a:tailEnd type="none" w="med" len="med"/>
-                    </a:lnR>
-                    <a:lnT w="12700" cap="flat" cmpd="sng" algn="ctr">
-                      <a:solidFill>
-                        <a:srgbClr val="FFFFFF"/>
-                      </a:solidFill>
-                      <a:prstDash val="solid"/>
-                      <a:round/>
-                      <a:headEnd type="none" w="med" len="med"/>
-                      <a:tailEnd type="none" w="med" len="med"/>
-                    </a:lnT>
-                    <a:lnB w="12700" cap="flat" cmpd="sng" algn="ctr">
-                      <a:solidFill>
-                        <a:srgbClr val="FFFFFF"/>
-                      </a:solidFill>
-                      <a:prstDash val="solid"/>
-                      <a:round/>
-                      <a:headEnd type="none" w="med" len="med"/>
-                      <a:tailEnd type="none" w="med" len="med"/>
-                    </a:lnB>
-                    <a:solidFill>
-                      <a:srgbClr val="F4F7F7"/>
-                    </a:solidFill>
-                  </a:tcPr>
-                </a:tc>
-                <a:tc>
-                  <a:txBody>
-                    <a:bodyPr/>
-                    <a:lstStyle/>
-                    <a:p>
-                      <a:pPr indent="0" marL="0">
-                        <a:buNone/>
-                      </a:pPr>
-                      <a:r>
-                        <a:rPr lang="en-US" sz="1200" dirty="0">
-                          <a:solidFill>
-                            <a:srgbClr val="1A1A1A"/>
-                          </a:solidFill>
-                          <a:latin typeface="Calibri" pitchFamily="34" charset="0"/>
-                          <a:ea typeface="Calibri" pitchFamily="34" charset="-122"/>
-                          <a:cs typeface="Calibri" pitchFamily="34" charset="-120"/>
-                        </a:rPr>
-                        <a:t>Product views (silver); reports (gold). M: failures retried and shown</a:t>
-                      </a:r>
-                      <a:endParaRPr lang="en-US" sz="1200" dirty="0">
-                        <a:latin typeface="Calibri" charset="0"/>
-                        <a:ea typeface="Calibri" charset="0"/>
-                        <a:cs typeface="Calibri" charset="0"/>
-                      </a:endParaRPr>
-                    </a:p>
-                  </a:txBody>
-                  <a:tcPr marL="54864" marR="54864" marT="54864" marB="54864" anchor="t">
-                    <a:lnL w="12700" cap="flat" cmpd="sng" algn="ctr">
-                      <a:solidFill>
-                        <a:srgbClr val="FFFFFF"/>
-                      </a:solidFill>
-                      <a:prstDash val="solid"/>
-                      <a:round/>
-                      <a:headEnd type="none" w="med" len="med"/>
-                      <a:tailEnd type="none" w="med" len="med"/>
-                    </a:lnL>
-                    <a:lnR w="12700" cap="flat" cmpd="sng" algn="ctr">
-                      <a:solidFill>
-                        <a:srgbClr val="FFFFFF"/>
-                      </a:solidFill>
-                      <a:prstDash val="solid"/>
-                      <a:round/>
-                      <a:headEnd type="none" w="med" len="med"/>
-                      <a:tailEnd type="none" w="med" len="med"/>
-                    </a:lnR>
-                    <a:lnT w="12700" cap="flat" cmpd="sng" algn="ctr">
-                      <a:solidFill>
-                        <a:srgbClr val="FFFFFF"/>
-                      </a:solidFill>
-                      <a:prstDash val="solid"/>
-                      <a:round/>
-                      <a:headEnd type="none" w="med" len="med"/>
-                      <a:tailEnd type="none" w="med" len="med"/>
-                    </a:lnT>
-                    <a:lnB w="12700" cap="flat" cmpd="sng" algn="ctr">
-                      <a:solidFill>
-                        <a:srgbClr val="FFFFFF"/>
-                      </a:solidFill>
-                      <a:prstDash val="solid"/>
-                      <a:round/>
-                      <a:headEnd type="none" w="med" len="med"/>
-                      <a:tailEnd type="none" w="med" len="med"/>
-                    </a:lnB>
-                    <a:solidFill>
-                      <a:srgbClr val="F4F7F7"/>
-                    </a:solidFill>
-                  </a:tcPr>
-                </a:tc>
-                <a:tc>
-                  <a:txBody>
-                    <a:bodyPr/>
-                    <a:lstStyle/>
-                    <a:p>
-                      <a:pPr indent="0" marL="0">
-                        <a:buNone/>
-                      </a:pPr>
-                      <a:r>
-                        <a:rPr lang="en-US" sz="1200" dirty="0">
-                          <a:solidFill>
-                            <a:srgbClr val="1A1A1A"/>
-                          </a:solidFill>
-                          <a:latin typeface="Calibri" pitchFamily="34" charset="0"/>
-                          <a:ea typeface="Calibri" pitchFamily="34" charset="-122"/>
-                          <a:cs typeface="Calibri" pitchFamily="34" charset="-120"/>
-                        </a:rPr>
-                        <a:t>A CMAC sees only their own requests</a:t>
-                      </a:r>
-                      <a:endParaRPr lang="en-US" sz="1200" dirty="0">
-                        <a:latin typeface="Calibri" charset="0"/>
-                        <a:ea typeface="Calibri" charset="0"/>
-                        <a:cs typeface="Calibri" charset="0"/>
-                      </a:endParaRPr>
-                    </a:p>
-                  </a:txBody>
-                  <a:tcPr marL="54864" marR="54864" marT="54864" marB="54864" anchor="t">
-                    <a:lnL w="12700" cap="flat" cmpd="sng" algn="ctr">
-                      <a:solidFill>
-                        <a:srgbClr val="FFFFFF"/>
-                      </a:solidFill>
-                      <a:prstDash val="solid"/>
-                      <a:round/>
-                      <a:headEnd type="none" w="med" len="med"/>
-                      <a:tailEnd type="none" w="med" len="med"/>
-                    </a:lnL>
-                    <a:lnR w="12700" cap="flat" cmpd="sng" algn="ctr">
-                      <a:solidFill>
-                        <a:srgbClr val="FFFFFF"/>
-                      </a:solidFill>
-                      <a:prstDash val="solid"/>
-                      <a:round/>
-                      <a:headEnd type="none" w="med" len="med"/>
-                      <a:tailEnd type="none" w="med" len="med"/>
-                    </a:lnR>
-                    <a:lnT w="12700" cap="flat" cmpd="sng" algn="ctr">
-                      <a:solidFill>
-                        <a:srgbClr val="FFFFFF"/>
-                      </a:solidFill>
-                      <a:prstDash val="solid"/>
-                      <a:round/>
-                      <a:headEnd type="none" w="med" len="med"/>
-                      <a:tailEnd type="none" w="med" len="med"/>
-                    </a:lnT>
-                    <a:lnB w="12700" cap="flat" cmpd="sng" algn="ctr">
-                      <a:solidFill>
-                        <a:srgbClr val="FFFFFF"/>
-                      </a:solidFill>
-                      <a:prstDash val="solid"/>
-                      <a:round/>
-                      <a:headEnd type="none" w="med" len="med"/>
-                      <a:tailEnd type="none" w="med" len="med"/>
-                    </a:lnB>
-                    <a:solidFill>
-                      <a:srgbClr val="F4F7F7"/>
-                    </a:solidFill>
-                  </a:tcPr>
-                </a:tc>
-              </a:tr>
-            </a:tbl>
-          </a:graphicData>
-        </a:graphic>
-      </p:graphicFrame>
-      <p:sp>
-        <p:nvSpPr>
-          <p:cNvPr id="5" name="clean"/>
+      <p:sp>
+        <p:nvSpPr>
+          <p:cNvPr id="4" name="Text 2"/>
+          <p:cNvSpPr txBox="1"/>
+          <p:nvPr/>
+        </p:nvSpPr>
+        <p:spPr>
+          <a:xfrm>
+            <a:off x="548640" y="1115568"/>
+            <a:ext cx="1783080" cy="310896"/>
+          </a:xfrm>
+          <a:prstGeom prst="rect">
+            <a:avLst/>
+          </a:prstGeom>
+          <a:noFill/>
+          <a:ln/>
+        </p:spPr>
+        <p:txBody>
+          <a:bodyPr wrap="square" lIns="1016" tIns="1016" rIns="1016" bIns="1016" rtlCol="0" anchor="b"/>
+          <a:lstStyle/>
+          <a:p>
+            <a:pPr indent="0" marL="0">
+              <a:buNone/>
+            </a:pPr>
+            <a:r>
+              <a:rPr lang="en-US" sz="1200" b="1" dirty="0">
+                <a:solidFill>
+                  <a:schemeClr val="accent1"/>
+                </a:solidFill>
+                <a:latin typeface="Calibri" pitchFamily="34" charset="0"/>
+                <a:ea typeface="Calibri" pitchFamily="34" charset="-122"/>
+                <a:cs typeface="Calibri" pitchFamily="34" charset="-120"/>
+              </a:rPr>
+              <a:t>Hop</a:t>
+            </a:r>
+            <a:endParaRPr lang="en-US" sz="1200" dirty="0"/>
+          </a:p>
+        </p:txBody>
+      </p:sp>
+      <p:sp>
+        <p:nvSpPr>
+          <p:cNvPr id="5" name="Text 3"/>
+          <p:cNvSpPr txBox="1"/>
+          <p:nvPr/>
+        </p:nvSpPr>
+        <p:spPr>
+          <a:xfrm>
+            <a:off x="2377440" y="1115568"/>
+            <a:ext cx="3154680" cy="310896"/>
+          </a:xfrm>
+          <a:prstGeom prst="rect">
+            <a:avLst/>
+          </a:prstGeom>
+          <a:noFill/>
+          <a:ln/>
+        </p:spPr>
+        <p:txBody>
+          <a:bodyPr wrap="square" lIns="1016" tIns="1016" rIns="1016" bIns="1016" rtlCol="0" anchor="b"/>
+          <a:lstStyle/>
+          <a:p>
+            <a:pPr indent="0" marL="0">
+              <a:buNone/>
+            </a:pPr>
+            <a:r>
+              <a:rPr lang="en-US" sz="1200" b="1" dirty="0">
+                <a:solidFill>
+                  <a:schemeClr val="accent1"/>
+                </a:solidFill>
+                <a:latin typeface="Calibri" pitchFamily="34" charset="0"/>
+                <a:ea typeface="Calibri" pitchFamily="34" charset="-122"/>
+                <a:cs typeface="Calibri" pitchFamily="34" charset="-120"/>
+              </a:rPr>
+              <a:t>What moves</a:t>
+            </a:r>
+            <a:endParaRPr lang="en-US" sz="1200" dirty="0"/>
+          </a:p>
+        </p:txBody>
+      </p:sp>
+      <p:sp>
+        <p:nvSpPr>
+          <p:cNvPr id="6" name="Text 4"/>
+          <p:cNvSpPr txBox="1"/>
+          <p:nvPr/>
+        </p:nvSpPr>
+        <p:spPr>
+          <a:xfrm>
+            <a:off x="5577840" y="1115568"/>
+            <a:ext cx="1463040" cy="310896"/>
+          </a:xfrm>
+          <a:prstGeom prst="rect">
+            <a:avLst/>
+          </a:prstGeom>
+          <a:noFill/>
+          <a:ln/>
+        </p:spPr>
+        <p:txBody>
+          <a:bodyPr wrap="square" lIns="1016" tIns="1016" rIns="1016" bIns="1016" rtlCol="0" anchor="b"/>
+          <a:lstStyle/>
+          <a:p>
+            <a:pPr indent="0" marL="0">
+              <a:buNone/>
+            </a:pPr>
+            <a:r>
+              <a:rPr lang="en-US" sz="1200" b="1" dirty="0">
+                <a:solidFill>
+                  <a:schemeClr val="accent1"/>
+                </a:solidFill>
+                <a:latin typeface="Calibri" pitchFamily="34" charset="0"/>
+                <a:ea typeface="Calibri" pitchFamily="34" charset="-122"/>
+                <a:cs typeface="Calibri" pitchFamily="34" charset="-120"/>
+              </a:rPr>
+              <a:t>Entered by</a:t>
+            </a:r>
+            <a:endParaRPr lang="en-US" sz="1200" dirty="0"/>
+          </a:p>
+        </p:txBody>
+      </p:sp>
+      <p:sp>
+        <p:nvSpPr>
+          <p:cNvPr id="7" name="Text 5"/>
+          <p:cNvSpPr txBox="1"/>
+          <p:nvPr/>
+        </p:nvSpPr>
+        <p:spPr>
+          <a:xfrm>
+            <a:off x="7086600" y="1115568"/>
+            <a:ext cx="1828800" cy="310896"/>
+          </a:xfrm>
+          <a:prstGeom prst="rect">
+            <a:avLst/>
+          </a:prstGeom>
+          <a:noFill/>
+          <a:ln/>
+        </p:spPr>
+        <p:txBody>
+          <a:bodyPr wrap="square" lIns="1016" tIns="1016" rIns="1016" bIns="1016" rtlCol="0" anchor="b"/>
+          <a:lstStyle/>
+          <a:p>
+            <a:pPr indent="0" marL="0">
+              <a:buNone/>
+            </a:pPr>
+            <a:r>
+              <a:rPr lang="en-US" sz="1200" b="1" dirty="0">
+                <a:solidFill>
+                  <a:schemeClr val="accent1"/>
+                </a:solidFill>
+                <a:latin typeface="Calibri" pitchFamily="34" charset="0"/>
+                <a:ea typeface="Calibri" pitchFamily="34" charset="-122"/>
+                <a:cs typeface="Calibri" pitchFamily="34" charset="-120"/>
+              </a:rPr>
+              <a:t>Accountable</a:t>
+            </a:r>
+            <a:endParaRPr lang="en-US" sz="1200" dirty="0"/>
+          </a:p>
+        </p:txBody>
+      </p:sp>
+      <p:sp>
+        <p:nvSpPr>
+          <p:cNvPr id="8" name="hop0"/>
           <p:cNvSpPr/>
           <p:nvPr/>
         </p:nvSpPr>
         <p:spPr>
           <a:xfrm>
-            <a:off x="8732520" y="1188720"/>
-            <a:ext cx="2880360" cy="4983480"/>
+            <a:off x="548640" y="1481328"/>
+            <a:ext cx="1783080" cy="713232"/>
           </a:xfrm>
           <a:prstGeom prst="roundRect">
             <a:avLst>
-              <a:gd name="adj" fmla="val 2540"/>
+              <a:gd name="adj" fmla="val 10256"/>
+            </a:avLst>
+          </a:prstGeom>
+          <a:solidFill>
+            <a:srgbClr val="C6DCFF"/>
+          </a:solidFill>
+          <a:ln/>
+        </p:spPr>
+      </p:sp>
+      <p:sp>
+        <p:nvSpPr>
+          <p:cNvPr id="9" name="Text 7"/>
+          <p:cNvSpPr txBox="1"/>
+          <p:nvPr/>
+        </p:nvSpPr>
+        <p:spPr>
+          <a:xfrm>
+            <a:off x="594360" y="1481328"/>
+            <a:ext cx="1691640" cy="713232"/>
+          </a:xfrm>
+          <a:prstGeom prst="rect">
+            <a:avLst/>
+          </a:prstGeom>
+          <a:noFill/>
+          <a:ln/>
+        </p:spPr>
+        <p:txBody>
+          <a:bodyPr wrap="square" lIns="1016" tIns="1016" rIns="1016" bIns="1016" rtlCol="0" anchor="ctr"/>
+          <a:lstStyle/>
+          <a:p>
+            <a:pPr indent="0" marL="0">
+              <a:buNone/>
+            </a:pPr>
+            <a:r>
+              <a:rPr lang="en-US" sz="1300" b="1" dirty="0">
+                <a:solidFill>
+                  <a:schemeClr val="tx1"/>
+                </a:solidFill>
+                <a:latin typeface="Calibri" pitchFamily="34" charset="0"/>
+                <a:ea typeface="Calibri" pitchFamily="34" charset="-122"/>
+                <a:cs typeface="Calibri" pitchFamily="34" charset="-120"/>
+              </a:rPr>
+              <a:t>1  Need is born</a:t>
+            </a:r>
+            <a:endParaRPr lang="en-US" sz="1300" dirty="0"/>
+          </a:p>
+        </p:txBody>
+      </p:sp>
+      <p:sp>
+        <p:nvSpPr>
+          <p:cNvPr id="10" name="moves0"/>
+          <p:cNvSpPr/>
+          <p:nvPr/>
+        </p:nvSpPr>
+        <p:spPr>
+          <a:xfrm>
+            <a:off x="2377440" y="1481328"/>
+            <a:ext cx="3154680" cy="713232"/>
+          </a:xfrm>
+          <a:prstGeom prst="roundRect">
+            <a:avLst>
+              <a:gd name="adj" fmla="val 10256"/>
+            </a:avLst>
+          </a:prstGeom>
+          <a:solidFill>
+            <a:srgbClr val="F4F7F7"/>
+          </a:solidFill>
+          <a:ln/>
+        </p:spPr>
+      </p:sp>
+      <p:sp>
+        <p:nvSpPr>
+          <p:cNvPr id="11" name="Text 9"/>
+          <p:cNvSpPr txBox="1"/>
+          <p:nvPr/>
+        </p:nvSpPr>
+        <p:spPr>
+          <a:xfrm>
+            <a:off x="2414016" y="1481328"/>
+            <a:ext cx="3081528" cy="713232"/>
+          </a:xfrm>
+          <a:prstGeom prst="rect">
+            <a:avLst/>
+          </a:prstGeom>
+          <a:noFill/>
+          <a:ln/>
+        </p:spPr>
+        <p:txBody>
+          <a:bodyPr wrap="square" lIns="1016" tIns="1016" rIns="1016" bIns="1016" rtlCol="0" anchor="ctr"/>
+          <a:lstStyle/>
+          <a:p>
+            <a:pPr indent="0" marL="0">
+              <a:buNone/>
+            </a:pPr>
+            <a:r>
+              <a:rPr lang="en-US" sz="1150" dirty="0">
+                <a:solidFill>
+                  <a:schemeClr val="tx1"/>
+                </a:solidFill>
+                <a:latin typeface="Calibri" pitchFamily="34" charset="0"/>
+                <a:ea typeface="Calibri" pitchFamily="34" charset="-122"/>
+                <a:cs typeface="Calibri" pitchFamily="34" charset="-120"/>
+              </a:rPr>
+              <a:t>Item, quantity, location, reason</a:t>
+            </a:r>
+            <a:endParaRPr lang="en-US" sz="1150" dirty="0"/>
+          </a:p>
+        </p:txBody>
+      </p:sp>
+      <p:sp>
+        <p:nvSpPr>
+          <p:cNvPr id="12" name="entered0"/>
+          <p:cNvSpPr/>
+          <p:nvPr/>
+        </p:nvSpPr>
+        <p:spPr>
+          <a:xfrm>
+            <a:off x="5577840" y="1481328"/>
+            <a:ext cx="1463040" cy="713232"/>
+          </a:xfrm>
+          <a:prstGeom prst="roundRect">
+            <a:avLst>
+              <a:gd name="adj" fmla="val 10256"/>
+            </a:avLst>
+          </a:prstGeom>
+          <a:solidFill>
+            <a:srgbClr val="FFE2B8"/>
+          </a:solidFill>
+          <a:ln/>
+        </p:spPr>
+      </p:sp>
+      <p:sp>
+        <p:nvSpPr>
+          <p:cNvPr id="13" name="Text 11"/>
+          <p:cNvSpPr txBox="1"/>
+          <p:nvPr/>
+        </p:nvSpPr>
+        <p:spPr>
+          <a:xfrm>
+            <a:off x="5614416" y="1481328"/>
+            <a:ext cx="1389888" cy="713232"/>
+          </a:xfrm>
+          <a:prstGeom prst="rect">
+            <a:avLst/>
+          </a:prstGeom>
+          <a:noFill/>
+          <a:ln/>
+        </p:spPr>
+        <p:txBody>
+          <a:bodyPr wrap="square" lIns="1016" tIns="1016" rIns="1016" bIns="1016" rtlCol="0" anchor="ctr"/>
+          <a:lstStyle/>
+          <a:p>
+            <a:pPr indent="0" marL="0">
+              <a:buNone/>
+            </a:pPr>
+            <a:r>
+              <a:rPr lang="en-US" sz="1150" dirty="0">
+                <a:solidFill>
+                  <a:schemeClr val="tx1"/>
+                </a:solidFill>
+                <a:latin typeface="Calibri" pitchFamily="34" charset="0"/>
+                <a:ea typeface="Calibri" pitchFamily="34" charset="-122"/>
+                <a:cs typeface="Calibri" pitchFamily="34" charset="-120"/>
+              </a:rPr>
+              <a:t>Requester, by email, Teams or phone</a:t>
+            </a:r>
+            <a:endParaRPr lang="en-US" sz="1150" dirty="0"/>
+          </a:p>
+        </p:txBody>
+      </p:sp>
+      <p:sp>
+        <p:nvSpPr>
+          <p:cNvPr id="14" name="acct0"/>
+          <p:cNvSpPr/>
+          <p:nvPr/>
+        </p:nvSpPr>
+        <p:spPr>
+          <a:xfrm>
+            <a:off x="7086600" y="1481328"/>
+            <a:ext cx="1828800" cy="713232"/>
+          </a:xfrm>
+          <a:prstGeom prst="roundRect">
+            <a:avLst>
+              <a:gd name="adj" fmla="val 10256"/>
+            </a:avLst>
+          </a:prstGeom>
+          <a:solidFill>
+            <a:srgbClr val="FFE2B8"/>
+          </a:solidFill>
+          <a:ln/>
+        </p:spPr>
+      </p:sp>
+      <p:sp>
+        <p:nvSpPr>
+          <p:cNvPr id="15" name="Text 13"/>
+          <p:cNvSpPr txBox="1"/>
+          <p:nvPr/>
+        </p:nvSpPr>
+        <p:spPr>
+          <a:xfrm>
+            <a:off x="7123176" y="1481328"/>
+            <a:ext cx="1755648" cy="713232"/>
+          </a:xfrm>
+          <a:prstGeom prst="rect">
+            <a:avLst/>
+          </a:prstGeom>
+          <a:noFill/>
+          <a:ln/>
+        </p:spPr>
+        <p:txBody>
+          <a:bodyPr wrap="square" lIns="1016" tIns="1016" rIns="1016" bIns="1016" rtlCol="0" anchor="ctr"/>
+          <a:lstStyle/>
+          <a:p>
+            <a:pPr indent="0" marL="0">
+              <a:buNone/>
+            </a:pPr>
+            <a:r>
+              <a:rPr lang="en-US" sz="1150" dirty="0">
+                <a:solidFill>
+                  <a:schemeClr val="tx1"/>
+                </a:solidFill>
+                <a:latin typeface="Calibri" pitchFamily="34" charset="0"/>
+                <a:ea typeface="Calibri" pitchFamily="34" charset="-122"/>
+                <a:cs typeface="Calibri" pitchFamily="34" charset="-120"/>
+              </a:rPr>
+              <a:t>The requester, for what they state</a:t>
+            </a:r>
+            <a:endParaRPr lang="en-US" sz="1150" dirty="0"/>
+          </a:p>
+        </p:txBody>
+      </p:sp>
+      <p:sp>
+        <p:nvSpPr>
+          <p:cNvPr id="16" name="Shape 14"/>
+          <p:cNvSpPr/>
+          <p:nvPr/>
+        </p:nvSpPr>
+        <p:spPr>
+          <a:xfrm>
+            <a:off x="777240" y="2212848"/>
+            <a:ext cx="182880" cy="164592"/>
+          </a:xfrm>
+          <a:prstGeom prst="downArrow">
+            <a:avLst/>
+          </a:prstGeom>
+          <a:solidFill>
+            <a:srgbClr val="E8A33D"/>
+          </a:solidFill>
+          <a:ln/>
+        </p:spPr>
+      </p:sp>
+      <p:sp>
+        <p:nvSpPr>
+          <p:cNvPr id="17" name="Text 15"/>
+          <p:cNvSpPr txBox="1"/>
+          <p:nvPr/>
+        </p:nvSpPr>
+        <p:spPr>
+          <a:xfrm>
+            <a:off x="1005840" y="2194560"/>
+            <a:ext cx="1371600" cy="201168"/>
+          </a:xfrm>
+          <a:prstGeom prst="rect">
+            <a:avLst/>
+          </a:prstGeom>
+          <a:noFill/>
+          <a:ln/>
+        </p:spPr>
+        <p:txBody>
+          <a:bodyPr wrap="square" lIns="0" tIns="0" rIns="0" bIns="0" rtlCol="0" anchor="ctr"/>
+          <a:lstStyle/>
+          <a:p>
+            <a:pPr indent="0" marL="0">
+              <a:buNone/>
+            </a:pPr>
+            <a:r>
+              <a:rPr lang="en-US" sz="1000" b="1" i="1" dirty="0">
+                <a:solidFill>
+                  <a:schemeClr val="accent1"/>
+                </a:solidFill>
+                <a:latin typeface="Calibri" pitchFamily="34" charset="0"/>
+                <a:ea typeface="Calibri" pitchFamily="34" charset="-122"/>
+                <a:cs typeface="Calibri" pitchFamily="34" charset="-120"/>
+              </a:rPr>
+              <a:t>A  authenticate</a:t>
+            </a:r>
+            <a:endParaRPr lang="en-US" sz="1000" dirty="0"/>
+          </a:p>
+        </p:txBody>
+      </p:sp>
+      <p:sp>
+        <p:nvSpPr>
+          <p:cNvPr id="18" name="hop1"/>
+          <p:cNvSpPr/>
+          <p:nvPr/>
+        </p:nvSpPr>
+        <p:spPr>
+          <a:xfrm>
+            <a:off x="548640" y="2395728"/>
+            <a:ext cx="1783080" cy="713232"/>
+          </a:xfrm>
+          <a:prstGeom prst="roundRect">
+            <a:avLst>
+              <a:gd name="adj" fmla="val 10256"/>
+            </a:avLst>
+          </a:prstGeom>
+          <a:solidFill>
+            <a:srgbClr val="C6DCFF"/>
+          </a:solidFill>
+          <a:ln/>
+        </p:spPr>
+      </p:sp>
+      <p:sp>
+        <p:nvSpPr>
+          <p:cNvPr id="19" name="Text 17"/>
+          <p:cNvSpPr txBox="1"/>
+          <p:nvPr/>
+        </p:nvSpPr>
+        <p:spPr>
+          <a:xfrm>
+            <a:off x="594360" y="2395728"/>
+            <a:ext cx="1691640" cy="713232"/>
+          </a:xfrm>
+          <a:prstGeom prst="rect">
+            <a:avLst/>
+          </a:prstGeom>
+          <a:noFill/>
+          <a:ln/>
+        </p:spPr>
+        <p:txBody>
+          <a:bodyPr wrap="square" lIns="1016" tIns="1016" rIns="1016" bIns="1016" rtlCol="0" anchor="ctr"/>
+          <a:lstStyle/>
+          <a:p>
+            <a:pPr indent="0" marL="0">
+              <a:buNone/>
+            </a:pPr>
+            <a:r>
+              <a:rPr lang="en-US" sz="1300" b="1" dirty="0">
+                <a:solidFill>
+                  <a:schemeClr val="tx1"/>
+                </a:solidFill>
+                <a:latin typeface="Calibri" pitchFamily="34" charset="0"/>
+                <a:ea typeface="Calibri" pitchFamily="34" charset="-122"/>
+                <a:cs typeface="Calibri" pitchFamily="34" charset="-120"/>
+              </a:rPr>
+              <a:t>2  Request is entered</a:t>
+            </a:r>
+            <a:endParaRPr lang="en-US" sz="1300" dirty="0"/>
+          </a:p>
+        </p:txBody>
+      </p:sp>
+      <p:sp>
+        <p:nvSpPr>
+          <p:cNvPr id="20" name="moves1"/>
+          <p:cNvSpPr/>
+          <p:nvPr/>
+        </p:nvSpPr>
+        <p:spPr>
+          <a:xfrm>
+            <a:off x="2377440" y="2395728"/>
+            <a:ext cx="3154680" cy="713232"/>
+          </a:xfrm>
+          <a:prstGeom prst="roundRect">
+            <a:avLst>
+              <a:gd name="adj" fmla="val 10256"/>
+            </a:avLst>
+          </a:prstGeom>
+          <a:solidFill>
+            <a:srgbClr val="F4F7F7"/>
+          </a:solidFill>
+          <a:ln/>
+        </p:spPr>
+      </p:sp>
+      <p:sp>
+        <p:nvSpPr>
+          <p:cNvPr id="21" name="Text 19"/>
+          <p:cNvSpPr txBox="1"/>
+          <p:nvPr/>
+        </p:nvSpPr>
+        <p:spPr>
+          <a:xfrm>
+            <a:off x="2414016" y="2395728"/>
+            <a:ext cx="3081528" cy="713232"/>
+          </a:xfrm>
+          <a:prstGeom prst="rect">
+            <a:avLst/>
+          </a:prstGeom>
+          <a:noFill/>
+          <a:ln/>
+        </p:spPr>
+        <p:txBody>
+          <a:bodyPr wrap="square" lIns="1016" tIns="1016" rIns="1016" bIns="1016" rtlCol="0" anchor="ctr"/>
+          <a:lstStyle/>
+          <a:p>
+            <a:pPr indent="0" marL="0">
+              <a:buNone/>
+            </a:pPr>
+            <a:r>
+              <a:rPr lang="en-US" sz="1150" dirty="0">
+                <a:solidFill>
+                  <a:schemeClr val="tx1"/>
+                </a:solidFill>
+                <a:latin typeface="Calibri" pitchFamily="34" charset="0"/>
+                <a:ea typeface="Calibri" pitchFamily="34" charset="-122"/>
+                <a:cs typeface="Calibri" pitchFamily="34" charset="-120"/>
+              </a:rPr>
+              <a:t>The same details in the guided form, plus type, required date and attachments; requester and building pre-filled from PRISM Core</a:t>
+            </a:r>
+            <a:endParaRPr lang="en-US" sz="1150" dirty="0"/>
+          </a:p>
+        </p:txBody>
+      </p:sp>
+      <p:sp>
+        <p:nvSpPr>
+          <p:cNvPr id="22" name="entered1"/>
+          <p:cNvSpPr/>
+          <p:nvPr/>
+        </p:nvSpPr>
+        <p:spPr>
+          <a:xfrm>
+            <a:off x="5577840" y="2395728"/>
+            <a:ext cx="1463040" cy="713232"/>
+          </a:xfrm>
+          <a:prstGeom prst="roundRect">
+            <a:avLst>
+              <a:gd name="adj" fmla="val 10256"/>
+            </a:avLst>
+          </a:prstGeom>
+          <a:solidFill>
+            <a:srgbClr val="FFE2B8"/>
+          </a:solidFill>
+          <a:ln/>
+        </p:spPr>
+      </p:sp>
+      <p:sp>
+        <p:nvSpPr>
+          <p:cNvPr id="23" name="Text 21"/>
+          <p:cNvSpPr txBox="1"/>
+          <p:nvPr/>
+        </p:nvSpPr>
+        <p:spPr>
+          <a:xfrm>
+            <a:off x="5614416" y="2395728"/>
+            <a:ext cx="1389888" cy="713232"/>
+          </a:xfrm>
+          <a:prstGeom prst="rect">
+            <a:avLst/>
+          </a:prstGeom>
+          <a:noFill/>
+          <a:ln/>
+        </p:spPr>
+        <p:txBody>
+          <a:bodyPr wrap="square" lIns="1016" tIns="1016" rIns="1016" bIns="1016" rtlCol="0" anchor="ctr"/>
+          <a:lstStyle/>
+          <a:p>
+            <a:pPr indent="0" marL="0">
+              <a:buNone/>
+            </a:pPr>
+            <a:r>
+              <a:rPr lang="en-US" sz="1150" dirty="0">
+                <a:solidFill>
+                  <a:schemeClr val="tx1"/>
+                </a:solidFill>
+                <a:latin typeface="Calibri" pitchFamily="34" charset="0"/>
+                <a:ea typeface="Calibri" pitchFamily="34" charset="-122"/>
+                <a:cs typeface="Calibri" pitchFamily="34" charset="-120"/>
+              </a:rPr>
+              <a:t>CMAC</a:t>
+            </a:r>
+            <a:endParaRPr lang="en-US" sz="1150" dirty="0"/>
+          </a:p>
+        </p:txBody>
+      </p:sp>
+      <p:sp>
+        <p:nvSpPr>
+          <p:cNvPr id="24" name="acct1"/>
+          <p:cNvSpPr/>
+          <p:nvPr/>
+        </p:nvSpPr>
+        <p:spPr>
+          <a:xfrm>
+            <a:off x="7086600" y="2395728"/>
+            <a:ext cx="1828800" cy="713232"/>
+          </a:xfrm>
+          <a:prstGeom prst="roundRect">
+            <a:avLst>
+              <a:gd name="adj" fmla="val 10256"/>
+            </a:avLst>
+          </a:prstGeom>
+          <a:solidFill>
+            <a:srgbClr val="FFC6C6"/>
+          </a:solidFill>
+          <a:ln/>
+        </p:spPr>
+      </p:sp>
+      <p:sp>
+        <p:nvSpPr>
+          <p:cNvPr id="25" name="Text 23"/>
+          <p:cNvSpPr txBox="1"/>
+          <p:nvPr/>
+        </p:nvSpPr>
+        <p:spPr>
+          <a:xfrm>
+            <a:off x="7123176" y="2395728"/>
+            <a:ext cx="1755648" cy="713232"/>
+          </a:xfrm>
+          <a:prstGeom prst="rect">
+            <a:avLst/>
+          </a:prstGeom>
+          <a:noFill/>
+          <a:ln/>
+        </p:spPr>
+        <p:txBody>
+          <a:bodyPr wrap="square" lIns="1016" tIns="1016" rIns="1016" bIns="1016" rtlCol="0" anchor="ctr"/>
+          <a:lstStyle/>
+          <a:p>
+            <a:pPr indent="0" marL="0">
+              <a:buNone/>
+            </a:pPr>
+            <a:r>
+              <a:rPr lang="en-US" sz="1150" dirty="0">
+                <a:solidFill>
+                  <a:schemeClr val="tx1"/>
+                </a:solidFill>
+                <a:latin typeface="Calibri" pitchFamily="34" charset="0"/>
+                <a:ea typeface="Calibri" pitchFamily="34" charset="-122"/>
+                <a:cs typeface="Calibri" pitchFamily="34" charset="-120"/>
+              </a:rPr>
+              <a:t>CMAC (Proposed); PRISM Core owner for pre-filled data (Open)</a:t>
+            </a:r>
+            <a:endParaRPr lang="en-US" sz="1150" dirty="0"/>
+          </a:p>
+        </p:txBody>
+      </p:sp>
+      <p:sp>
+        <p:nvSpPr>
+          <p:cNvPr id="26" name="Shape 24"/>
+          <p:cNvSpPr/>
+          <p:nvPr/>
+        </p:nvSpPr>
+        <p:spPr>
+          <a:xfrm>
+            <a:off x="777240" y="3127248"/>
+            <a:ext cx="182880" cy="164592"/>
+          </a:xfrm>
+          <a:prstGeom prst="downArrow">
+            <a:avLst/>
+          </a:prstGeom>
+          <a:solidFill>
+            <a:srgbClr val="E8A33D"/>
+          </a:solidFill>
+          <a:ln/>
+        </p:spPr>
+      </p:sp>
+      <p:sp>
+        <p:nvSpPr>
+          <p:cNvPr id="27" name="Text 25"/>
+          <p:cNvSpPr txBox="1"/>
+          <p:nvPr/>
+        </p:nvSpPr>
+        <p:spPr>
+          <a:xfrm>
+            <a:off x="1005840" y="3108960"/>
+            <a:ext cx="1371600" cy="201168"/>
+          </a:xfrm>
+          <a:prstGeom prst="rect">
+            <a:avLst/>
+          </a:prstGeom>
+          <a:noFill/>
+          <a:ln/>
+        </p:spPr>
+        <p:txBody>
+          <a:bodyPr wrap="square" lIns="0" tIns="0" rIns="0" bIns="0" rtlCol="0" anchor="ctr"/>
+          <a:lstStyle/>
+          <a:p>
+            <a:pPr indent="0" marL="0">
+              <a:buNone/>
+            </a:pPr>
+            <a:r>
+              <a:rPr lang="en-US" sz="1000" b="1" i="1" dirty="0">
+                <a:solidFill>
+                  <a:schemeClr val="accent1"/>
+                </a:solidFill>
+                <a:latin typeface="Calibri" pitchFamily="34" charset="0"/>
+                <a:ea typeface="Calibri" pitchFamily="34" charset="-122"/>
+                <a:cs typeface="Calibri" pitchFamily="34" charset="-120"/>
+              </a:rPr>
+              <a:t>V  validate</a:t>
+            </a:r>
+            <a:endParaRPr lang="en-US" sz="1000" dirty="0"/>
+          </a:p>
+        </p:txBody>
+      </p:sp>
+      <p:sp>
+        <p:nvSpPr>
+          <p:cNvPr id="28" name="hop2"/>
+          <p:cNvSpPr/>
+          <p:nvPr/>
+        </p:nvSpPr>
+        <p:spPr>
+          <a:xfrm>
+            <a:off x="548640" y="3310128"/>
+            <a:ext cx="1783080" cy="713232"/>
+          </a:xfrm>
+          <a:prstGeom prst="roundRect">
+            <a:avLst>
+              <a:gd name="adj" fmla="val 10256"/>
+            </a:avLst>
+          </a:prstGeom>
+          <a:solidFill>
+            <a:srgbClr val="C6DCFF"/>
+          </a:solidFill>
+          <a:ln/>
+        </p:spPr>
+      </p:sp>
+      <p:sp>
+        <p:nvSpPr>
+          <p:cNvPr id="29" name="Text 27"/>
+          <p:cNvSpPr txBox="1"/>
+          <p:nvPr/>
+        </p:nvSpPr>
+        <p:spPr>
+          <a:xfrm>
+            <a:off x="594360" y="3310128"/>
+            <a:ext cx="1691640" cy="713232"/>
+          </a:xfrm>
+          <a:prstGeom prst="rect">
+            <a:avLst/>
+          </a:prstGeom>
+          <a:noFill/>
+          <a:ln/>
+        </p:spPr>
+        <p:txBody>
+          <a:bodyPr wrap="square" lIns="1016" tIns="1016" rIns="1016" bIns="1016" rtlCol="0" anchor="ctr"/>
+          <a:lstStyle/>
+          <a:p>
+            <a:pPr indent="0" marL="0">
+              <a:buNone/>
+            </a:pPr>
+            <a:r>
+              <a:rPr lang="en-US" sz="1300" b="1" dirty="0">
+                <a:solidFill>
+                  <a:schemeClr val="tx1"/>
+                </a:solidFill>
+                <a:latin typeface="Calibri" pitchFamily="34" charset="0"/>
+                <a:ea typeface="Calibri" pitchFamily="34" charset="-122"/>
+                <a:cs typeface="Calibri" pitchFamily="34" charset="-120"/>
+              </a:rPr>
+              <a:t>3  Checked and shaped</a:t>
+            </a:r>
+            <a:endParaRPr lang="en-US" sz="1300" dirty="0"/>
+          </a:p>
+        </p:txBody>
+      </p:sp>
+      <p:sp>
+        <p:nvSpPr>
+          <p:cNvPr id="30" name="moves2"/>
+          <p:cNvSpPr/>
+          <p:nvPr/>
+        </p:nvSpPr>
+        <p:spPr>
+          <a:xfrm>
+            <a:off x="2377440" y="3310128"/>
+            <a:ext cx="3154680" cy="713232"/>
+          </a:xfrm>
+          <a:prstGeom prst="roundRect">
+            <a:avLst>
+              <a:gd name="adj" fmla="val 10256"/>
+            </a:avLst>
+          </a:prstGeom>
+          <a:solidFill>
+            <a:srgbClr val="F4F7F7"/>
+          </a:solidFill>
+          <a:ln/>
+        </p:spPr>
+      </p:sp>
+      <p:sp>
+        <p:nvSpPr>
+          <p:cNvPr id="31" name="Text 29"/>
+          <p:cNvSpPr txBox="1"/>
+          <p:nvPr/>
+        </p:nvSpPr>
+        <p:spPr>
+          <a:xfrm>
+            <a:off x="2414016" y="3310128"/>
+            <a:ext cx="3081528" cy="713232"/>
+          </a:xfrm>
+          <a:prstGeom prst="rect">
+            <a:avLst/>
+          </a:prstGeom>
+          <a:noFill/>
+          <a:ln/>
+        </p:spPr>
+        <p:txBody>
+          <a:bodyPr wrap="square" lIns="1016" tIns="1016" rIns="1016" bIns="1016" rtlCol="0" anchor="ctr"/>
+          <a:lstStyle/>
+          <a:p>
+            <a:pPr indent="0" marL="0">
+              <a:buNone/>
+            </a:pPr>
+            <a:r>
+              <a:rPr lang="en-US" sz="1150" dirty="0">
+                <a:solidFill>
+                  <a:schemeClr val="tx1"/>
+                </a:solidFill>
+                <a:latin typeface="Calibri" pitchFamily="34" charset="0"/>
+                <a:ea typeface="Calibri" pitchFamily="34" charset="-122"/>
+                <a:cs typeface="Calibri" pitchFamily="34" charset="-120"/>
+              </a:rPr>
+              <a:t>Kept as submitted (bronze); one Work Order ID, standard status, required fields and duplicates checked (silver)</a:t>
+            </a:r>
+            <a:endParaRPr lang="en-US" sz="1150" dirty="0"/>
+          </a:p>
+        </p:txBody>
+      </p:sp>
+      <p:sp>
+        <p:nvSpPr>
+          <p:cNvPr id="32" name="entered2"/>
+          <p:cNvSpPr/>
+          <p:nvPr/>
+        </p:nvSpPr>
+        <p:spPr>
+          <a:xfrm>
+            <a:off x="5577840" y="3310128"/>
+            <a:ext cx="1463040" cy="713232"/>
+          </a:xfrm>
+          <a:prstGeom prst="roundRect">
+            <a:avLst>
+              <a:gd name="adj" fmla="val 10256"/>
+            </a:avLst>
+          </a:prstGeom>
+          <a:solidFill>
+            <a:srgbClr val="FFE2B8"/>
+          </a:solidFill>
+          <a:ln/>
+        </p:spPr>
+      </p:sp>
+      <p:sp>
+        <p:nvSpPr>
+          <p:cNvPr id="33" name="Text 31"/>
+          <p:cNvSpPr txBox="1"/>
+          <p:nvPr/>
+        </p:nvSpPr>
+        <p:spPr>
+          <a:xfrm>
+            <a:off x="5614416" y="3310128"/>
+            <a:ext cx="1389888" cy="713232"/>
+          </a:xfrm>
+          <a:prstGeom prst="rect">
+            <a:avLst/>
+          </a:prstGeom>
+          <a:noFill/>
+          <a:ln/>
+        </p:spPr>
+        <p:txBody>
+          <a:bodyPr wrap="square" lIns="1016" tIns="1016" rIns="1016" bIns="1016" rtlCol="0" anchor="ctr"/>
+          <a:lstStyle/>
+          <a:p>
+            <a:pPr indent="0" marL="0">
+              <a:buNone/>
+            </a:pPr>
+            <a:r>
+              <a:rPr lang="en-US" sz="1150" dirty="0">
+                <a:solidFill>
+                  <a:schemeClr val="tx1"/>
+                </a:solidFill>
+                <a:latin typeface="Calibri" pitchFamily="34" charset="0"/>
+                <a:ea typeface="Calibri" pitchFamily="34" charset="-122"/>
+                <a:cs typeface="Calibri" pitchFamily="34" charset="-120"/>
+              </a:rPr>
+              <a:t>Coordinator at review</a:t>
+            </a:r>
+            <a:endParaRPr lang="en-US" sz="1150" dirty="0"/>
+          </a:p>
+        </p:txBody>
+      </p:sp>
+      <p:sp>
+        <p:nvSpPr>
+          <p:cNvPr id="34" name="acct2"/>
+          <p:cNvSpPr/>
+          <p:nvPr/>
+        </p:nvSpPr>
+        <p:spPr>
+          <a:xfrm>
+            <a:off x="7086600" y="3310128"/>
+            <a:ext cx="1828800" cy="713232"/>
+          </a:xfrm>
+          <a:prstGeom prst="roundRect">
+            <a:avLst>
+              <a:gd name="adj" fmla="val 10256"/>
+            </a:avLst>
+          </a:prstGeom>
+          <a:solidFill>
+            <a:srgbClr val="FFC6C6"/>
+          </a:solidFill>
+          <a:ln/>
+        </p:spPr>
+      </p:sp>
+      <p:sp>
+        <p:nvSpPr>
+          <p:cNvPr id="35" name="Text 33"/>
+          <p:cNvSpPr txBox="1"/>
+          <p:nvPr/>
+        </p:nvSpPr>
+        <p:spPr>
+          <a:xfrm>
+            <a:off x="7123176" y="3310128"/>
+            <a:ext cx="1755648" cy="713232"/>
+          </a:xfrm>
+          <a:prstGeom prst="rect">
+            <a:avLst/>
+          </a:prstGeom>
+          <a:noFill/>
+          <a:ln/>
+        </p:spPr>
+        <p:txBody>
+          <a:bodyPr wrap="square" lIns="1016" tIns="1016" rIns="1016" bIns="1016" rtlCol="0" anchor="ctr"/>
+          <a:lstStyle/>
+          <a:p>
+            <a:pPr indent="0" marL="0">
+              <a:buNone/>
+            </a:pPr>
+            <a:r>
+              <a:rPr lang="en-US" sz="1150" dirty="0">
+                <a:solidFill>
+                  <a:schemeClr val="tx1"/>
+                </a:solidFill>
+                <a:latin typeface="Calibri" pitchFamily="34" charset="0"/>
+                <a:ea typeface="Calibri" pitchFamily="34" charset="-122"/>
+                <a:cs typeface="Calibri" pitchFamily="34" charset="-120"/>
+              </a:rPr>
+              <a:t>Rules owner: Open (Proposed: Furniture Request Coordinator)</a:t>
+            </a:r>
+            <a:endParaRPr lang="en-US" sz="1150" dirty="0"/>
+          </a:p>
+        </p:txBody>
+      </p:sp>
+      <p:sp>
+        <p:nvSpPr>
+          <p:cNvPr id="36" name="Shape 34"/>
+          <p:cNvSpPr/>
+          <p:nvPr/>
+        </p:nvSpPr>
+        <p:spPr>
+          <a:xfrm>
+            <a:off x="777240" y="4041648"/>
+            <a:ext cx="182880" cy="164592"/>
+          </a:xfrm>
+          <a:prstGeom prst="downArrow">
+            <a:avLst/>
+          </a:prstGeom>
+          <a:solidFill>
+            <a:srgbClr val="E8A33D"/>
+          </a:solidFill>
+          <a:ln/>
+        </p:spPr>
+      </p:sp>
+      <p:sp>
+        <p:nvSpPr>
+          <p:cNvPr id="37" name="Text 35"/>
+          <p:cNvSpPr txBox="1"/>
+          <p:nvPr/>
+        </p:nvSpPr>
+        <p:spPr>
+          <a:xfrm>
+            <a:off x="1005840" y="4023360"/>
+            <a:ext cx="1371600" cy="201168"/>
+          </a:xfrm>
+          <a:prstGeom prst="rect">
+            <a:avLst/>
+          </a:prstGeom>
+          <a:noFill/>
+          <a:ln/>
+        </p:spPr>
+        <p:txBody>
+          <a:bodyPr wrap="square" lIns="0" tIns="0" rIns="0" bIns="0" rtlCol="0" anchor="ctr"/>
+          <a:lstStyle/>
+          <a:p>
+            <a:pPr indent="0" marL="0">
+              <a:buNone/>
+            </a:pPr>
+            <a:r>
+              <a:rPr lang="en-US" sz="1000" b="1" i="1" dirty="0">
+                <a:solidFill>
+                  <a:schemeClr val="accent1"/>
+                </a:solidFill>
+                <a:latin typeface="Calibri" pitchFamily="34" charset="0"/>
+                <a:ea typeface="Calibri" pitchFamily="34" charset="-122"/>
+                <a:cs typeface="Calibri" pitchFamily="34" charset="-120"/>
+              </a:rPr>
+              <a:t>F  monitor</a:t>
+            </a:r>
+            <a:endParaRPr lang="en-US" sz="1000" dirty="0"/>
+          </a:p>
+        </p:txBody>
+      </p:sp>
+      <p:sp>
+        <p:nvSpPr>
+          <p:cNvPr id="38" name="hop3"/>
+          <p:cNvSpPr/>
+          <p:nvPr/>
+        </p:nvSpPr>
+        <p:spPr>
+          <a:xfrm>
+            <a:off x="548640" y="4224528"/>
+            <a:ext cx="1783080" cy="713232"/>
+          </a:xfrm>
+          <a:prstGeom prst="roundRect">
+            <a:avLst>
+              <a:gd name="adj" fmla="val 10256"/>
+            </a:avLst>
+          </a:prstGeom>
+          <a:solidFill>
+            <a:srgbClr val="C6DCFF"/>
+          </a:solidFill>
+          <a:ln/>
+        </p:spPr>
+      </p:sp>
+      <p:sp>
+        <p:nvSpPr>
+          <p:cNvPr id="39" name="Text 37"/>
+          <p:cNvSpPr txBox="1"/>
+          <p:nvPr/>
+        </p:nvSpPr>
+        <p:spPr>
+          <a:xfrm>
+            <a:off x="594360" y="4224528"/>
+            <a:ext cx="1691640" cy="713232"/>
+          </a:xfrm>
+          <a:prstGeom prst="rect">
+            <a:avLst/>
+          </a:prstGeom>
+          <a:noFill/>
+          <a:ln/>
+        </p:spPr>
+        <p:txBody>
+          <a:bodyPr wrap="square" lIns="1016" tIns="1016" rIns="1016" bIns="1016" rtlCol="0" anchor="ctr"/>
+          <a:lstStyle/>
+          <a:p>
+            <a:pPr indent="0" marL="0">
+              <a:buNone/>
+            </a:pPr>
+            <a:r>
+              <a:rPr lang="en-US" sz="1300" b="1" dirty="0">
+                <a:solidFill>
+                  <a:schemeClr val="tx1"/>
+                </a:solidFill>
+                <a:latin typeface="Calibri" pitchFamily="34" charset="0"/>
+                <a:ea typeface="Calibri" pitchFamily="34" charset="-122"/>
+                <a:cs typeface="Calibri" pitchFamily="34" charset="-120"/>
+              </a:rPr>
+              <a:t>4  Stored as one record</a:t>
+            </a:r>
+            <a:endParaRPr lang="en-US" sz="1300" dirty="0"/>
+          </a:p>
+        </p:txBody>
+      </p:sp>
+      <p:sp>
+        <p:nvSpPr>
+          <p:cNvPr id="40" name="moves3"/>
+          <p:cNvSpPr/>
+          <p:nvPr/>
+        </p:nvSpPr>
+        <p:spPr>
+          <a:xfrm>
+            <a:off x="2377440" y="4224528"/>
+            <a:ext cx="3154680" cy="713232"/>
+          </a:xfrm>
+          <a:prstGeom prst="roundRect">
+            <a:avLst>
+              <a:gd name="adj" fmla="val 10256"/>
+            </a:avLst>
+          </a:prstGeom>
+          <a:solidFill>
+            <a:srgbClr val="F4F7F7"/>
+          </a:solidFill>
+          <a:ln/>
+        </p:spPr>
+      </p:sp>
+      <p:sp>
+        <p:nvSpPr>
+          <p:cNvPr id="41" name="Text 39"/>
+          <p:cNvSpPr txBox="1"/>
+          <p:nvPr/>
+        </p:nvSpPr>
+        <p:spPr>
+          <a:xfrm>
+            <a:off x="2414016" y="4224528"/>
+            <a:ext cx="3081528" cy="713232"/>
+          </a:xfrm>
+          <a:prstGeom prst="rect">
+            <a:avLst/>
+          </a:prstGeom>
+          <a:noFill/>
+          <a:ln/>
+        </p:spPr>
+        <p:txBody>
+          <a:bodyPr wrap="square" lIns="1016" tIns="1016" rIns="1016" bIns="1016" rtlCol="0" anchor="ctr"/>
+          <a:lstStyle/>
+          <a:p>
+            <a:pPr indent="0" marL="0">
+              <a:buNone/>
+            </a:pPr>
+            <a:r>
+              <a:rPr lang="en-US" sz="1150" dirty="0">
+                <a:solidFill>
+                  <a:schemeClr val="tx1"/>
+                </a:solidFill>
+                <a:latin typeface="Calibri" pitchFamily="34" charset="0"/>
+                <a:ea typeface="Calibri" pitchFamily="34" charset="-122"/>
+                <a:cs typeface="Calibri" pitchFamily="34" charset="-120"/>
+              </a:rPr>
+              <a:t>Every change time-stamped and attributed; history never overwritten</a:t>
+            </a:r>
+            <a:endParaRPr lang="en-US" sz="1150" dirty="0"/>
+          </a:p>
+        </p:txBody>
+      </p:sp>
+      <p:sp>
+        <p:nvSpPr>
+          <p:cNvPr id="42" name="entered3"/>
+          <p:cNvSpPr/>
+          <p:nvPr/>
+        </p:nvSpPr>
+        <p:spPr>
+          <a:xfrm>
+            <a:off x="5577840" y="4224528"/>
+            <a:ext cx="1463040" cy="713232"/>
+          </a:xfrm>
+          <a:prstGeom prst="roundRect">
+            <a:avLst>
+              <a:gd name="adj" fmla="val 10256"/>
+            </a:avLst>
+          </a:prstGeom>
+          <a:solidFill>
+            <a:srgbClr val="FFE2B8"/>
+          </a:solidFill>
+          <a:ln/>
+        </p:spPr>
+      </p:sp>
+      <p:sp>
+        <p:nvSpPr>
+          <p:cNvPr id="43" name="Text 41"/>
+          <p:cNvSpPr txBox="1"/>
+          <p:nvPr/>
+        </p:nvSpPr>
+        <p:spPr>
+          <a:xfrm>
+            <a:off x="5614416" y="4224528"/>
+            <a:ext cx="1389888" cy="713232"/>
+          </a:xfrm>
+          <a:prstGeom prst="rect">
+            <a:avLst/>
+          </a:prstGeom>
+          <a:noFill/>
+          <a:ln/>
+        </p:spPr>
+        <p:txBody>
+          <a:bodyPr wrap="square" lIns="1016" tIns="1016" rIns="1016" bIns="1016" rtlCol="0" anchor="ctr"/>
+          <a:lstStyle/>
+          <a:p>
+            <a:pPr indent="0" marL="0">
+              <a:buNone/>
+            </a:pPr>
+            <a:r>
+              <a:rPr lang="en-US" sz="1150" dirty="0">
+                <a:solidFill>
+                  <a:schemeClr val="tx1"/>
+                </a:solidFill>
+                <a:latin typeface="Calibri" pitchFamily="34" charset="0"/>
+                <a:ea typeface="Calibri" pitchFamily="34" charset="-122"/>
+                <a:cs typeface="Calibri" pitchFamily="34" charset="-120"/>
+              </a:rPr>
+              <a:t>Written by the stages above</a:t>
+            </a:r>
+            <a:endParaRPr lang="en-US" sz="1150" dirty="0"/>
+          </a:p>
+        </p:txBody>
+      </p:sp>
+      <p:sp>
+        <p:nvSpPr>
+          <p:cNvPr id="44" name="acct3"/>
+          <p:cNvSpPr/>
+          <p:nvPr/>
+        </p:nvSpPr>
+        <p:spPr>
+          <a:xfrm>
+            <a:off x="7086600" y="4224528"/>
+            <a:ext cx="1828800" cy="713232"/>
+          </a:xfrm>
+          <a:prstGeom prst="roundRect">
+            <a:avLst>
+              <a:gd name="adj" fmla="val 10256"/>
+            </a:avLst>
+          </a:prstGeom>
+          <a:solidFill>
+            <a:srgbClr val="FFC6C6"/>
+          </a:solidFill>
+          <a:ln/>
+        </p:spPr>
+      </p:sp>
+      <p:sp>
+        <p:nvSpPr>
+          <p:cNvPr id="45" name="Text 43"/>
+          <p:cNvSpPr txBox="1"/>
+          <p:nvPr/>
+        </p:nvSpPr>
+        <p:spPr>
+          <a:xfrm>
+            <a:off x="7123176" y="4224528"/>
+            <a:ext cx="1755648" cy="713232"/>
+          </a:xfrm>
+          <a:prstGeom prst="rect">
+            <a:avLst/>
+          </a:prstGeom>
+          <a:noFill/>
+          <a:ln/>
+        </p:spPr>
+        <p:txBody>
+          <a:bodyPr wrap="square" lIns="1016" tIns="1016" rIns="1016" bIns="1016" rtlCol="0" anchor="ctr"/>
+          <a:lstStyle/>
+          <a:p>
+            <a:pPr indent="0" marL="0">
+              <a:buNone/>
+            </a:pPr>
+            <a:r>
+              <a:rPr lang="en-US" sz="1150" dirty="0">
+                <a:solidFill>
+                  <a:schemeClr val="tx1"/>
+                </a:solidFill>
+                <a:latin typeface="Calibri" pitchFamily="34" charset="0"/>
+                <a:ea typeface="Calibri" pitchFamily="34" charset="-122"/>
+                <a:cs typeface="Calibri" pitchFamily="34" charset="-120"/>
+              </a:rPr>
+              <a:t>Data owner: Open (confirm with the client)</a:t>
+            </a:r>
+            <a:endParaRPr lang="en-US" sz="1150" dirty="0"/>
+          </a:p>
+        </p:txBody>
+      </p:sp>
+      <p:sp>
+        <p:nvSpPr>
+          <p:cNvPr id="46" name="Shape 44"/>
+          <p:cNvSpPr/>
+          <p:nvPr/>
+        </p:nvSpPr>
+        <p:spPr>
+          <a:xfrm>
+            <a:off x="777240" y="4956048"/>
+            <a:ext cx="182880" cy="164592"/>
+          </a:xfrm>
+          <a:prstGeom prst="downArrow">
+            <a:avLst/>
+          </a:prstGeom>
+          <a:solidFill>
+            <a:srgbClr val="E8A33D"/>
+          </a:solidFill>
+          <a:ln/>
+        </p:spPr>
+      </p:sp>
+      <p:sp>
+        <p:nvSpPr>
+          <p:cNvPr id="47" name="Text 45"/>
+          <p:cNvSpPr txBox="1"/>
+          <p:nvPr/>
+        </p:nvSpPr>
+        <p:spPr>
+          <a:xfrm>
+            <a:off x="1005840" y="4937760"/>
+            <a:ext cx="1371600" cy="201168"/>
+          </a:xfrm>
+          <a:prstGeom prst="rect">
+            <a:avLst/>
+          </a:prstGeom>
+          <a:noFill/>
+          <a:ln/>
+        </p:spPr>
+        <p:txBody>
+          <a:bodyPr wrap="square" lIns="0" tIns="0" rIns="0" bIns="0" rtlCol="0" anchor="ctr"/>
+          <a:lstStyle/>
+          <a:p>
+            <a:pPr indent="0" marL="0">
+              <a:buNone/>
+            </a:pPr>
+            <a:r>
+              <a:rPr lang="en-US" sz="1000" b="1" i="1" dirty="0">
+                <a:solidFill>
+                  <a:schemeClr val="accent1"/>
+                </a:solidFill>
+                <a:latin typeface="Calibri" pitchFamily="34" charset="0"/>
+                <a:ea typeface="Calibri" pitchFamily="34" charset="-122"/>
+                <a:cs typeface="Calibri" pitchFamily="34" charset="-120"/>
+              </a:rPr>
+              <a:t>M  mitigate</a:t>
+            </a:r>
+            <a:endParaRPr lang="en-US" sz="1000" dirty="0"/>
+          </a:p>
+        </p:txBody>
+      </p:sp>
+      <p:sp>
+        <p:nvSpPr>
+          <p:cNvPr id="48" name="hop4"/>
+          <p:cNvSpPr/>
+          <p:nvPr/>
+        </p:nvSpPr>
+        <p:spPr>
+          <a:xfrm>
+            <a:off x="548640" y="5138928"/>
+            <a:ext cx="1783080" cy="713232"/>
+          </a:xfrm>
+          <a:prstGeom prst="roundRect">
+            <a:avLst>
+              <a:gd name="adj" fmla="val 10256"/>
+            </a:avLst>
+          </a:prstGeom>
+          <a:solidFill>
+            <a:srgbClr val="C6DCFF"/>
+          </a:solidFill>
+          <a:ln/>
+        </p:spPr>
+      </p:sp>
+      <p:sp>
+        <p:nvSpPr>
+          <p:cNvPr id="49" name="Text 47"/>
+          <p:cNvSpPr txBox="1"/>
+          <p:nvPr/>
+        </p:nvSpPr>
+        <p:spPr>
+          <a:xfrm>
+            <a:off x="594360" y="5138928"/>
+            <a:ext cx="1691640" cy="713232"/>
+          </a:xfrm>
+          <a:prstGeom prst="rect">
+            <a:avLst/>
+          </a:prstGeom>
+          <a:noFill/>
+          <a:ln/>
+        </p:spPr>
+        <p:txBody>
+          <a:bodyPr wrap="square" lIns="1016" tIns="1016" rIns="1016" bIns="1016" rtlCol="0" anchor="ctr"/>
+          <a:lstStyle/>
+          <a:p>
+            <a:pPr indent="0" marL="0">
+              <a:buNone/>
+            </a:pPr>
+            <a:r>
+              <a:rPr lang="en-US" sz="1300" b="1" dirty="0">
+                <a:solidFill>
+                  <a:schemeClr val="tx1"/>
+                </a:solidFill>
+                <a:latin typeface="Calibri" pitchFamily="34" charset="0"/>
+                <a:ea typeface="Calibri" pitchFamily="34" charset="-122"/>
+                <a:cs typeface="Calibri" pitchFamily="34" charset="-120"/>
+              </a:rPr>
+              <a:t>5  Read by the product</a:t>
+            </a:r>
+            <a:endParaRPr lang="en-US" sz="1300" dirty="0"/>
+          </a:p>
+        </p:txBody>
+      </p:sp>
+      <p:sp>
+        <p:nvSpPr>
+          <p:cNvPr id="50" name="moves4"/>
+          <p:cNvSpPr/>
+          <p:nvPr/>
+        </p:nvSpPr>
+        <p:spPr>
+          <a:xfrm>
+            <a:off x="2377440" y="5138928"/>
+            <a:ext cx="3154680" cy="713232"/>
+          </a:xfrm>
+          <a:prstGeom prst="roundRect">
+            <a:avLst>
+              <a:gd name="adj" fmla="val 10256"/>
+            </a:avLst>
+          </a:prstGeom>
+          <a:solidFill>
+            <a:srgbClr val="F4F7F7"/>
+          </a:solidFill>
+          <a:ln/>
+        </p:spPr>
+      </p:sp>
+      <p:sp>
+        <p:nvSpPr>
+          <p:cNvPr id="51" name="Text 49"/>
+          <p:cNvSpPr txBox="1"/>
+          <p:nvPr/>
+        </p:nvSpPr>
+        <p:spPr>
+          <a:xfrm>
+            <a:off x="2414016" y="5138928"/>
+            <a:ext cx="3081528" cy="713232"/>
+          </a:xfrm>
+          <a:prstGeom prst="rect">
+            <a:avLst/>
+          </a:prstGeom>
+          <a:noFill/>
+          <a:ln/>
+        </p:spPr>
+        <p:txBody>
+          <a:bodyPr wrap="square" lIns="1016" tIns="1016" rIns="1016" bIns="1016" rtlCol="0" anchor="ctr"/>
+          <a:lstStyle/>
+          <a:p>
+            <a:pPr indent="0" marL="0">
+              <a:buNone/>
+            </a:pPr>
+            <a:r>
+              <a:rPr lang="en-US" sz="1150" dirty="0">
+                <a:solidFill>
+                  <a:schemeClr val="tx1"/>
+                </a:solidFill>
+                <a:latin typeface="Calibri" pitchFamily="34" charset="0"/>
+                <a:ea typeface="Calibri" pitchFamily="34" charset="-122"/>
+                <a:cs typeface="Calibri" pitchFamily="34" charset="-120"/>
+              </a:rPr>
+              <a:t>Status, owner, next step, history, messages</a:t>
+            </a:r>
+            <a:endParaRPr lang="en-US" sz="1150" dirty="0"/>
+          </a:p>
+        </p:txBody>
+      </p:sp>
+      <p:sp>
+        <p:nvSpPr>
+          <p:cNvPr id="52" name="entered4"/>
+          <p:cNvSpPr/>
+          <p:nvPr/>
+        </p:nvSpPr>
+        <p:spPr>
+          <a:xfrm>
+            <a:off x="5577840" y="5138928"/>
+            <a:ext cx="1463040" cy="713232"/>
+          </a:xfrm>
+          <a:prstGeom prst="roundRect">
+            <a:avLst>
+              <a:gd name="adj" fmla="val 10256"/>
+            </a:avLst>
+          </a:prstGeom>
+          <a:solidFill>
+            <a:srgbClr val="FFE2B8"/>
+          </a:solidFill>
+          <a:ln/>
+        </p:spPr>
+      </p:sp>
+      <p:sp>
+        <p:nvSpPr>
+          <p:cNvPr id="53" name="Text 51"/>
+          <p:cNvSpPr txBox="1"/>
+          <p:nvPr/>
+        </p:nvSpPr>
+        <p:spPr>
+          <a:xfrm>
+            <a:off x="5614416" y="5138928"/>
+            <a:ext cx="1389888" cy="713232"/>
+          </a:xfrm>
+          <a:prstGeom prst="rect">
+            <a:avLst/>
+          </a:prstGeom>
+          <a:noFill/>
+          <a:ln/>
+        </p:spPr>
+        <p:txBody>
+          <a:bodyPr wrap="square" lIns="1016" tIns="1016" rIns="1016" bIns="1016" rtlCol="0" anchor="ctr"/>
+          <a:lstStyle/>
+          <a:p>
+            <a:pPr indent="0" marL="0">
+              <a:buNone/>
+            </a:pPr>
+            <a:r>
+              <a:rPr lang="en-US" sz="1150" dirty="0">
+                <a:solidFill>
+                  <a:schemeClr val="tx1"/>
+                </a:solidFill>
+                <a:latin typeface="Calibri" pitchFamily="34" charset="0"/>
+                <a:ea typeface="Calibri" pitchFamily="34" charset="-122"/>
+                <a:cs typeface="Calibri" pitchFamily="34" charset="-120"/>
+              </a:rPr>
+              <a:t>No new entry</a:t>
+            </a:r>
+            <a:endParaRPr lang="en-US" sz="1150" dirty="0"/>
+          </a:p>
+        </p:txBody>
+      </p:sp>
+      <p:sp>
+        <p:nvSpPr>
+          <p:cNvPr id="54" name="acct4"/>
+          <p:cNvSpPr/>
+          <p:nvPr/>
+        </p:nvSpPr>
+        <p:spPr>
+          <a:xfrm>
+            <a:off x="7086600" y="5138928"/>
+            <a:ext cx="1828800" cy="713232"/>
+          </a:xfrm>
+          <a:prstGeom prst="roundRect">
+            <a:avLst>
+              <a:gd name="adj" fmla="val 10256"/>
+            </a:avLst>
+          </a:prstGeom>
+          <a:solidFill>
+            <a:srgbClr val="FFE2B8"/>
+          </a:solidFill>
+          <a:ln/>
+        </p:spPr>
+      </p:sp>
+      <p:sp>
+        <p:nvSpPr>
+          <p:cNvPr id="55" name="Text 53"/>
+          <p:cNvSpPr txBox="1"/>
+          <p:nvPr/>
+        </p:nvSpPr>
+        <p:spPr>
+          <a:xfrm>
+            <a:off x="7123176" y="5138928"/>
+            <a:ext cx="1755648" cy="713232"/>
+          </a:xfrm>
+          <a:prstGeom prst="rect">
+            <a:avLst/>
+          </a:prstGeom>
+          <a:noFill/>
+          <a:ln/>
+        </p:spPr>
+        <p:txBody>
+          <a:bodyPr wrap="square" lIns="1016" tIns="1016" rIns="1016" bIns="1016" rtlCol="0" anchor="ctr"/>
+          <a:lstStyle/>
+          <a:p>
+            <a:pPr indent="0" marL="0">
+              <a:buNone/>
+            </a:pPr>
+            <a:r>
+              <a:rPr lang="en-US" sz="1150" dirty="0">
+                <a:solidFill>
+                  <a:schemeClr val="tx1"/>
+                </a:solidFill>
+                <a:latin typeface="Calibri" pitchFamily="34" charset="0"/>
+                <a:ea typeface="Calibri" pitchFamily="34" charset="-122"/>
+                <a:cs typeface="Calibri" pitchFamily="34" charset="-120"/>
+              </a:rPr>
+              <a:t>Data owner, for what the views show</a:t>
+            </a:r>
+            <a:endParaRPr lang="en-US" sz="1150" dirty="0"/>
+          </a:p>
+        </p:txBody>
+      </p:sp>
+      <p:sp>
+        <p:nvSpPr>
+          <p:cNvPr id="56" name="Text 54"/>
+          <p:cNvSpPr txBox="1"/>
+          <p:nvPr/>
+        </p:nvSpPr>
+        <p:spPr>
+          <a:xfrm>
+            <a:off x="9144000" y="1115568"/>
+            <a:ext cx="2468880" cy="310896"/>
+          </a:xfrm>
+          <a:prstGeom prst="rect">
+            <a:avLst/>
+          </a:prstGeom>
+          <a:noFill/>
+          <a:ln/>
+        </p:spPr>
+        <p:txBody>
+          <a:bodyPr wrap="square" lIns="1016" tIns="1016" rIns="1016" bIns="1016" rtlCol="0" anchor="b"/>
+          <a:lstStyle/>
+          <a:p>
+            <a:pPr indent="0" marL="0">
+              <a:buNone/>
+            </a:pPr>
+            <a:r>
+              <a:rPr lang="en-US" sz="1200" b="1" dirty="0">
+                <a:solidFill>
+                  <a:schemeClr val="accent1"/>
+                </a:solidFill>
+                <a:latin typeface="Calibri" pitchFamily="34" charset="0"/>
+                <a:ea typeface="Calibri" pitchFamily="34" charset="-122"/>
+                <a:cs typeface="Calibri" pitchFamily="34" charset="-120"/>
+              </a:rPr>
+              <a:t>Reaches the sinks (S, alarm)</a:t>
+            </a:r>
+            <a:endParaRPr lang="en-US" sz="1200" dirty="0"/>
+          </a:p>
+        </p:txBody>
+      </p:sp>
+      <p:sp>
+        <p:nvSpPr>
+          <p:cNvPr id="57" name="sink0"/>
+          <p:cNvSpPr/>
+          <p:nvPr/>
+        </p:nvSpPr>
+        <p:spPr>
+          <a:xfrm>
+            <a:off x="9144000" y="1481328"/>
+            <a:ext cx="2468880" cy="978408"/>
+          </a:xfrm>
+          <a:prstGeom prst="roundRect">
+            <a:avLst>
+              <a:gd name="adj" fmla="val 7477"/>
+            </a:avLst>
+          </a:prstGeom>
+          <a:solidFill>
+            <a:srgbClr val="ADF0C7"/>
+          </a:solidFill>
+          <a:ln/>
+        </p:spPr>
+      </p:sp>
+      <p:sp>
+        <p:nvSpPr>
+          <p:cNvPr id="58" name="Text 56"/>
+          <p:cNvSpPr txBox="1"/>
+          <p:nvPr/>
+        </p:nvSpPr>
+        <p:spPr>
+          <a:xfrm>
+            <a:off x="9180576" y="1499616"/>
+            <a:ext cx="2395728" cy="941832"/>
+          </a:xfrm>
+          <a:prstGeom prst="rect">
+            <a:avLst/>
+          </a:prstGeom>
+          <a:noFill/>
+          <a:ln/>
+        </p:spPr>
+        <p:txBody>
+          <a:bodyPr wrap="square" lIns="1016" tIns="1016" rIns="1016" bIns="1016" rtlCol="0" anchor="t"/>
+          <a:lstStyle/>
+          <a:p>
+            <a:pPr indent="0" marL="0">
+              <a:buNone/>
+            </a:pPr>
+            <a:r>
+              <a:rPr lang="en-US" sz="1100" b="1" dirty="0">
+                <a:solidFill>
+                  <a:schemeClr val="tx1"/>
+                </a:solidFill>
+                <a:latin typeface="Calibri" pitchFamily="34" charset="0"/>
+                <a:ea typeface="Calibri" pitchFamily="34" charset="-122"/>
+                <a:cs typeface="Calibri" pitchFamily="34" charset="-120"/>
+              </a:rPr>
+              <a:t>Product</a:t>
+            </a:r>
+            <a:endParaRPr lang="en-US" sz="1100" dirty="0"/>
+          </a:p>
+          <a:p>
+            <a:pPr indent="0" marL="0">
+              <a:buNone/>
+            </a:pPr>
+            <a:r>
+              <a:rPr lang="en-US" sz="1100" dirty="0">
+                <a:solidFill>
+                  <a:schemeClr val="tx1"/>
+                </a:solidFill>
+                <a:latin typeface="Calibri" pitchFamily="34" charset="0"/>
+                <a:ea typeface="Calibri" pitchFamily="34" charset="-122"/>
+                <a:cs typeface="Calibri" pitchFamily="34" charset="-120"/>
+              </a:rPr>
+              <a:t>CMAC request view: status, owner, next step. Coordinator queue: incomplete and duplicate flags</a:t>
+            </a:r>
+            <a:endParaRPr lang="en-US" sz="1100" dirty="0"/>
+          </a:p>
+        </p:txBody>
+      </p:sp>
+      <p:sp>
+        <p:nvSpPr>
+          <p:cNvPr id="59" name="sink1"/>
+          <p:cNvSpPr/>
+          <p:nvPr/>
+        </p:nvSpPr>
+        <p:spPr>
+          <a:xfrm>
+            <a:off x="9144000" y="2551176"/>
+            <a:ext cx="2468880" cy="978408"/>
+          </a:xfrm>
+          <a:prstGeom prst="roundRect">
+            <a:avLst>
+              <a:gd name="adj" fmla="val 7477"/>
+            </a:avLst>
+          </a:prstGeom>
+          <a:solidFill>
+            <a:srgbClr val="ADF0C7"/>
+          </a:solidFill>
+          <a:ln/>
+        </p:spPr>
+      </p:sp>
+      <p:sp>
+        <p:nvSpPr>
+          <p:cNvPr id="60" name="Text 58"/>
+          <p:cNvSpPr txBox="1"/>
+          <p:nvPr/>
+        </p:nvSpPr>
+        <p:spPr>
+          <a:xfrm>
+            <a:off x="9180576" y="2569464"/>
+            <a:ext cx="2395728" cy="941832"/>
+          </a:xfrm>
+          <a:prstGeom prst="rect">
+            <a:avLst/>
+          </a:prstGeom>
+          <a:noFill/>
+          <a:ln/>
+        </p:spPr>
+        <p:txBody>
+          <a:bodyPr wrap="square" lIns="1016" tIns="1016" rIns="1016" bIns="1016" rtlCol="0" anchor="t"/>
+          <a:lstStyle/>
+          <a:p>
+            <a:pPr indent="0" marL="0">
+              <a:buNone/>
+            </a:pPr>
+            <a:r>
+              <a:rPr lang="en-US" sz="1100" b="1" dirty="0">
+                <a:solidFill>
+                  <a:schemeClr val="tx1"/>
+                </a:solidFill>
+                <a:latin typeface="Calibri" pitchFamily="34" charset="0"/>
+                <a:ea typeface="Calibri" pitchFamily="34" charset="-122"/>
+                <a:cs typeface="Calibri" pitchFamily="34" charset="-120"/>
+              </a:rPr>
+              <a:t>Measurement</a:t>
+            </a:r>
+            <a:endParaRPr lang="en-US" sz="1100" dirty="0"/>
+          </a:p>
+          <a:p>
+            <a:pPr indent="0" marL="0">
+              <a:buNone/>
+            </a:pPr>
+            <a:r>
+              <a:rPr lang="en-US" sz="1100" dirty="0">
+                <a:solidFill>
+                  <a:schemeClr val="tx1"/>
+                </a:solidFill>
+                <a:latin typeface="Calibri" pitchFamily="34" charset="0"/>
+                <a:ea typeface="Calibri" pitchFamily="34" charset="-122"/>
+                <a:cs typeface="Calibri" pitchFamily="34" charset="-120"/>
+              </a:rPr>
+              <a:t>Submission time, returns for information and stage times give right first time and time in stage</a:t>
+            </a:r>
+            <a:endParaRPr lang="en-US" sz="1100" dirty="0"/>
+          </a:p>
+        </p:txBody>
+      </p:sp>
+      <p:sp>
+        <p:nvSpPr>
+          <p:cNvPr id="61" name="sink2"/>
+          <p:cNvSpPr/>
+          <p:nvPr/>
+        </p:nvSpPr>
+        <p:spPr>
+          <a:xfrm>
+            <a:off x="9144000" y="3621024"/>
+            <a:ext cx="2468880" cy="978408"/>
+          </a:xfrm>
+          <a:prstGeom prst="roundRect">
+            <a:avLst>
+              <a:gd name="adj" fmla="val 7477"/>
+            </a:avLst>
+          </a:prstGeom>
+          <a:solidFill>
+            <a:srgbClr val="ADF0C7"/>
+          </a:solidFill>
+          <a:ln/>
+        </p:spPr>
+      </p:sp>
+      <p:sp>
+        <p:nvSpPr>
+          <p:cNvPr id="62" name="Text 60"/>
+          <p:cNvSpPr txBox="1"/>
+          <p:nvPr/>
+        </p:nvSpPr>
+        <p:spPr>
+          <a:xfrm>
+            <a:off x="9180576" y="3639312"/>
+            <a:ext cx="2395728" cy="941832"/>
+          </a:xfrm>
+          <a:prstGeom prst="rect">
+            <a:avLst/>
+          </a:prstGeom>
+          <a:noFill/>
+          <a:ln/>
+        </p:spPr>
+        <p:txBody>
+          <a:bodyPr wrap="square" lIns="1016" tIns="1016" rIns="1016" bIns="1016" rtlCol="0" anchor="t"/>
+          <a:lstStyle/>
+          <a:p>
+            <a:pPr indent="0" marL="0">
+              <a:buNone/>
+            </a:pPr>
+            <a:r>
+              <a:rPr lang="en-US" sz="1100" b="1" dirty="0">
+                <a:solidFill>
+                  <a:schemeClr val="tx1"/>
+                </a:solidFill>
+                <a:latin typeface="Calibri" pitchFamily="34" charset="0"/>
+                <a:ea typeface="Calibri" pitchFamily="34" charset="-122"/>
+                <a:cs typeface="Calibri" pitchFamily="34" charset="-120"/>
+              </a:rPr>
+              <a:t>Business value</a:t>
+            </a:r>
+            <a:endParaRPr lang="en-US" sz="1100" dirty="0"/>
+          </a:p>
+          <a:p>
+            <a:pPr indent="0" marL="0">
+              <a:buNone/>
+            </a:pPr>
+            <a:r>
+              <a:rPr lang="en-US" sz="1100" dirty="0">
+                <a:solidFill>
+                  <a:schemeClr val="tx1"/>
+                </a:solidFill>
+                <a:latin typeface="Calibri" pitchFamily="34" charset="0"/>
+                <a:ea typeface="Calibri" pitchFamily="34" charset="-122"/>
+                <a:cs typeface="Calibri" pitchFamily="34" charset="-120"/>
+              </a:rPr>
+              <a:t>Aggregates by location, status and period; recycled preference; item and date for asset history</a:t>
+            </a:r>
+            <a:endParaRPr lang="en-US" sz="1100" dirty="0"/>
+          </a:p>
+        </p:txBody>
+      </p:sp>
+      <p:sp>
+        <p:nvSpPr>
+          <p:cNvPr id="63" name="vfails"/>
+          <p:cNvSpPr/>
+          <p:nvPr/>
+        </p:nvSpPr>
+        <p:spPr>
+          <a:xfrm>
+            <a:off x="9144000" y="4727448"/>
+            <a:ext cx="2468880" cy="566928"/>
+          </a:xfrm>
+          <a:prstGeom prst="roundRect">
+            <a:avLst>
+              <a:gd name="adj" fmla="val 12903"/>
+            </a:avLst>
+          </a:prstGeom>
+          <a:solidFill>
+            <a:srgbClr val="FFC6C6"/>
+          </a:solidFill>
+          <a:ln/>
+        </p:spPr>
+      </p:sp>
+      <p:sp>
+        <p:nvSpPr>
+          <p:cNvPr id="64" name="Text 62"/>
+          <p:cNvSpPr txBox="1"/>
+          <p:nvPr/>
+        </p:nvSpPr>
+        <p:spPr>
+          <a:xfrm>
+            <a:off x="9180576" y="4727448"/>
+            <a:ext cx="2395728" cy="566928"/>
+          </a:xfrm>
+          <a:prstGeom prst="rect">
+            <a:avLst/>
+          </a:prstGeom>
+          <a:noFill/>
+          <a:ln/>
+        </p:spPr>
+        <p:txBody>
+          <a:bodyPr wrap="square" lIns="1016" tIns="1016" rIns="1016" bIns="1016" rtlCol="0" anchor="ctr"/>
+          <a:lstStyle/>
+          <a:p>
+            <a:pPr indent="0" marL="0">
+              <a:buNone/>
+            </a:pPr>
+            <a:r>
+              <a:rPr lang="en-US" sz="1100" b="1" dirty="0">
+                <a:solidFill>
+                  <a:schemeClr val="tx1"/>
+                </a:solidFill>
+                <a:latin typeface="Calibri" pitchFamily="34" charset="0"/>
+                <a:ea typeface="Calibri" pitchFamily="34" charset="-122"/>
+                <a:cs typeface="Calibri" pitchFamily="34" charset="-120"/>
+              </a:rPr>
+              <a:t>If V fails: </a:t>
+            </a:r>
+            <a:pPr indent="0" marL="0">
+              <a:buNone/>
+            </a:pPr>
+            <a:r>
+              <a:rPr lang="en-US" sz="1100" dirty="0">
+                <a:solidFill>
+                  <a:schemeClr val="tx1"/>
+                </a:solidFill>
+                <a:latin typeface="Calibri" pitchFamily="34" charset="0"/>
+                <a:ea typeface="Calibri" pitchFamily="34" charset="-122"/>
+                <a:cs typeface="Calibri" pitchFamily="34" charset="-120"/>
+              </a:rPr>
+              <a:t>returned to the CMAC in the request thread, then re-checked</a:t>
+            </a:r>
+            <a:endParaRPr lang="en-US" sz="1100" dirty="0"/>
+          </a:p>
+        </p:txBody>
+      </p:sp>
+      <p:sp>
+        <p:nvSpPr>
+          <p:cNvPr id="65" name="principle"/>
+          <p:cNvSpPr/>
+          <p:nvPr/>
+        </p:nvSpPr>
+        <p:spPr>
+          <a:xfrm>
+            <a:off x="9144000" y="5358384"/>
+            <a:ext cx="2468880" cy="493776"/>
+          </a:xfrm>
+          <a:prstGeom prst="roundRect">
+            <a:avLst>
+              <a:gd name="adj" fmla="val 14815"/>
             </a:avLst>
           </a:prstGeom>
           <a:solidFill>
@@ -8463,14 +8750,14 @@
       </p:sp>
       <p:sp>
         <p:nvSpPr>
-          <p:cNvPr id="6" name="Text 3"/>
+          <p:cNvPr id="66" name="Text 64"/>
           <p:cNvSpPr txBox="1"/>
           <p:nvPr/>
         </p:nvSpPr>
         <p:spPr>
           <a:xfrm>
-            <a:off x="8869680" y="1280160"/>
-            <a:ext cx="2651760" cy="457200"/>
+            <a:off x="9180576" y="5358384"/>
+            <a:ext cx="2395728" cy="493776"/>
           </a:xfrm>
           <a:prstGeom prst="rect">
             <a:avLst/>
@@ -8479,58 +8766,14 @@
           <a:ln/>
         </p:spPr>
         <p:txBody>
-          <a:bodyPr wrap="square" lIns="1016" tIns="1016" rIns="1016" bIns="1016" rtlCol="0" anchor="t"/>
+          <a:bodyPr wrap="square" lIns="1016" tIns="1016" rIns="1016" bIns="1016" rtlCol="0" anchor="ctr"/>
           <a:lstStyle/>
           <a:p>
             <a:pPr indent="0" marL="0">
               <a:buNone/>
             </a:pPr>
             <a:r>
-              <a:rPr lang="en-US" sz="1700" b="1" dirty="0">
-                <a:solidFill>
-                  <a:schemeClr val="tx2"/>
-                </a:solidFill>
-                <a:latin typeface="Cambria" pitchFamily="34" charset="0"/>
-                <a:ea typeface="Cambria" pitchFamily="34" charset="-122"/>
-                <a:cs typeface="Cambria" pitchFamily="34" charset="-120"/>
-              </a:rPr>
-              <a:t>What "clean" means here</a:t>
-            </a:r>
-            <a:endParaRPr lang="en-US" sz="1700" dirty="0"/>
-          </a:p>
-        </p:txBody>
-      </p:sp>
-      <p:sp>
-        <p:nvSpPr>
-          <p:cNvPr id="7" name="Text 4"/>
-          <p:cNvSpPr txBox="1"/>
-          <p:nvPr/>
-        </p:nvSpPr>
-        <p:spPr>
-          <a:xfrm>
-            <a:off x="8869680" y="1783080"/>
-            <a:ext cx="2651760" cy="3291840"/>
-          </a:xfrm>
-          <a:prstGeom prst="rect">
-            <a:avLst/>
-          </a:prstGeom>
-          <a:noFill/>
-          <a:ln/>
-        </p:spPr>
-        <p:txBody>
-          <a:bodyPr wrap="square" lIns="1016" tIns="1016" rIns="1016" bIns="1016" rtlCol="0" anchor="t"/>
-          <a:lstStyle/>
-          <a:p>
-            <a:pPr marL="342900" indent="-342900">
-              <a:spcAft>
-                <a:spcPts val="400"/>
-              </a:spcAft>
-              <a:buSzPct val="100000"/>
-              <a:buFont typeface="+mj-lt"/>
-              <a:buAutoNum type="arabicPeriod" startAt="1"/>
-            </a:pPr>
-            <a:r>
-              <a:rPr lang="en-US" sz="1300" dirty="0">
+              <a:rPr lang="en-US" sz="1100" b="1" dirty="0">
                 <a:solidFill>
                   <a:schemeClr val="tx1"/>
                 </a:solidFill>
@@ -8538,158 +8781,62 @@
                 <a:ea typeface="Calibri" pitchFamily="34" charset="-122"/>
                 <a:cs typeface="Calibri" pitchFamily="34" charset="-120"/>
               </a:rPr>
-              <a:t>One work order ID, every update linked to it</a:t>
-            </a:r>
-            <a:endParaRPr lang="en-US" sz="1300" dirty="0"/>
-          </a:p>
-          <a:p>
-            <a:pPr marL="342900" indent="-342900">
-              <a:spcAft>
-                <a:spcPts val="400"/>
-              </a:spcAft>
-              <a:buSzPct val="100000"/>
-              <a:buFont typeface="+mj-lt"/>
-              <a:buAutoNum type="arabicPeriod" startAt="1"/>
-            </a:pPr>
-            <a:r>
-              <a:rPr lang="en-US" sz="1300" dirty="0">
-                <a:solidFill>
-                  <a:schemeClr val="tx1"/>
+              <a:t>Entering data is not the same as being accountable for its accuracy</a:t>
+            </a:r>
+            <a:endParaRPr lang="en-US" sz="1100" dirty="0"/>
+          </a:p>
+        </p:txBody>
+      </p:sp>
+      <p:sp>
+        <p:nvSpPr>
+          <p:cNvPr id="67" name="Text 65"/>
+          <p:cNvSpPr txBox="1"/>
+          <p:nvPr/>
+        </p:nvSpPr>
+        <p:spPr>
+          <a:xfrm>
+            <a:off x="548640" y="5925312"/>
+            <a:ext cx="11064240" cy="411480"/>
+          </a:xfrm>
+          <a:prstGeom prst="rect">
+            <a:avLst/>
+          </a:prstGeom>
+          <a:noFill/>
+          <a:ln/>
+        </p:spPr>
+        <p:txBody>
+          <a:bodyPr wrap="square" lIns="1016" tIns="1016" rIns="1016" bIns="1016" rtlCol="0" anchor="ctr"/>
+          <a:lstStyle/>
+          <a:p>
+            <a:pPr indent="0" marL="0">
+              <a:buNone/>
+            </a:pPr>
+            <a:r>
+              <a:rPr lang="en-US" sz="1100" b="1" dirty="0">
+                <a:solidFill>
+                  <a:srgbClr val="3D5252"/>
                 </a:solidFill>
                 <a:latin typeface="Calibri" pitchFamily="34" charset="0"/>
                 <a:ea typeface="Calibri" pitchFamily="34" charset="-122"/>
                 <a:cs typeface="Calibri" pitchFamily="34" charset="-120"/>
               </a:rPr>
-              <a:t>One status from a standard list</a:t>
-            </a:r>
-            <a:endParaRPr lang="en-US" sz="1300" dirty="0"/>
-          </a:p>
-          <a:p>
-            <a:pPr marL="342900" indent="-342900">
-              <a:spcAft>
-                <a:spcPts val="400"/>
-              </a:spcAft>
-              <a:buSzPct val="100000"/>
-              <a:buFont typeface="+mj-lt"/>
-              <a:buAutoNum type="arabicPeriod" startAt="1"/>
-            </a:pPr>
-            <a:r>
-              <a:rPr lang="en-US" sz="1300" dirty="0">
-                <a:solidFill>
-                  <a:schemeClr val="tx1"/>
+              <a:t>Constraints: </a:t>
+            </a:r>
+            <a:pPr indent="0" marL="0">
+              <a:buNone/>
+            </a:pPr>
+            <a:r>
+              <a:rPr lang="en-US" sz="1100" dirty="0">
+                <a:solidFill>
+                  <a:srgbClr val="3D5252"/>
                 </a:solidFill>
                 <a:latin typeface="Calibri" pitchFamily="34" charset="0"/>
                 <a:ea typeface="Calibri" pitchFamily="34" charset="-122"/>
                 <a:cs typeface="Calibri" pitchFamily="34" charset="-120"/>
               </a:rPr>
-              <a:t>A named, valid owner at every stage</a:t>
-            </a:r>
-            <a:endParaRPr lang="en-US" sz="1300" dirty="0"/>
-          </a:p>
-          <a:p>
-            <a:pPr marL="342900" indent="-342900">
-              <a:spcAft>
-                <a:spcPts val="400"/>
-              </a:spcAft>
-              <a:buSzPct val="100000"/>
-              <a:buFont typeface="+mj-lt"/>
-              <a:buAutoNum type="arabicPeriod" startAt="1"/>
-            </a:pPr>
-            <a:r>
-              <a:rPr lang="en-US" sz="1300" dirty="0">
-                <a:solidFill>
-                  <a:schemeClr val="tx1"/>
-                </a:solidFill>
-                <a:latin typeface="Calibri" pitchFamily="34" charset="0"/>
-                <a:ea typeface="Calibri" pitchFamily="34" charset="-122"/>
-                <a:cs typeface="Calibri" pitchFamily="34" charset="-120"/>
-              </a:rPr>
-              <a:t>Required fields complete before review</a:t>
-            </a:r>
-            <a:endParaRPr lang="en-US" sz="1300" dirty="0"/>
-          </a:p>
-          <a:p>
-            <a:pPr marL="342900" indent="-342900">
-              <a:spcAft>
-                <a:spcPts val="400"/>
-              </a:spcAft>
-              <a:buSzPct val="100000"/>
-              <a:buFont typeface="+mj-lt"/>
-              <a:buAutoNum type="arabicPeriod" startAt="1"/>
-            </a:pPr>
-            <a:r>
-              <a:rPr lang="en-US" sz="1300" dirty="0">
-                <a:solidFill>
-                  <a:schemeClr val="tx1"/>
-                </a:solidFill>
-                <a:latin typeface="Calibri" pitchFamily="34" charset="0"/>
-                <a:ea typeface="Calibri" pitchFamily="34" charset="-122"/>
-                <a:cs typeface="Calibri" pitchFamily="34" charset="-120"/>
-              </a:rPr>
-              <a:t>Dates in one format and in true order</a:t>
-            </a:r>
-            <a:endParaRPr lang="en-US" sz="1300" dirty="0"/>
-          </a:p>
-          <a:p>
-            <a:pPr marL="342900" indent="-342900">
-              <a:spcAft>
-                <a:spcPts val="400"/>
-              </a:spcAft>
-              <a:buSzPct val="100000"/>
-              <a:buFont typeface="+mj-lt"/>
-              <a:buAutoNum type="arabicPeriod" startAt="1"/>
-            </a:pPr>
-            <a:r>
-              <a:rPr lang="en-US" sz="1300" dirty="0">
-                <a:solidFill>
-                  <a:schemeClr val="tx1"/>
-                </a:solidFill>
-                <a:latin typeface="Calibri" pitchFamily="34" charset="0"/>
-                <a:ea typeface="Calibri" pitchFamily="34" charset="-122"/>
-                <a:cs typeface="Calibri" pitchFamily="34" charset="-120"/>
-              </a:rPr>
-              <a:t>Duplicates checked on an agreed match key</a:t>
-            </a:r>
-            <a:endParaRPr lang="en-US" sz="1300" dirty="0"/>
-          </a:p>
-        </p:txBody>
-      </p:sp>
-      <p:sp>
-        <p:nvSpPr>
-          <p:cNvPr id="8" name="Text 5"/>
-          <p:cNvSpPr txBox="1"/>
-          <p:nvPr/>
-        </p:nvSpPr>
-        <p:spPr>
-          <a:xfrm>
-            <a:off x="8869680" y="5257800"/>
-            <a:ext cx="2651760" cy="822960"/>
-          </a:xfrm>
-          <a:prstGeom prst="rect">
-            <a:avLst/>
-          </a:prstGeom>
-          <a:noFill/>
-          <a:ln/>
-        </p:spPr>
-        <p:txBody>
-          <a:bodyPr wrap="square" lIns="1016" tIns="1016" rIns="1016" bIns="1016" rtlCol="0" anchor="t"/>
-          <a:lstStyle/>
-          <a:p>
-            <a:pPr indent="0" marL="0">
-              <a:buNone/>
-            </a:pPr>
-            <a:r>
-              <a:rPr lang="en-US" sz="1200" i="1" dirty="0">
-                <a:solidFill>
-                  <a:srgbClr val="3D5252"/>
-                </a:solidFill>
-                <a:latin typeface="Calibri" pitchFamily="34" charset="0"/>
-                <a:ea typeface="Calibri" pitchFamily="34" charset="-122"/>
-                <a:cs typeface="Calibri" pitchFamily="34" charset="-120"/>
-              </a:rPr>
-              <a:t>A product decision, not a technical one (Session Three). The method is not specified.</a:t>
-            </a:r>
-            <a:endParaRPr lang="en-US" sz="1200" dirty="0"/>
+              <a:t>human-generated and intermittent; event-driven; files 10MB, replies 5MB; role-based access, a CMAC sees only their own requests; retention to confirm; no migration or direct SnapTracker or OneGX/SAP link.</a:t>
+            </a:r>
+            <a:endParaRPr lang="en-US" sz="1100" dirty="0"/>
           </a:p>
         </p:txBody>
       </p:sp>

</xml_diff>

<commit_message>
Label data flows, treat governance as per-hand-off considerations, mark access rule Proposed
Arrows now name the data that moves between stages. Authentication,
validation, monitoring, mitigation and alarm are presented as questions
asked at every hand-off, with a grid of how each applies. The CMAC
own-requests rule is marked Proposed pending confirmed permissions.

Co-Authored-By: Claude Opus 5.5 <noreply@anthropic.com>
Claude-Session: https://claude.ai/code/session_01XD5hCTym2561nrmEJXnbUU
</commit_message>
<xml_diff>
--- a/MDPM 830/Data Pipeline/TeamDART_MDPM830_Data_Pipeline.pptx
+++ b/MDPM 830/Data Pipeline/TeamDART_MDPM830_Data_Pipeline.pptx
@@ -116,44 +116,44 @@
   <p:extLst>
     <p:ext uri="{521415D9-36F7-43E2-AB2F-B90AF26B5E84}">
       <p14:sectionLst xmlns:p14="http://schemas.microsoft.com/office/powerpoint/2010/main">
-        <p14:section name="Opening" id="{700e8be8-ed57-f627-ce3d-cfd5da568e43}">
+        <p14:section name="Opening" id="{c79a6ebc-0c30-2080-a400-50a9905c6150}">
           <p14:sldIdLst>
             <p14:sldId id="256"/>
           </p14:sldIdLst>
         </p14:section>
-        <p14:section name="Product and data" id="{639d0519-cc3d-7020-390c-dde37f96f640}">
+        <p14:section name="Product and data" id="{c7ed320a-659a-fd47-81bc-edec1efe4949}">
           <p14:sldIdLst>
             <p14:sldId id="257"/>
           </p14:sldIdLst>
         </p14:section>
-        <p14:section name="Step One: Sources and scope" id="{0be59457-288e-c96a-dbc2-46dad222a9c0}">
+        <p14:section name="Step One: Sources and scope" id="{355bf523-fb52-81f8-6b39-f4c72b38f127}">
           <p14:sldIdLst>
             <p14:sldId id="258"/>
             <p14:sldId id="259"/>
           </p14:sldIdLst>
         </p14:section>
-        <p14:section name="Step Two: The pipeline" id="{05c87d1b-200b-abf2-eb98-b4d050be2115}">
+        <p14:section name="Step Two: The pipeline" id="{36c7a429-0597-3595-dd1b-2955b864ca16}">
           <p14:sldIdLst>
             <p14:sldId id="260"/>
             <p14:sldId id="261"/>
           </p14:sldIdLst>
         </p14:section>
-        <p14:section name="Step Three: Sinks" id="{7670ffbb-0ab0-cc51-4fe4-9b2e62a73825}">
+        <p14:section name="Step Three: Sinks" id="{048bb3dc-104a-41b9-e539-9b5dcc3fbf0d}">
           <p14:sldIdLst>
             <p14:sldId id="262"/>
           </p14:sldIdLst>
         </p14:section>
-        <p14:section name="Step Four: Generated data" id="{ed42749f-572c-162a-9330-427fc2183ca6}">
+        <p14:section name="Step Four: Generated data" id="{2d663762-32eb-5fdf-e1e4-2e2d33bff8c8}">
           <p14:sldIdLst>
             <p14:sldId id="263"/>
           </p14:sldIdLst>
         </p14:section>
-        <p14:section name="Step Five: Gaps and leaks" id="{57e5dbb2-2855-a36d-2a0c-fa4c125c1b57}">
+        <p14:section name="Step Five: Gaps and leaks" id="{3720fc3d-cc33-9bdb-feb0-5623a02c7831}">
           <p14:sldIdLst>
             <p14:sldId id="264"/>
           </p14:sldIdLst>
         </p14:section>
-        <p14:section name="Implications" id="{ea75c458-93f8-8852-5d29-e5908c9e0cb1}">
+        <p14:section name="Implications" id="{ecfc607b-984b-5bb4-d3b1-ce90135ff455}">
           <p14:sldIdLst>
             <p14:sldId id="265"/>
           </p14:sldIdLst>
@@ -1030,13 +1030,8 @@
               <a:rPr lang="en-US" dirty="0"/>
               <a:t>This image is the pipeline model built in Miro with the Session Four conceptual template: the scope boundary on top, the five stages (Generate, Collect, Keep and Shape, Store, Use), each showing who enters the data and who is accountable for its accuracy, three kinds of sink on the right, and the loop underneath. The board link is on this slide and opens with view access.
 On the board, read these frames together: "Working 2: Pipeline Stages and Data Ownership" (this picture plus the full stage table), "Data Pipeline: Sinks, Generated Data, Gaps and Leaks" (Steps Three to Five), and "Scope, Data Sources and Origin" (Step One).
-Nodes do the work and connectors carry the controls (Session Four, adapted from Raj et al. 2020, Fig. 6):
-A Authenticate, into Collect: only an authorized requester may submit for their ministry (FR-25, Roles and Authorization Rules).
-V Validate, into Keep and Shape: required fields are checked against the request checklist, and an incomplete request goes back to the requester (FR-07, Scenario 7).
-F Monitor, into Store: every stage change arrives with a time, so a request that stops moving is visible.
-M Mitigate, into Use: a failed update or upload is held and retried, and the user is told.
-S Alarm, into the sinks: an unanswered Action Required notifies the requester; a shared proposal notifies the coordinator. The client prefers email notification.
-All five controls are Proposed until confirmed with the client.
+The labels on the arrows show what data moves: the need (item, quantity, location, reason) into Collect; the submitted request and attachments (bronze) into Keep and Shape; the clean, linked request (silver) into Store; the request record with its history into Use; and status, events and aggregates (gold) into the sinks.
+Governance: nodes do the work and connectors carry the controls (Session Four, adapted from Raj et al. 2020, Fig. 6). Session Four asks all five questions at every hand-off, so authentication, validation, monitoring, mitigation and alarms are considerations across each connection, not one control per arrow. The Miro board (Part G) has a grid of how each applies at each hand-off. For example, at the hand-off into Collect: authenticate, only an authorized requester may submit (FR-25); validate, required fields and attachments are checked (FR-03, FR-07); monitor, needs kept in email or Teams stay invisible (gap G1); mitigate, drafts are saved (FR-05); alarm, submission is confirmed to the requester (FR-09). Items not in our requirements are Proposed until the client confirms.
 Bronze, silver, gold: the audit trail is bronze (the request as submitted), the product reads silver (one clean, consistent record), and management reports read gold (aggregated).</a:t>
             </a:r>
             <a:endParaRPr lang="en-US" dirty="0"/>
@@ -1128,17 +1123,18 @@
               <a:t>This slide traces the data itself, not just the stages. It follows one request's details from the person who needs the furniture to the three kinds of sink, and names two different roles at every hop: who enters the data, and who is accountable for its accuracy. Creating or entering data is not the same as being accountable for it. Creators answer for what they state, the stage owner answers for the rules that make the data trustworthy, and the data owner answers for the record end to end. Roles marked Open need the client's confirmation.
 Trace 1, request details:
 1. The need is born with the original requester: item, quantity, location, reason. It reaches the CMAC by email, Teams or phone. The requester answers for what they state.
-Control A, authenticate: only an authorized requester may submit for their ministry (FR-25).
+Moves on: the need. Main governance consideration here: authentication, only an authorized requester may submit for their ministry (FR-25).
 2. The CMAC enters it in the guided form, adds type, required date and attachments, and PRISM Core pre-fills requester and building data (NFR-09). We propose the CMAC is accountable for the details they submit. The owner of PRISM Core reference data is Open.
-Control V, validate: required fields and the attachments the request type needs are checked (FR-03, FR-07). If they fail, the request goes back to the CMAC in the request thread and is checked again (Scenario 7).
+Moves on: the submitted request and attachments (bronze). Main consideration: validation, required fields and the attachments the request type needs are checked (FR-03, FR-07). If they fail, the request goes back to the CMAC in the request thread and is checked again (Scenario 7).
 3. The coordinator reviews it. The request as submitted is kept (bronze). One consistent version is built (silver) using six rules: one Work Order ID with every update linked; one status from a standard list; a named, valid owner at every stage; required fields complete before review; dates in one format and true order; duplicates checked on an agreed match key. Who owns these rules is Open; we propose the Furniture Request Coordinator.
-Control F, monitor: every stage change carries a time.
+Moves on: the clean, linked request (silver). Main consideration: monitoring, every stage change carries a time.
 4. The record is stored once and read by everyone. Its data owner is Open, to confirm with the client.
-Control M, mitigate: a failed update or upload is retried and the user is told.
-5. The product reads it, and control S, alarm, notifies the requester when Action Required is unanswered.
+Moves on: the request record with its history. Main consideration: mitigation, a failed update or upload is retried and the user is told.
+5. The product reads it, and the alarm consideration means the requester is notified the requester when Action Required is unanswered.
 Sinks reached: the product sink (CMAC view, coordinator queue); the measurement sink (submission time, returns for information and stage times give right first time and time in stage); the business-value sinks (aggregates by location, status and period for Infrastructure reports; recycled preference for the recycle program; item, location and fulfilment date for asset and warranty history).
 Trace 2 is on the Miro board: a coordinator update must be entered on the request, not only sent by email or Teams, or it never reaches the record (gap G1). The board also has an element-by-element lineage table: born, entered by, accountable for accuracy, path, and sinks reached.
-Constraints: human-generated and intermittent; event-driven; files 10MB, replies 5MB; role-based access; retention per the Government of Alberta records schedule, to confirm; no historical migration; no direct SnapTracker or OneGX/SAP link assumed.</a:t>
+Governance: these are the main considerations at each hop, but all five (authentication, validation, monitoring, mitigation, alarm) are asked at every hand-off; the Miro board, Part G, shows the full grid.
+Constraints: human-generated and intermittent; event-driven; files 10MB, replies 5MB; role-based access, with "a CMAC sees only their own requests" Proposed until exact permissions are confirmed with the client; retention per the Government of Alberta records schedule, to confirm; no historical migration; no direct SnapTracker or OneGX/SAP link assumed.</a:t>
             </a:r>
             <a:endParaRPr lang="en-US" dirty="0"/>
           </a:p>
@@ -6511,7 +6507,7 @@
                 <a:ea typeface="Cambria" pitchFamily="34" charset="-122"/>
                 <a:cs typeface="Cambria" pitchFamily="34" charset="-120"/>
               </a:rPr>
-              <a:t>Five stages from source to sink, with the controls on the hand-offs</a:t>
+              <a:t>Five stages from source to sink, and what moves between them</a:t>
             </a:r>
             <a:endParaRPr lang="en-US" sz="3000" dirty="0"/>
           </a:p>
@@ -6519,7 +6515,7 @@
       </p:sp>
       <p:pic>
         <p:nvPicPr>
-          <p:cNvPr id="4" name="Miro pipeline image" descr="Miro pipeline: scope boundary, five stages Generate, Collect, Keep and Shape, Store, Use with owners, controls A V F M S on the connectors, three kinds of sink, and the loop">    </p:cNvPr>
+          <p:cNvPr id="4" name="Miro pipeline image" descr="Miro pipeline: scope boundary, five stages Generate, Collect, Keep and Shape, Store, Use each showing who enters the data and who is accountable, labels on the arrows for the data that moves, three kinds of sink, and the loop">    </p:cNvPr>
           <p:cNvPicPr>
             <a:picLocks noChangeAspect="1"/>
           </p:cNvPicPr>
@@ -6534,7 +6530,7 @@
         <p:spPr>
           <a:xfrm>
             <a:off x="548640" y="1143000"/>
-            <a:ext cx="11064240" cy="4360612"/>
+            <a:ext cx="11064240" cy="3901600"/>
           </a:xfrm>
           <a:prstGeom prst="rect">
             <a:avLst/>
@@ -6549,7 +6545,7 @@
         </p:nvSpPr>
         <p:spPr>
           <a:xfrm>
-            <a:off x="548640" y="5640772"/>
+            <a:off x="548640" y="5181760"/>
             <a:ext cx="11064240" cy="502920"/>
           </a:xfrm>
           <a:prstGeom prst="roundRect">
@@ -6571,7 +6567,7 @@
         </p:nvSpPr>
         <p:spPr>
           <a:xfrm>
-            <a:off x="685800" y="5640772"/>
+            <a:off x="685800" y="5181760"/>
             <a:ext cx="10789920" cy="502920"/>
           </a:xfrm>
           <a:prstGeom prst="rect">
@@ -7195,7 +7191,7 @@
         <p:spPr>
           <a:xfrm>
             <a:off x="1005840" y="2194560"/>
-            <a:ext cx="1371600" cy="201168"/>
+            <a:ext cx="6400800" cy="201168"/>
           </a:xfrm>
           <a:prstGeom prst="rect">
             <a:avLst/>
@@ -7219,7 +7215,7 @@
                 <a:ea typeface="Calibri" pitchFamily="34" charset="-122"/>
                 <a:cs typeface="Calibri" pitchFamily="34" charset="-120"/>
               </a:rPr>
-              <a:t>A  authenticate</a:t>
+              <a:t>Moves on: the need (item, quantity, location, reason)</a:t>
             </a:r>
             <a:endParaRPr lang="en-US" sz="1000" dirty="0"/>
           </a:p>
@@ -7498,7 +7494,7 @@
         <p:spPr>
           <a:xfrm>
             <a:off x="1005840" y="3108960"/>
-            <a:ext cx="1371600" cy="201168"/>
+            <a:ext cx="6400800" cy="201168"/>
           </a:xfrm>
           <a:prstGeom prst="rect">
             <a:avLst/>
@@ -7522,7 +7518,7 @@
                 <a:ea typeface="Calibri" pitchFamily="34" charset="-122"/>
                 <a:cs typeface="Calibri" pitchFamily="34" charset="-120"/>
               </a:rPr>
-              <a:t>V  validate</a:t>
+              <a:t>Moves on: the submitted request and attachments (bronze)</a:t>
             </a:r>
             <a:endParaRPr lang="en-US" sz="1000" dirty="0"/>
           </a:p>
@@ -7801,7 +7797,7 @@
         <p:spPr>
           <a:xfrm>
             <a:off x="1005840" y="4023360"/>
-            <a:ext cx="1371600" cy="201168"/>
+            <a:ext cx="6400800" cy="201168"/>
           </a:xfrm>
           <a:prstGeom prst="rect">
             <a:avLst/>
@@ -7825,7 +7821,7 @@
                 <a:ea typeface="Calibri" pitchFamily="34" charset="-122"/>
                 <a:cs typeface="Calibri" pitchFamily="34" charset="-120"/>
               </a:rPr>
-              <a:t>F  monitor</a:t>
+              <a:t>Moves on: the clean, linked request (silver)</a:t>
             </a:r>
             <a:endParaRPr lang="en-US" sz="1000" dirty="0"/>
           </a:p>
@@ -8104,7 +8100,7 @@
         <p:spPr>
           <a:xfrm>
             <a:off x="1005840" y="4937760"/>
-            <a:ext cx="1371600" cy="201168"/>
+            <a:ext cx="6400800" cy="201168"/>
           </a:xfrm>
           <a:prstGeom prst="rect">
             <a:avLst/>
@@ -8128,7 +8124,7 @@
                 <a:ea typeface="Calibri" pitchFamily="34" charset="-122"/>
                 <a:cs typeface="Calibri" pitchFamily="34" charset="-120"/>
               </a:rPr>
-              <a:t>M  mitigate</a:t>
+              <a:t>Moves on: the request record with its history</a:t>
             </a:r>
             <a:endParaRPr lang="en-US" sz="1000" dirty="0"/>
           </a:p>
@@ -8411,7 +8407,7 @@
                 <a:ea typeface="Calibri" pitchFamily="34" charset="-122"/>
                 <a:cs typeface="Calibri" pitchFamily="34" charset="-120"/>
               </a:rPr>
-              <a:t>Reaches the sinks (S, alarm)</a:t>
+              <a:t>Reaches the sinks</a:t>
             </a:r>
             <a:endParaRPr lang="en-US" sz="1200" dirty="0"/>
           </a:p>
@@ -8706,7 +8702,7 @@
                 <a:ea typeface="Calibri" pitchFamily="34" charset="-122"/>
                 <a:cs typeface="Calibri" pitchFamily="34" charset="-120"/>
               </a:rPr>
-              <a:t>If V fails: </a:t>
+              <a:t>If validation fails: </a:t>
             </a:r>
             <a:pPr indent="0" marL="0">
               <a:buNone/>
@@ -8795,8 +8791,8 @@
         </p:nvSpPr>
         <p:spPr>
           <a:xfrm>
-            <a:off x="548640" y="5925312"/>
-            <a:ext cx="11064240" cy="411480"/>
+            <a:off x="548640" y="5897880"/>
+            <a:ext cx="11064240" cy="457200"/>
           </a:xfrm>
           <a:prstGeom prst="rect">
             <a:avLst/>
@@ -8812,7 +8808,7 @@
               <a:buNone/>
             </a:pPr>
             <a:r>
-              <a:rPr lang="en-US" sz="1100" b="1" dirty="0">
+              <a:rPr lang="en-US" sz="1050" b="1" dirty="0">
                 <a:solidFill>
                   <a:srgbClr val="3D5252"/>
                 </a:solidFill>
@@ -8820,13 +8816,13 @@
                 <a:ea typeface="Calibri" pitchFamily="34" charset="-122"/>
                 <a:cs typeface="Calibri" pitchFamily="34" charset="-120"/>
               </a:rPr>
-              <a:t>Constraints: </a:t>
+              <a:t>Governance: </a:t>
             </a:r>
             <a:pPr indent="0" marL="0">
               <a:buNone/>
             </a:pPr>
             <a:r>
-              <a:rPr lang="en-US" sz="1100" dirty="0">
+              <a:rPr lang="en-US" sz="1050" dirty="0">
                 <a:solidFill>
                   <a:srgbClr val="3D5252"/>
                 </a:solidFill>
@@ -8834,9 +8830,37 @@
                 <a:ea typeface="Calibri" pitchFamily="34" charset="-122"/>
                 <a:cs typeface="Calibri" pitchFamily="34" charset="-120"/>
               </a:rPr>
-              <a:t>human-generated and intermittent; event-driven; files 10MB, replies 5MB; role-based access, a CMAC sees only their own requests; retention to confirm; no migration or direct SnapTracker or OneGX/SAP link.</a:t>
-            </a:r>
-            <a:endParaRPr lang="en-US" sz="1100" dirty="0"/>
+              <a:t>authenticate, validate, monitor, mitigate and alarm are considered at every hand-off, not one per arrow (Miro Part G). </a:t>
+            </a:r>
+            <a:pPr indent="0" marL="0">
+              <a:buNone/>
+            </a:pPr>
+            <a:r>
+              <a:rPr lang="en-US" sz="1050" b="1" dirty="0">
+                <a:solidFill>
+                  <a:srgbClr val="3D5252"/>
+                </a:solidFill>
+                <a:latin typeface="Calibri" pitchFamily="34" charset="0"/>
+                <a:ea typeface="Calibri" pitchFamily="34" charset="-122"/>
+                <a:cs typeface="Calibri" pitchFamily="34" charset="-120"/>
+              </a:rPr>
+              <a:t>Constraints: </a:t>
+            </a:r>
+            <a:pPr indent="0" marL="0">
+              <a:buNone/>
+            </a:pPr>
+            <a:r>
+              <a:rPr lang="en-US" sz="1050" dirty="0">
+                <a:solidFill>
+                  <a:srgbClr val="3D5252"/>
+                </a:solidFill>
+                <a:latin typeface="Calibri" pitchFamily="34" charset="0"/>
+                <a:ea typeface="Calibri" pitchFamily="34" charset="-122"/>
+                <a:cs typeface="Calibri" pitchFamily="34" charset="-120"/>
+              </a:rPr>
+              <a:t>intermittent, event-driven; files 10MB, replies 5MB; role-based access (Proposed: a CMAC sees only their own requests); retention to confirm; no migration or direct integrations.</a:t>
+            </a:r>
+            <a:endParaRPr lang="en-US" sz="1050" dirty="0"/>
           </a:p>
         </p:txBody>
       </p:sp>
@@ -10075,7 +10099,7 @@
                 <a:ea typeface="Calibri" pitchFamily="34" charset="-122"/>
                 <a:cs typeface="Calibri" pitchFamily="34" charset="-120"/>
               </a:rPr>
-              <a:t>Role-based: CMAC own requests; coordinators their queue; management aggregates; external requester a read-only status link</a:t>
+              <a:t>Role-based, exact permissions to confirm. Proposed: CMAC own requests; coordinators their queue; management aggregates; external read-only status link</a:t>
             </a:r>
             <a:endParaRPr lang="en-US" sz="1200" dirty="0"/>
           </a:p>

</xml_diff>

<commit_message>
Align Data Pipeline deck and Ade deliverables with the consolidated Working 2 Miro frame
Miro part references now point to the single frame (Parts A to E); lineage
paths drop the old governance letters.

Co-Authored-By: Claude Opus 5.5 <noreply@anthropic.com>
Claude-Session: https://claude.ai/code/session_01XD5hCTym2561nrmEJXnbUU
</commit_message>
<xml_diff>
--- a/MDPM 830/Data Pipeline/TeamDART_MDPM830_Data_Pipeline.pptx
+++ b/MDPM 830/Data Pipeline/TeamDART_MDPM830_Data_Pipeline.pptx
@@ -116,44 +116,44 @@
   <p:extLst>
     <p:ext uri="{521415D9-36F7-43E2-AB2F-B90AF26B5E84}">
       <p14:sectionLst xmlns:p14="http://schemas.microsoft.com/office/powerpoint/2010/main">
-        <p14:section name="Opening" id="{c79a6ebc-0c30-2080-a400-50a9905c6150}">
+        <p14:section name="Opening" id="{255795e1-1bc4-f31c-8c95-18f97cef87b3}">
           <p14:sldIdLst>
             <p14:sldId id="256"/>
           </p14:sldIdLst>
         </p14:section>
-        <p14:section name="Product and data" id="{c7ed320a-659a-fd47-81bc-edec1efe4949}">
+        <p14:section name="Product and data" id="{fb370001-ca99-0f4f-f63c-1d4356fca6e1}">
           <p14:sldIdLst>
             <p14:sldId id="257"/>
           </p14:sldIdLst>
         </p14:section>
-        <p14:section name="Step One: Sources and scope" id="{355bf523-fb52-81f8-6b39-f4c72b38f127}">
+        <p14:section name="Step One: Sources and scope" id="{9a799f20-b8e3-722d-1c28-76324bdb5be7}">
           <p14:sldIdLst>
             <p14:sldId id="258"/>
             <p14:sldId id="259"/>
           </p14:sldIdLst>
         </p14:section>
-        <p14:section name="Step Two: The pipeline" id="{36c7a429-0597-3595-dd1b-2955b864ca16}">
+        <p14:section name="Step Two: The pipeline" id="{0762a9d2-1c82-e33b-60e4-04f2fc4477f6}">
           <p14:sldIdLst>
             <p14:sldId id="260"/>
             <p14:sldId id="261"/>
           </p14:sldIdLst>
         </p14:section>
-        <p14:section name="Step Three: Sinks" id="{048bb3dc-104a-41b9-e539-9b5dcc3fbf0d}">
+        <p14:section name="Step Three: Sinks" id="{10f97f42-a09b-a63f-1337-1fe74794088b}">
           <p14:sldIdLst>
             <p14:sldId id="262"/>
           </p14:sldIdLst>
         </p14:section>
-        <p14:section name="Step Four: Generated data" id="{2d663762-32eb-5fdf-e1e4-2e2d33bff8c8}">
+        <p14:section name="Step Four: Generated data" id="{ce1fb0c5-d584-f60c-cd64-cde1aba8f61e}">
           <p14:sldIdLst>
             <p14:sldId id="263"/>
           </p14:sldIdLst>
         </p14:section>
-        <p14:section name="Step Five: Gaps and leaks" id="{3720fc3d-cc33-9bdb-feb0-5623a02c7831}">
+        <p14:section name="Step Five: Gaps and leaks" id="{a5398106-87a9-23d9-3841-cc1a7ed3b246}">
           <p14:sldIdLst>
             <p14:sldId id="264"/>
           </p14:sldIdLst>
         </p14:section>
-        <p14:section name="Implications" id="{ecfc607b-984b-5bb4-d3b1-ce90135ff455}">
+        <p14:section name="Implications" id="{87c84ed8-4932-41a1-c2be-1ddbd214d3d8}">
           <p14:sldIdLst>
             <p14:sldId id="265"/>
           </p14:sldIdLst>
@@ -1031,7 +1031,7 @@
               <a:t>This image is the pipeline model built in Miro with the Session Four conceptual template: the scope boundary on top, the five stages (Generate, Collect, Keep and Shape, Store, Use), each showing who enters the data and who is accountable for its accuracy, three kinds of sink on the right, and the loop underneath. The board link is on this slide and opens with view access.
 On the board, read these frames together: "Working 2: Pipeline Stages and Data Ownership" (this picture plus the full stage table), "Data Pipeline: Sinks, Generated Data, Gaps and Leaks" (Steps Three to Five), and "Scope, Data Sources and Origin" (Step One).
 The labels on the arrows show what data moves: the need (item, quantity, location, reason) into Collect; the submitted request and attachments (bronze) into Keep and Shape; the clean, linked request (silver) into Store; the request record with its history into Use; and status, events and aggregates (gold) into the sinks.
-Governance: nodes do the work and connectors carry the controls (Session Four, adapted from Raj et al. 2020, Fig. 6). Session Four asks all five questions at every hand-off, so authentication, validation, monitoring, mitigation and alarms are considerations across each connection, not one control per arrow. The Miro board (Part G) has a grid of how each applies at each hand-off. For example, at the hand-off into Collect: authenticate, only an authorized requester may submit (FR-25); validate, required fields and attachments are checked (FR-03, FR-07); monitor, needs kept in email or Teams stay invisible (gap G1); mitigate, drafts are saved (FR-05); alarm, submission is confirmed to the requester (FR-09). Items not in our requirements are Proposed until the client confirms.
+Governance: nodes do the work and connectors carry the controls (Session Four, adapted from Raj et al. 2020, Fig. 6). Session Four asks all five questions at every hand-off, so authentication, validation, monitoring, mitigation and alarms are considerations across each connection, not one control per arrow. The Miro board (Part B) has a grid of how each applies at each hand-off. For example, at the hand-off into Collect: authenticate, only an authorized requester may submit (FR-25); validate, required fields and attachments are checked (FR-03, FR-07); monitor, needs kept in email or Teams stay invisible (gap G1); mitigate, drafts are saved (FR-05); alarm, submission is confirmed to the requester (FR-09). Items not in our requirements are Proposed until the client confirms.
 Bronze, silver, gold: the audit trail is bronze (the request as submitted), the product reads silver (one clean, consistent record), and management reports read gold (aggregated).</a:t>
             </a:r>
             <a:endParaRPr lang="en-US" dirty="0"/>
@@ -1133,7 +1133,7 @@
 5. The product reads it, and the alarm consideration means the requester is notified the requester when Action Required is unanswered.
 Sinks reached: the product sink (CMAC view, coordinator queue); the measurement sink (submission time, returns for information and stage times give right first time and time in stage); the business-value sinks (aggregates by location, status and period for Infrastructure reports; recycled preference for the recycle program; item, location and fulfilment date for asset and warranty history).
 Trace 2 is on the Miro board: a coordinator update must be entered on the request, not only sent by email or Teams, or it never reaches the record (gap G1). The board also has an element-by-element lineage table: born, entered by, accountable for accuracy, path, and sinks reached.
-Governance: these are the main considerations at each hop, but all five (authentication, validation, monitoring, mitigation, alarm) are asked at every hand-off; the Miro board, Part G, shows the full grid.
+Governance: these are the main considerations at each hop, but all five (authentication, validation, monitoring, mitigation, alarm) are asked at every hand-off; the Miro board, Part B, shows the full grid.
 Constraints: human-generated and intermittent; event-driven; files 10MB, replies 5MB; role-based access, with "a CMAC sees only their own requests" Proposed until exact permissions are confirmed with the client; retention per the Government of Alberta records schedule, to confirm; no historical migration; no direct SnapTracker or OneGX/SAP link assumed.</a:t>
             </a:r>
             <a:endParaRPr lang="en-US" dirty="0"/>
@@ -8830,7 +8830,7 @@
                 <a:ea typeface="Calibri" pitchFamily="34" charset="-122"/>
                 <a:cs typeface="Calibri" pitchFamily="34" charset="-120"/>
               </a:rPr>
-              <a:t>authenticate, validate, monitor, mitigate and alarm are considered at every hand-off, not one per arrow (Miro Part G). </a:t>
+              <a:t>authenticate, validate, monitor, mitigate and alarm are considered at every hand-off, not one per arrow (Miro Part B). </a:t>
             </a:r>
             <a:pPr indent="0" marL="0">
               <a:buNone/>

</xml_diff>